<commit_message>
Fix revenue assumptions and add break-even conditions and stop lines
- Setup support margin now matches its labor cost (800万×2/12≒133万, about 1/3)
- Sales team grows to 3 from year 4; CAC 約88万, LTV 約1,850万
- Break-even reframed as 3 sites per staff at year end (2.7 on paper, new sites pay half the first year)
- New slide on shortfall scenarios and go/fix/stop gates in all three decks
- Stress test adds the full-cloud AI cost case; funding dependency stated
- Script, Q&A and framework notes updated to the new numbers

Co-Authored-By: Claude Opus 5.5 <noreply@anthropic.com>
Claude-Session: https://claude.ai/code/session_01Lvjvqoc8h4yHt4F4M6n1V9
</commit_message>
<xml_diff>
--- a/deck/カンツギ_事業計画書_理論武装版.pptx
+++ b/deck/カンツギ_事業計画書_理論武装版.pptx
@@ -22,9 +22,10 @@
     <p:sldId id="270" r:id="rId16"/>
     <p:sldId id="271" r:id="rId17"/>
     <p:sldId id="272" r:id="rId18"/>
+    <p:sldId id="273" r:id="rId19"/>
   </p:sldIdLst>
   <p:notesMasterIdLst>
-    <p:notesMasterId r:id="rId19"/>
+    <p:notesMasterId r:id="rId20"/>
   </p:notesMasterIdLst>
   <p:sldSz cx="9144000" cy="5143500"/>
   <p:notesSz cx="5143500" cy="9144000"/>
@@ -609,8 +610,8 @@
             <a:r>
               <a:rPr lang="en-US" dirty="0"/>
               <a:t>【根拠8】
-要約：LTVは控えめに7年。3年で解約されても13倍
-LTVは年255万円の粗利を7年分と、導入支援の粗利80万円で約1,865万円。計画上の解約率は年5%台なので平均は約18年続く計算ですが、控えめに7年にしています。仮に3年で全部解約されても、LTVは845万円で、CACの約13倍です。</a:t>
+要約：LTVは控えめに7年。3年で解約されても9倍
+LTVは年255万円の粗利を7年分と、導入支援の粗利67万円で約1,850万円。CACは5年目の営業3人の人件費2,400万円と広告500万円を新規33拠点で割って約88万円です。計画上の解約率は年5%台なので平均は約18年続く計算ですが、控えめに7年にしています。仮に3年で全部解約されても、LTVは832万円で、CACの約9倍です。</a:t>
             </a:r>
             <a:endParaRPr lang="en-US" dirty="0"/>
           </a:p>
@@ -700,7 +701,7 @@
               <a:rPr lang="en-US" dirty="0"/>
               <a:t>【根拠9】
 要約：崩れても死なない。条件は採用を拠点数に連動させること
-計画が崩れた場合のストレステストです。単価が2割下がっても、解約が倍になっても、4年目の黒字は変わりません。獲得が3割遅れたり、1年遅れたりすると黒字化は5年目にずれますが、採用を拠点数に合わせて遅らせれば、現金は最低ラインを割りません。一番危ないのは、獲得が遅れているのに計画どおり採用することで、この場合は現金が尽きます。だから、社員1人2.8拠点を採用のルールにしています。</a:t>
+計画が崩れた場合のストレステストです。解約が倍になっても、人件費が上がっても、4年目の黒字は変わりません。単価が2割下がる、動画を全部クラウドで処理してAIの費用が膨らむ、1年遅れる、の3つは黒字化が5年目にずれますが、現金は最低ラインを割りません。獲得が3割遅れても、採用を拠点数に合わせて遅らせれば4年目に黒字です。一番危ないのは、獲得が遅れているのに計画どおり採用することで、この場合は現金が尽きます。だから、期末で社員1人3拠点を採用のルールにしています。</a:t>
             </a:r>
             <a:endParaRPr lang="en-US" dirty="0"/>
           </a:p>
@@ -788,9 +789,9 @@
           <a:p>
             <a:r>
               <a:rPr lang="en-US" dirty="0"/>
-              <a:t>【根拠10】
-要約：必要資金1.5億円は積み上げで出した
-必要資金1.5億円は、累積赤字のピーク6,500万円、運転資金2,900万円、1年遅れた場合の備え5,600万円の積み上げです。現金残高は最も薄い3年目でも約6,000万円残ります。</a:t>
+              <a:t>【根拠9-2】
+要約：計画の6割で黒字。届かなければ、先に決めた線で止まる
+黒字化の条件です。新しい拠点が計画の何割取れたら持つかを、同じ計算で確かめました。採用を実績に合わせて遅らせれば、計画の7割で4年目、6割で5年目に黒字です。5割を下回ると黒字になりません。だから進むか止まるかの線を先に決めています。1年目の終わりに実証3社のうち2社以上が本契約なら進む、1社なら値段と顧客を見直す、0社なら撤退か方向転換。2年目に新しい拠点が5つに届かなければ採用を止めます。なお、この計画は出資1億1,500万円が前提で、公庫の1,000万円だけでは1年目から現金が足りません。</a:t>
             </a:r>
             <a:endParaRPr lang="en-US" dirty="0"/>
           </a:p>
@@ -878,9 +879,9 @@
           <a:p>
             <a:r>
               <a:rPr lang="en-US" dirty="0"/>
-              <a:t>【根拠11】
-要約：ターゲット市場は業種×規模で数えて約141億円
-市場規模の計算です。業種と規模の2つの軸で分けて、顧客数かける年額を足しました。電気工事と電気通信工事の中堅以上、約3,100社で約141億円です。大手は支店5拠点分で数えています。土台の65,497社は国の統計ですが、規模別の内訳は仮定なので、聞かれたら推計だと正直に言います。電線や素材の工場は、成長期以降の隣接市場として外しています。</a:t>
+              <a:t>【根拠10】
+要約：必要資金1.5億円は積み上げで出した
+必要資金1.5億円は、累積赤字のピーク6,500万円、運転資金2,900万円、1年遅れた場合の備え5,600万円の積み上げです。現金残高は最も薄い3年目でも約6,000万円残ります。</a:t>
             </a:r>
             <a:endParaRPr lang="en-US" dirty="0"/>
           </a:p>
@@ -968,9 +969,9 @@
           <a:p>
             <a:r>
               <a:rPr lang="en-US" dirty="0"/>
-              <a:t>【根拠12】
-要約：最初の顧客は4つの物差しで選び、5年の獲得数は顧客側から積んだ
-なぜ中堅の電気工事会社からなのか。大きさ、困りごと、会いやすさ、波及効果の4つで採点し、17点で最も高くなりました。5年の獲得数は、関東の735社に、会える率45%、成約率25%をかけて83社、大手1社の5拠点を足して約88拠点。導入能力から出した計画の85拠点は、これより控えめです。</a:t>
+              <a:t>【根拠11】
+要約：ターゲット市場は業種×規模で数えて約141億円
+市場規模の計算です。業種と規模の2つの軸で分けて、顧客数かける年額を足しました。電気工事と電気通信工事の中堅以上、約3,100社で約141億円です。大手は支店5拠点分で数えています。土台の65,497社は国の統計ですが、規模別の内訳は仮定なので、聞かれたら推計だと正直に言います。電線や素材の工場は、成長期以降の隣接市場として外しています。</a:t>
             </a:r>
             <a:endParaRPr lang="en-US" dirty="0"/>
           </a:p>
@@ -1058,9 +1059,9 @@
           <a:p>
             <a:r>
               <a:rPr lang="en-US" dirty="0"/>
-              <a:t>【根拠13】
-要約：グラスは作らず選ぶ。手元ARの効果は3つの数字で実測する
-端末と実証の設計です。グラス本体は開発しません。落下・防じん防水・電池・ヘルメット・手袋での操作という現場の条件で市販の端末を選び、乗り換えられる設計にします。手元ARの効果は、よく使うジョイント1種類で、手戻りの件数、1ジョイントの作業時間、新人が独り立ちするまでの期間の3つで測ります。</a:t>
+              <a:t>【根拠12】
+要約：最初の顧客は4つの物差しで選び、5年の獲得数は顧客側から積んだ
+なぜ中堅の電気工事会社からなのか。大きさ、困りごと、会いやすさ、波及効果の4つで採点し、17点で最も高くなりました。5年の獲得数は、関東の735社に、会える率45%、成約率25%をかけて83社、大手1社の5拠点を足して約88拠点。導入能力から出した計画の85拠点は、これより控えめです。</a:t>
             </a:r>
             <a:endParaRPr lang="en-US" dirty="0"/>
           </a:p>
@@ -1148,9 +1149,9 @@
           <a:p>
             <a:r>
               <a:rPr lang="en-US" dirty="0"/>
-              <a:t>【根拠14】
-要約：厳しい質問には、数字→式→前提の順で答える
-厳しい質問への回答集です。それぞれ、一言の答えと、根拠のページを書いています。</a:t>
+              <a:t>【根拠13】
+要約：グラスは作らず選ぶ。手元ARの効果は3つの数字で実測する
+端末と実証の設計です。グラス本体は開発しません。落下・防じん防水・電池・ヘルメット・手袋での操作という現場の条件で市販の端末を選び、乗り換えられる設計にします。手元ARの効果は、よく使うジョイント1種類で、手戻りの件数、1ジョイントの作業時間、新人が独り立ちするまでの期間の3つで測ります。</a:t>
             </a:r>
             <a:endParaRPr lang="en-US" dirty="0"/>
           </a:p>
@@ -1238,6 +1239,96 @@
           <a:p>
             <a:r>
               <a:rPr lang="en-US" dirty="0"/>
+              <a:t>【根拠14】
+要約：厳しい質問には、数字→式→前提の順で答える
+厳しい質問への回答集です。それぞれ、一言の答えと、根拠のページを書いています。</a:t>
+            </a:r>
+            <a:endParaRPr lang="en-US" dirty="0"/>
+          </a:p>
+        </p:txBody>
+      </p:sp>
+      <p:sp>
+        <p:nvSpPr>
+          <p:cNvPr id="4" name="Slide Number Placeholder 3"/>
+          <p:cNvSpPr>
+            <a:spLocks noGrp="1"/>
+          </p:cNvSpPr>
+          <p:nvPr>
+            <p:ph type="sldNum" sz="quarter" idx="10"/>
+          </p:nvPr>
+        </p:nvSpPr>
+        <p:spPr/>
+        <p:txBody>
+          <a:bodyPr/>
+          <a:lstStyle/>
+          <a:p>
+            <a:fld id="{F7021451-1387-4CA6-816F-3879F97B5CBC}" type="slidenum">
+              <a:rPr lang="en-US"/>
+              <a:t>17</a:t>
+            </a:fld>
+            <a:endParaRPr lang="en-US"/>
+          </a:p>
+        </p:txBody>
+      </p:sp>
+    </p:spTree>
+    <p:extLst>
+      <p:ext uri="{BB962C8B-B14F-4D97-AF65-F5344CB8AC3E}">
+        <p14:creationId xmlns:p14="http://schemas.microsoft.com/office/powerpoint/2010/main" val="1024086991"/>
+      </p:ext>
+    </p:extLst>
+  </p:cSld>
+  <p:clrMapOvr>
+    <a:masterClrMapping/>
+  </p:clrMapOvr>
+</p:notes>
+</file>
+
+<file path=ppt/notesSlides/notesSlide18.xml><?xml version="1.0" encoding="utf-8"?>
+<p:notes xmlns:a="http://schemas.openxmlformats.org/drawingml/2006/main" xmlns:r="http://schemas.openxmlformats.org/officeDocument/2006/relationships" xmlns:p="http://schemas.openxmlformats.org/presentationml/2006/main">
+  <p:cSld>
+    <p:spTree>
+      <p:nvGrpSpPr>
+        <p:cNvPr id="1" name=""/>
+        <p:cNvGrpSpPr/>
+        <p:nvPr/>
+      </p:nvGrpSpPr>
+      <p:grpSpPr>
+        <a:xfrm>
+          <a:off x="0" y="0"/>
+          <a:ext cx="0" cy="0"/>
+          <a:chOff x="0" y="0"/>
+          <a:chExt cx="0" cy="0"/>
+        </a:xfrm>
+      </p:grpSpPr>
+      <p:sp>
+        <p:nvSpPr>
+          <p:cNvPr id="2" name="Slide Image Placeholder 1"/>
+          <p:cNvSpPr>
+            <a:spLocks noGrp="1" noRot="1" noChangeAspect="1"/>
+          </p:cNvSpPr>
+          <p:nvPr>
+            <p:ph type="sldImg"/>
+          </p:nvPr>
+        </p:nvSpPr>
+        <p:spPr/>
+      </p:sp>
+      <p:sp>
+        <p:nvSpPr>
+          <p:cNvPr id="3" name="Notes Placeholder 2"/>
+          <p:cNvSpPr>
+            <a:spLocks noGrp="1"/>
+          </p:cNvSpPr>
+          <p:nvPr>
+            <p:ph type="body" idx="1"/>
+          </p:nvPr>
+        </p:nvSpPr>
+        <p:spPr/>
+        <p:txBody>
+          <a:bodyPr/>
+          <a:lstStyle/>
+          <a:p>
+            <a:r>
+              <a:rPr lang="en-US" dirty="0"/>
               <a:t>【出典】
 要約：公的統計と原典を明記する。未確認のものは未確認と言う
 出典一覧です。確認が必要なものには印を付けています。発表前に原典を確認してください。</a:t>
@@ -1263,7 +1354,7 @@
           <a:p>
             <a:fld id="{F7021451-1387-4CA6-816F-3879F97B5CBC}" type="slidenum">
               <a:rPr lang="en-US"/>
-              <a:t>17</a:t>
+              <a:t>18</a:t>
             </a:fld>
             <a:endParaRPr lang="en-US"/>
           </a:p>
@@ -1330,7 +1421,7 @@
               <a:rPr lang="en-US" dirty="0"/>
               <a:t>【根拠1】
 要約：営業利益は5つの数字の掛け算と足し算に分解できる
-5年目の営業利益6,900万円を分解した木です。上から、売上総利益から販管費を引く。売上総利益は、利用料の85%とサービスの40%。利用料は、前の年までの55拠点に300万円と、新しい33拠点の半年分。販管費は、社員20人に800万円から、導入支援に回った人件費を原価に振り替え、家賃などを足す。どの枝を聞かれても、この木のどこかを指せば答えられます。</a:t>
+5年目の営業利益約6,100万円を分解した木です。上から、売上総利益から販管費を引く。売上総利益は、利用料の85%とサービスの3分の1。利用料は、前の年までの55拠点に300万円と、新しい33拠点の半年分。販管費は、社員21人に800万円から、導入支援に回った人件費を原価に振り替え、家賃などを足す。どの枝を聞かれても、この木のどこかを指せば答えられます。</a:t>
             </a:r>
             <a:endParaRPr lang="en-US" dirty="0"/>
           </a:p>
@@ -1870,7 +1961,7 @@
               <a:rPr lang="en-US" dirty="0"/>
               <a:t>【根拠6】
 要約：導入支援の人件費は原価に振り替える
-原価と販管費です。利用料の原価はサーバーとAIの費用で15%。導入支援と受託の原価は担当者の人件費で60%。その分を販管費の人件費から引いて、二重に数えないようにしています。</a:t>
+原価と販管費です。利用料の原価はサーバーとAIの費用で15%。導入支援と受託の原価は担当者の人件費で3分の2。導入支援200万円なら、担当者1人の2か月分、800万円×2÷12＝約133万円です。その分を販管費の人件費から引いて、二重に数えないようにしています。</a:t>
             </a:r>
             <a:endParaRPr lang="en-US" dirty="0"/>
           </a:p>
@@ -1960,7 +2051,7 @@
               <a:rPr lang="en-US" dirty="0"/>
               <a:t>【根拠7】
 要約：損益分岐点は売上で見ても、人で見ても4年目
-損益分岐点は二通りで見ています。一つは販管費を粗利率で割る売上ベース。もう一つは社員1人あたりの拠点数で、713万円を255万円で割って2.8拠点。どちらで見ても4年目に超えます。</a:t>
+損益分岐点は二通りで見ています。一つは販管費を粗利率で割る売上ベース。もう一つは社員1人あたりの拠点数で、4年目の販管費694万円を255万円で割って2.7拠点。ただ新しい拠点は初年度に半年分しか払わないので、期末の拠点数では1人3拠点が目安です。3年目は2.73で届かず、4年目は3.44で超えます。</a:t>
             </a:r>
             <a:endParaRPr lang="en-US" dirty="0"/>
           </a:p>
@@ -3227,7 +3318,7 @@
                 <a:ea typeface="Meiryo" pitchFamily="34" charset="-122"/>
                 <a:cs typeface="Meiryo" pitchFamily="34" charset="-120"/>
               </a:rPr>
-              <a:t>ストレステストと資金計画</a:t>
+              <a:t>ストレステスト・撤退ライン・資金計画</a:t>
             </a:r>
             <a:endParaRPr lang="en-US" sz="1050" dirty="0"/>
           </a:p>
@@ -3460,7 +3551,7 @@
                 <a:ea typeface="Meiryo" pitchFamily="34" charset="-122"/>
                 <a:cs typeface="Meiryo" pitchFamily="34" charset="-120"/>
               </a:rPr>
-              <a:t>LTV・CAC ─ 控えめに7年。3年で解約されても13倍</a:t>
+              <a:t>LTV・CAC ─ 控えめに7年。3年で解約されても9倍</a:t>
             </a:r>
             <a:endParaRPr lang="en-US" sz="2000" dirty="0"/>
           </a:p>
@@ -3590,7 +3681,7 @@
                 <a:ea typeface="Meiryo" pitchFamily="34" charset="-122"/>
                 <a:cs typeface="Meiryo" pitchFamily="34" charset="-120"/>
               </a:rPr>
-              <a:t>255万円 × 7年 ＋ 80万円 ＝ </a:t>
+              <a:t>255万円 × 7年 ＋ 67万円 ＝ </a:t>
             </a:r>
             <a:pPr algn="l" indent="0" marL="0">
               <a:lnSpc>
@@ -3610,7 +3701,7 @@
                 <a:ea typeface="Meiryo" pitchFamily="34" charset="-122"/>
                 <a:cs typeface="Meiryo" pitchFamily="34" charset="-120"/>
               </a:rPr>
-              <a:t>約1,865万円</a:t>
+              <a:t>約1,852万円</a:t>
             </a:r>
             <a:endParaRPr lang="en-US" sz="1050" dirty="0"/>
           </a:p>
@@ -3633,7 +3724,7 @@
                 <a:ea typeface="Meiryo" pitchFamily="34" charset="-122"/>
                 <a:cs typeface="Meiryo" pitchFamily="34" charset="-120"/>
               </a:rPr>
-              <a:t>255万円＝300万円×85%　80万円＝200万円×40%</a:t>
+              <a:t>255万円＝300万円×85%　67万円＝200万円×1/3</a:t>
             </a:r>
             <a:endParaRPr lang="en-US" sz="1050" dirty="0"/>
           </a:p>
@@ -3721,7 +3812,7 @@
                 <a:ea typeface="Meiryo" pitchFamily="34" charset="-122"/>
                 <a:cs typeface="Meiryo" pitchFamily="34" charset="-120"/>
               </a:rPr>
-              <a:t>（1,600万円＋500万円）÷ 33拠点 ＝ </a:t>
+              <a:t>（2,400万円＋500万円）÷ 33拠点 ＝ </a:t>
             </a:r>
             <a:pPr algn="l" indent="0" marL="0">
               <a:lnSpc>
@@ -3741,7 +3832,7 @@
                 <a:ea typeface="Meiryo" pitchFamily="34" charset="-122"/>
                 <a:cs typeface="Meiryo" pitchFamily="34" charset="-120"/>
               </a:rPr>
-              <a:t>約64万円</a:t>
+              <a:t>約88万円</a:t>
             </a:r>
             <a:endParaRPr lang="en-US" sz="1050" dirty="0"/>
           </a:p>
@@ -3764,7 +3855,7 @@
                 <a:ea typeface="Meiryo" pitchFamily="34" charset="-122"/>
                 <a:cs typeface="Meiryo" pitchFamily="34" charset="-120"/>
               </a:rPr>
-              <a:t>5年目：営業2人の人件費＋広告・展示会 ÷ 新規拠点</a:t>
+              <a:t>5年目：営業3人の人件費＋広告・展示会 ÷ 新規拠点</a:t>
             </a:r>
             <a:endParaRPr lang="en-US" sz="1050" dirty="0"/>
           </a:p>
@@ -4059,7 +4150,7 @@
                           <a:ea typeface="Meiryo" pitchFamily="34" charset="-122"/>
                           <a:cs typeface="Meiryo" pitchFamily="34" charset="-120"/>
                         </a:rPr>
-                        <a:t>845万円</a:t>
+                        <a:t>832万円</a:t>
                       </a:r>
                       <a:endParaRPr lang="en-US" sz="950" dirty="0">
                         <a:latin typeface="Meiryo" charset="0"/>
@@ -4109,7 +4200,7 @@
                           <a:ea typeface="Meiryo" pitchFamily="34" charset="-122"/>
                           <a:cs typeface="Meiryo" pitchFamily="34" charset="-120"/>
                         </a:rPr>
-                        <a:t>13倍</a:t>
+                        <a:t>9倍</a:t>
                       </a:r>
                       <a:endParaRPr lang="en-US" sz="950" dirty="0">
                         <a:latin typeface="Meiryo" charset="0"/>
@@ -4211,7 +4302,7 @@
                           <a:ea typeface="Meiryo" pitchFamily="34" charset="-122"/>
                           <a:cs typeface="Meiryo" pitchFamily="34" charset="-120"/>
                         </a:rPr>
-                        <a:t>1,355万円</a:t>
+                        <a:t>1,342万円</a:t>
                       </a:r>
                       <a:endParaRPr lang="en-US" sz="950" dirty="0">
                         <a:latin typeface="Meiryo" charset="0"/>
@@ -4261,7 +4352,7 @@
                           <a:ea typeface="Meiryo" pitchFamily="34" charset="-122"/>
                           <a:cs typeface="Meiryo" pitchFamily="34" charset="-120"/>
                         </a:rPr>
-                        <a:t>21倍</a:t>
+                        <a:t>15倍</a:t>
                       </a:r>
                       <a:endParaRPr lang="en-US" sz="950" dirty="0">
                         <a:latin typeface="Meiryo" charset="0"/>
@@ -4363,7 +4454,7 @@
                           <a:ea typeface="Meiryo" pitchFamily="34" charset="-122"/>
                           <a:cs typeface="Meiryo" pitchFamily="34" charset="-120"/>
                         </a:rPr>
-                        <a:t>1,865万円</a:t>
+                        <a:t>1,852万円</a:t>
                       </a:r>
                       <a:endParaRPr lang="en-US" sz="950" dirty="0">
                         <a:latin typeface="Meiryo" charset="0"/>
@@ -4413,7 +4504,7 @@
                           <a:ea typeface="Meiryo" pitchFamily="34" charset="-122"/>
                           <a:cs typeface="Meiryo" pitchFamily="34" charset="-120"/>
                         </a:rPr>
-                        <a:t>29倍</a:t>
+                        <a:t>21倍</a:t>
                       </a:r>
                       <a:endParaRPr lang="en-US" sz="950" dirty="0">
                         <a:latin typeface="Meiryo" charset="0"/>
@@ -4515,7 +4606,7 @@
                           <a:ea typeface="Meiryo" pitchFamily="34" charset="-122"/>
                           <a:cs typeface="Meiryo" pitchFamily="34" charset="-120"/>
                         </a:rPr>
-                        <a:t>2,630万円</a:t>
+                        <a:t>2,617万円</a:t>
                       </a:r>
                       <a:endParaRPr lang="en-US" sz="950" dirty="0">
                         <a:latin typeface="Meiryo" charset="0"/>
@@ -4565,7 +4656,7 @@
                           <a:ea typeface="Meiryo" pitchFamily="34" charset="-122"/>
                           <a:cs typeface="Meiryo" pitchFamily="34" charset="-120"/>
                         </a:rPr>
-                        <a:t>41倍</a:t>
+                        <a:t>30倍</a:t>
                       </a:r>
                       <a:endParaRPr lang="en-US" sz="950" dirty="0">
                         <a:latin typeface="Meiryo" charset="0"/>
@@ -4842,7 +4933,7 @@
                           <a:ea typeface="Meiryo" pitchFamily="34" charset="-122"/>
                           <a:cs typeface="Meiryo" pitchFamily="34" charset="-120"/>
                         </a:rPr>
-                        <a:t>64万円（計画）</a:t>
+                        <a:t>88万円（計画）</a:t>
                       </a:r>
                       <a:endParaRPr lang="en-US" sz="950" dirty="0">
                         <a:latin typeface="Meiryo" charset="0"/>
@@ -4892,7 +4983,7 @@
                           <a:ea typeface="Meiryo" pitchFamily="34" charset="-122"/>
                           <a:cs typeface="Meiryo" pitchFamily="34" charset="-120"/>
                         </a:rPr>
-                        <a:t>29倍</a:t>
+                        <a:t>21倍</a:t>
                       </a:r>
                       <a:endParaRPr lang="en-US" sz="950" dirty="0">
                         <a:latin typeface="Meiryo" charset="0"/>
@@ -4942,7 +5033,7 @@
                           <a:ea typeface="Meiryo" pitchFamily="34" charset="-122"/>
                           <a:cs typeface="Meiryo" pitchFamily="34" charset="-120"/>
                         </a:rPr>
-                        <a:t>3か月</a:t>
+                        <a:t>4か月</a:t>
                       </a:r>
                       <a:endParaRPr lang="en-US" sz="950" dirty="0">
                         <a:latin typeface="Meiryo" charset="0"/>
@@ -4994,7 +5085,7 @@
                           <a:ea typeface="Meiryo" pitchFamily="34" charset="-122"/>
                           <a:cs typeface="Meiryo" pitchFamily="34" charset="-120"/>
                         </a:rPr>
-                        <a:t>127万円（2倍）</a:t>
+                        <a:t>176万円（2倍）</a:t>
                       </a:r>
                       <a:endParaRPr lang="en-US" sz="950" dirty="0">
                         <a:latin typeface="Meiryo" charset="0"/>
@@ -5044,7 +5135,7 @@
                           <a:ea typeface="Meiryo" pitchFamily="34" charset="-122"/>
                           <a:cs typeface="Meiryo" pitchFamily="34" charset="-120"/>
                         </a:rPr>
-                        <a:t>15倍</a:t>
+                        <a:t>11倍</a:t>
                       </a:r>
                       <a:endParaRPr lang="en-US" sz="950" dirty="0">
                         <a:latin typeface="Meiryo" charset="0"/>
@@ -5094,7 +5185,7 @@
                           <a:ea typeface="Meiryo" pitchFamily="34" charset="-122"/>
                           <a:cs typeface="Meiryo" pitchFamily="34" charset="-120"/>
                         </a:rPr>
-                        <a:t>6か月</a:t>
+                        <a:t>8か月</a:t>
                       </a:r>
                       <a:endParaRPr lang="en-US" sz="950" dirty="0">
                         <a:latin typeface="Meiryo" charset="0"/>
@@ -5146,7 +5237,7 @@
                           <a:ea typeface="Meiryo" pitchFamily="34" charset="-122"/>
                           <a:cs typeface="Meiryo" pitchFamily="34" charset="-120"/>
                         </a:rPr>
-                        <a:t>255万円（4倍）</a:t>
+                        <a:t>352万円（4倍）</a:t>
                       </a:r>
                       <a:endParaRPr lang="en-US" sz="950" dirty="0">
                         <a:latin typeface="Meiryo" charset="0"/>
@@ -5196,7 +5287,7 @@
                           <a:ea typeface="Meiryo" pitchFamily="34" charset="-122"/>
                           <a:cs typeface="Meiryo" pitchFamily="34" charset="-120"/>
                         </a:rPr>
-                        <a:t>7倍</a:t>
+                        <a:t>5倍</a:t>
                       </a:r>
                       <a:endParaRPr lang="en-US" sz="950" dirty="0">
                         <a:latin typeface="Meiryo" charset="0"/>
@@ -5246,7 +5337,7 @@
                           <a:ea typeface="Meiryo" pitchFamily="34" charset="-122"/>
                           <a:cs typeface="Meiryo" pitchFamily="34" charset="-120"/>
                         </a:rPr>
-                        <a:t>12か月</a:t>
+                        <a:t>17か月</a:t>
                       </a:r>
                       <a:endParaRPr lang="en-US" sz="950" dirty="0">
                         <a:latin typeface="Meiryo" charset="0"/>
@@ -5411,7 +5502,7 @@
                 <a:ea typeface="Meiryo" pitchFamily="34" charset="-122"/>
                 <a:cs typeface="Meiryo" pitchFamily="34" charset="-120"/>
               </a:rPr>
-              <a:t>SaaSでよく使われる目安は「LTV÷CACが3倍以上、回収12か月以内」。当社は29倍・3か月</a:t>
+              <a:t>SaaSでよく使われる目安は「LTV÷CACが3倍以上、回収12か月以内」。当社は21倍・4か月</a:t>
             </a:r>
             <a:endParaRPr lang="en-US" sz="900" dirty="0"/>
           </a:p>
@@ -6100,7 +6191,7 @@
                           <a:ea typeface="Meiryo" pitchFamily="34" charset="-122"/>
                           <a:cs typeface="Meiryo" pitchFamily="34" charset="-120"/>
                         </a:rPr>
-                        <a:t>69百万円</a:t>
+                        <a:t>61百万円</a:t>
                       </a:r>
                       <a:endParaRPr lang="en-US" sz="900" dirty="0">
                         <a:latin typeface="Meiryo" charset="0"/>
@@ -6314,7 +6405,7 @@
                           <a:ea typeface="Meiryo" pitchFamily="34" charset="-122"/>
                           <a:cs typeface="Meiryo" pitchFamily="34" charset="-120"/>
                         </a:rPr>
-                        <a:t>4年目</a:t>
+                        <a:t>5年目</a:t>
                       </a:r>
                       <a:endParaRPr lang="en-US" sz="900" dirty="0">
                         <a:latin typeface="Meiryo" charset="0"/>
@@ -6364,7 +6455,7 @@
                           <a:ea typeface="Meiryo" pitchFamily="34" charset="-122"/>
                           <a:cs typeface="Meiryo" pitchFamily="34" charset="-120"/>
                         </a:rPr>
-                        <a:t>32百万円</a:t>
+                        <a:t>24百万円</a:t>
                       </a:r>
                       <a:endParaRPr lang="en-US" sz="900" dirty="0">
                         <a:latin typeface="Meiryo" charset="0"/>
@@ -6414,7 +6505,7 @@
                           <a:ea typeface="Meiryo" pitchFamily="34" charset="-122"/>
                           <a:cs typeface="Meiryo" pitchFamily="34" charset="-120"/>
                         </a:rPr>
-                        <a:t>45百万円</a:t>
+                        <a:t>43百万円</a:t>
                       </a:r>
                       <a:endParaRPr lang="en-US" sz="900" dirty="0">
                         <a:latin typeface="Meiryo" charset="0"/>
@@ -6616,7 +6707,7 @@
                           <a:ea typeface="Meiryo" pitchFamily="34" charset="-122"/>
                           <a:cs typeface="Meiryo" pitchFamily="34" charset="-120"/>
                         </a:rPr>
-                        <a:t>59百万円</a:t>
+                        <a:t>51百万円</a:t>
                       </a:r>
                       <a:endParaRPr lang="en-US" sz="900" dirty="0">
                         <a:latin typeface="Meiryo" charset="0"/>
@@ -6718,7 +6809,7 @@
                           <a:ea typeface="Meiryo" pitchFamily="34" charset="-122"/>
                           <a:cs typeface="Meiryo" pitchFamily="34" charset="-120"/>
                         </a:rPr>
-                        <a:t>ライセンス粗利率 85%→75%</a:t>
+                        <a:t>ライセンス粗利率 85%→60%</a:t>
                       </a:r>
                       <a:endParaRPr lang="en-US" sz="900" dirty="0">
                         <a:latin typeface="Meiryo" charset="0"/>
@@ -6768,7 +6859,7 @@
                           <a:ea typeface="Meiryo" pitchFamily="34" charset="-122"/>
                           <a:cs typeface="Meiryo" pitchFamily="34" charset="-120"/>
                         </a:rPr>
-                        <a:t>AIの推論費用が想定より高い</a:t>
+                        <a:t>動画を全部クラウドでAI処理した</a:t>
                       </a:r>
                       <a:endParaRPr lang="en-US" sz="900" dirty="0">
                         <a:latin typeface="Meiryo" charset="0"/>
@@ -6818,7 +6909,7 @@
                           <a:ea typeface="Meiryo" pitchFamily="34" charset="-122"/>
                           <a:cs typeface="Meiryo" pitchFamily="34" charset="-120"/>
                         </a:rPr>
-                        <a:t>4年目</a:t>
+                        <a:t>5年目</a:t>
                       </a:r>
                       <a:endParaRPr lang="en-US" sz="900" dirty="0">
                         <a:latin typeface="Meiryo" charset="0"/>
@@ -6868,7 +6959,7 @@
                           <a:ea typeface="Meiryo" pitchFamily="34" charset="-122"/>
                           <a:cs typeface="Meiryo" pitchFamily="34" charset="-120"/>
                         </a:rPr>
-                        <a:t>47百万円</a:t>
+                        <a:t>7百万円</a:t>
                       </a:r>
                       <a:endParaRPr lang="en-US" sz="900" dirty="0">
                         <a:latin typeface="Meiryo" charset="0"/>
@@ -6918,7 +7009,7 @@
                           <a:ea typeface="Meiryo" pitchFamily="34" charset="-122"/>
                           <a:cs typeface="Meiryo" pitchFamily="34" charset="-120"/>
                         </a:rPr>
-                        <a:t>51百万円</a:t>
+                        <a:t>26百万円</a:t>
                       </a:r>
                       <a:endParaRPr lang="en-US" sz="900" dirty="0">
                         <a:latin typeface="Meiryo" charset="0"/>
@@ -7120,7 +7211,7 @@
                           <a:ea typeface="Meiryo" pitchFamily="34" charset="-122"/>
                           <a:cs typeface="Meiryo" pitchFamily="34" charset="-120"/>
                         </a:rPr>
-                        <a:t>49百万円</a:t>
+                        <a:t>40百万円</a:t>
                       </a:r>
                       <a:endParaRPr lang="en-US" sz="900" dirty="0">
                         <a:latin typeface="Meiryo" charset="0"/>
@@ -7322,7 +7413,7 @@
                           <a:ea typeface="Meiryo" pitchFamily="34" charset="-122"/>
                           <a:cs typeface="Meiryo" pitchFamily="34" charset="-120"/>
                         </a:rPr>
-                        <a:t>4年目</a:t>
+                        <a:t>5年目</a:t>
                       </a:r>
                       <a:endParaRPr lang="en-US" sz="900" dirty="0">
                         <a:latin typeface="Meiryo" charset="0"/>
@@ -7372,7 +7463,7 @@
                           <a:ea typeface="Meiryo" pitchFamily="34" charset="-122"/>
                           <a:cs typeface="Meiryo" pitchFamily="34" charset="-120"/>
                         </a:rPr>
-                        <a:t>24百万円</a:t>
+                        <a:t>16百万円</a:t>
                       </a:r>
                       <a:endParaRPr lang="en-US" sz="900" dirty="0">
                         <a:latin typeface="Meiryo" charset="0"/>
@@ -7422,7 +7513,7 @@
                           <a:ea typeface="Meiryo" pitchFamily="34" charset="-122"/>
                           <a:cs typeface="Meiryo" pitchFamily="34" charset="-120"/>
                         </a:rPr>
-                        <a:t>43百万円</a:t>
+                        <a:t>37百万円</a:t>
                       </a:r>
                       <a:endParaRPr lang="en-US" sz="900" dirty="0">
                         <a:latin typeface="Meiryo" charset="0"/>
@@ -7574,7 +7665,7 @@
                           <a:ea typeface="Meiryo" pitchFamily="34" charset="-122"/>
                           <a:cs typeface="Meiryo" pitchFamily="34" charset="-120"/>
                         </a:rPr>
-                        <a:t>5年目</a:t>
+                        <a:t>4年目</a:t>
                       </a:r>
                       <a:endParaRPr lang="en-US" sz="900" dirty="0">
                         <a:latin typeface="Meiryo" charset="0"/>
@@ -7624,7 +7715,7 @@
                           <a:ea typeface="Meiryo" pitchFamily="34" charset="-122"/>
                           <a:cs typeface="Meiryo" pitchFamily="34" charset="-120"/>
                         </a:rPr>
-                        <a:t>17百万円</a:t>
+                        <a:t>22百万円</a:t>
                       </a:r>
                       <a:endParaRPr lang="en-US" sz="900" dirty="0">
                         <a:latin typeface="Meiryo" charset="0"/>
@@ -7674,7 +7765,7 @@
                           <a:ea typeface="Meiryo" pitchFamily="34" charset="-122"/>
                           <a:cs typeface="Meiryo" pitchFamily="34" charset="-120"/>
                         </a:rPr>
-                        <a:t>22百万円</a:t>
+                        <a:t>36百万円</a:t>
                       </a:r>
                       <a:endParaRPr lang="en-US" sz="900" dirty="0">
                         <a:latin typeface="Meiryo" charset="0"/>
@@ -7876,7 +7967,7 @@
                           <a:ea typeface="Meiryo" pitchFamily="34" charset="-122"/>
                           <a:cs typeface="Meiryo" pitchFamily="34" charset="-120"/>
                         </a:rPr>
-                        <a:t>34百万円</a:t>
+                        <a:t>26百万円</a:t>
                       </a:r>
                       <a:endParaRPr lang="en-US" sz="900" dirty="0">
                         <a:latin typeface="Meiryo" charset="0"/>
@@ -8128,7 +8219,7 @@
                           <a:ea typeface="Meiryo" pitchFamily="34" charset="-122"/>
                           <a:cs typeface="Meiryo" pitchFamily="34" charset="-120"/>
                         </a:rPr>
-                        <a:t>▲7百万円</a:t>
+                        <a:t>▲18百万円</a:t>
                       </a:r>
                       <a:endParaRPr lang="en-US" sz="900" dirty="0">
                         <a:latin typeface="Meiryo" charset="0"/>
@@ -8178,7 +8269,7 @@
                           <a:ea typeface="Meiryo" pitchFamily="34" charset="-122"/>
                           <a:cs typeface="Meiryo" pitchFamily="34" charset="-120"/>
                         </a:rPr>
-                        <a:t>▲10百万円</a:t>
+                        <a:t>▲38百万円</a:t>
                       </a:r>
                       <a:endParaRPr lang="en-US" sz="900" dirty="0">
                         <a:latin typeface="Meiryo" charset="0"/>
@@ -8289,7 +8380,7 @@
                 <a:ea typeface="Meiryo" pitchFamily="34" charset="-122"/>
                 <a:cs typeface="Meiryo" pitchFamily="34" charset="-120"/>
               </a:rPr>
-              <a:t>値引き・解約・コスト高では黒字化の年は変わらない。獲得の遅れは黒字化を1年ずらすが、採用を拠点数に連動させれば現金は残る。危ないのは「遅れているのに計画どおり採用する」ことだけ → 採用は「1人2.8拠点」をルールにする</a:t>
+              <a:t>解約・人件費では黒字化の年は変わらない。値引き・AI費用・1年遅れは5年目にずれるが現金は残る。獲得の遅れも採用を連動させれば残る。危ないのは「遅れているのに計画どおり採用する」ことだけ → 採用は「期末1人3拠点」をルールにする</a:t>
             </a:r>
             <a:endParaRPr lang="en-US" sz="950" dirty="0"/>
           </a:p>
@@ -8396,6 +8487,3098 @@
 <file path=ppt/slides/slide12.xml><?xml version="1.0" encoding="utf-8"?>
 <p:sld xmlns:a="http://schemas.openxmlformats.org/drawingml/2006/main" xmlns:r="http://schemas.openxmlformats.org/officeDocument/2006/relationships" xmlns:p="http://schemas.openxmlformats.org/presentationml/2006/main">
   <p:cSld name="Slide 12">
+    <p:spTree>
+      <p:nvGrpSpPr>
+        <p:cNvPr id="1" name=""/>
+        <p:cNvGrpSpPr/>
+        <p:nvPr/>
+      </p:nvGrpSpPr>
+      <p:grpSpPr>
+        <a:xfrm>
+          <a:off x="0" y="0"/>
+          <a:ext cx="0" cy="0"/>
+          <a:chOff x="0" y="0"/>
+          <a:chExt cx="0" cy="0"/>
+        </a:xfrm>
+      </p:grpSpPr>
+      <p:sp>
+        <p:nvSpPr>
+          <p:cNvPr id="3" name="title"/>
+          <p:cNvSpPr txBox="1"/>
+          <p:nvPr/>
+        </p:nvSpPr>
+        <p:spPr>
+          <a:xfrm>
+            <a:off x="365760" y="256032"/>
+            <a:ext cx="7955280" cy="384048"/>
+          </a:xfrm>
+          <a:prstGeom prst="rect">
+            <a:avLst/>
+          </a:prstGeom>
+          <a:noFill/>
+          <a:ln/>
+        </p:spPr>
+        <p:txBody>
+          <a:bodyPr wrap="square" lIns="0" tIns="0" rIns="0" bIns="0" rtlCol="0" anchor="ctr"/>
+          <a:lstStyle/>
+          <a:p>
+            <a:pPr algn="l" indent="0" marL="0">
+              <a:lnSpc>
+                <a:spcPct val="115000"/>
+              </a:lnSpc>
+              <a:buNone/>
+            </a:pPr>
+            <a:r>
+              <a:rPr lang="en-US" sz="2000" b="1" dirty="0">
+                <a:solidFill>
+                  <a:srgbClr val="B8692E"/>
+                </a:solidFill>
+                <a:latin typeface="Meiryo" pitchFamily="34" charset="0"/>
+                <a:ea typeface="Meiryo" pitchFamily="34" charset="-122"/>
+                <a:cs typeface="Meiryo" pitchFamily="34" charset="-120"/>
+              </a:rPr>
+              <a:t>根拠9 </a:t>
+            </a:r>
+            <a:pPr algn="l" indent="0" marL="0">
+              <a:lnSpc>
+                <a:spcPct val="115000"/>
+              </a:lnSpc>
+              <a:buNone/>
+            </a:pPr>
+            <a:r>
+              <a:rPr lang="en-US" sz="2000" b="1" dirty="0">
+                <a:solidFill>
+                  <a:srgbClr val="1A1A1A"/>
+                </a:solidFill>
+                <a:latin typeface="Meiryo" pitchFamily="34" charset="0"/>
+                <a:ea typeface="Meiryo" pitchFamily="34" charset="-122"/>
+                <a:cs typeface="Meiryo" pitchFamily="34" charset="-120"/>
+              </a:rPr>
+              <a:t>-2　黒字化の条件 ─ 計画の6割取れれば黒字</a:t>
+            </a:r>
+            <a:endParaRPr lang="en-US" sz="2000" dirty="0"/>
+          </a:p>
+        </p:txBody>
+      </p:sp>
+      <p:sp>
+        <p:nvSpPr>
+          <p:cNvPr id="4" name="lead"/>
+          <p:cNvSpPr txBox="1"/>
+          <p:nvPr/>
+        </p:nvSpPr>
+        <p:spPr>
+          <a:xfrm>
+            <a:off x="365760" y="658368"/>
+            <a:ext cx="7955280" cy="256032"/>
+          </a:xfrm>
+          <a:prstGeom prst="rect">
+            <a:avLst/>
+          </a:prstGeom>
+          <a:noFill/>
+          <a:ln/>
+        </p:spPr>
+        <p:txBody>
+          <a:bodyPr wrap="square" lIns="0" tIns="0" rIns="0" bIns="0" rtlCol="0" anchor="ctr"/>
+          <a:lstStyle/>
+          <a:p>
+            <a:pPr algn="l" indent="0" marL="0">
+              <a:lnSpc>
+                <a:spcPct val="115000"/>
+              </a:lnSpc>
+              <a:buNone/>
+            </a:pPr>
+            <a:r>
+              <a:rPr lang="en-US" sz="1200" dirty="0">
+                <a:solidFill>
+                  <a:srgbClr val="4D4D4D"/>
+                </a:solidFill>
+                <a:latin typeface="Meiryo" pitchFamily="34" charset="0"/>
+                <a:ea typeface="Meiryo" pitchFamily="34" charset="-122"/>
+                <a:cs typeface="Meiryo" pitchFamily="34" charset="-120"/>
+              </a:rPr>
+              <a:t>新規拠点が計画の何割なら持つかを同じモデルで計算し、進む・直す・止まるの線を先に引く</a:t>
+            </a:r>
+            <a:endParaRPr lang="en-US" sz="1200" dirty="0"/>
+          </a:p>
+        </p:txBody>
+      </p:sp>
+      <p:sp>
+        <p:nvSpPr>
+          <p:cNvPr id="5" name="Text 2"/>
+          <p:cNvSpPr txBox="1"/>
+          <p:nvPr/>
+        </p:nvSpPr>
+        <p:spPr>
+          <a:xfrm>
+            <a:off x="365760" y="1051560"/>
+            <a:ext cx="4846320" cy="237744"/>
+          </a:xfrm>
+          <a:prstGeom prst="rect">
+            <a:avLst/>
+          </a:prstGeom>
+          <a:noFill/>
+          <a:ln/>
+        </p:spPr>
+        <p:txBody>
+          <a:bodyPr wrap="square" lIns="0" tIns="0" rIns="0" bIns="0" rtlCol="0" anchor="t"/>
+          <a:lstStyle/>
+          <a:p>
+            <a:pPr algn="l" indent="0" marL="0">
+              <a:lnSpc>
+                <a:spcPct val="115000"/>
+              </a:lnSpc>
+              <a:buNone/>
+            </a:pPr>
+            <a:r>
+              <a:rPr lang="en-US" sz="1050" b="1" dirty="0">
+                <a:solidFill>
+                  <a:srgbClr val="1A1A1A"/>
+                </a:solidFill>
+                <a:latin typeface="Meiryo" pitchFamily="34" charset="0"/>
+                <a:ea typeface="Meiryo" pitchFamily="34" charset="-122"/>
+                <a:cs typeface="Meiryo" pitchFamily="34" charset="-120"/>
+              </a:rPr>
+              <a:t>新規拠点が計画に届かなかったら（百万円）</a:t>
+            </a:r>
+            <a:endParaRPr lang="en-US" sz="1050" dirty="0"/>
+          </a:p>
+        </p:txBody>
+      </p:sp>
+      <p:sp>
+        <p:nvSpPr>
+          <p:cNvPr id="6" name="Text 3"/>
+          <p:cNvSpPr txBox="1"/>
+          <p:nvPr/>
+        </p:nvSpPr>
+        <p:spPr>
+          <a:xfrm>
+            <a:off x="2651760" y="1325880"/>
+            <a:ext cx="1280160" cy="219456"/>
+          </a:xfrm>
+          <a:prstGeom prst="rect">
+            <a:avLst/>
+          </a:prstGeom>
+          <a:solidFill>
+            <a:srgbClr val="F2F2F2"/>
+          </a:solidFill>
+          <a:ln/>
+        </p:spPr>
+        <p:txBody>
+          <a:bodyPr wrap="square" lIns="0" tIns="0" rIns="0" bIns="0" rtlCol="0" anchor="ctr"/>
+          <a:lstStyle/>
+          <a:p>
+            <a:pPr algn="ctr" indent="0" marL="0">
+              <a:lnSpc>
+                <a:spcPct val="115000"/>
+              </a:lnSpc>
+              <a:buNone/>
+            </a:pPr>
+            <a:r>
+              <a:rPr lang="en-US" sz="850" b="1" dirty="0">
+                <a:solidFill>
+                  <a:srgbClr val="1A1A1A"/>
+                </a:solidFill>
+                <a:latin typeface="Meiryo" pitchFamily="34" charset="0"/>
+                <a:ea typeface="Meiryo" pitchFamily="34" charset="-122"/>
+                <a:cs typeface="Meiryo" pitchFamily="34" charset="-120"/>
+              </a:rPr>
+              <a:t>採用を実績に合わせる</a:t>
+            </a:r>
+            <a:endParaRPr lang="en-US" sz="850" dirty="0"/>
+          </a:p>
+        </p:txBody>
+      </p:sp>
+      <p:sp>
+        <p:nvSpPr>
+          <p:cNvPr id="7" name="Text 4"/>
+          <p:cNvSpPr txBox="1"/>
+          <p:nvPr/>
+        </p:nvSpPr>
+        <p:spPr>
+          <a:xfrm>
+            <a:off x="3931920" y="1325880"/>
+            <a:ext cx="1280160" cy="219456"/>
+          </a:xfrm>
+          <a:prstGeom prst="rect">
+            <a:avLst/>
+          </a:prstGeom>
+          <a:solidFill>
+            <a:srgbClr val="F2F2F2"/>
+          </a:solidFill>
+          <a:ln/>
+        </p:spPr>
+        <p:txBody>
+          <a:bodyPr wrap="square" lIns="0" tIns="0" rIns="0" bIns="0" rtlCol="0" anchor="ctr"/>
+          <a:lstStyle/>
+          <a:p>
+            <a:pPr algn="ctr" indent="0" marL="0">
+              <a:lnSpc>
+                <a:spcPct val="115000"/>
+              </a:lnSpc>
+              <a:buNone/>
+            </a:pPr>
+            <a:r>
+              <a:rPr lang="en-US" sz="850" b="1" dirty="0">
+                <a:solidFill>
+                  <a:srgbClr val="B8692E"/>
+                </a:solidFill>
+                <a:latin typeface="Meiryo" pitchFamily="34" charset="0"/>
+                <a:ea typeface="Meiryo" pitchFamily="34" charset="-122"/>
+                <a:cs typeface="Meiryo" pitchFamily="34" charset="-120"/>
+              </a:rPr>
+              <a:t>採用は計画どおり</a:t>
+            </a:r>
+            <a:endParaRPr lang="en-US" sz="850" dirty="0"/>
+          </a:p>
+        </p:txBody>
+      </p:sp>
+      <p:graphicFrame>
+        <p:nvGraphicFramePr>
+          <p:cNvPr id="13" name="shortfall"/>
+          <p:cNvGraphicFramePr>
+            <a:graphicFrameLocks noGrp="1"/>
+          </p:cNvGraphicFramePr>
+          <p:nvPr>
+            <p:extLst>
+              <p:ext uri="{D42A27DB-BD31-4B8C-83A1-F6EECF244321}">
+                <p14:modId xmlns:p14="http://schemas.microsoft.com/office/powerpoint/2010/main" val="1579011935"/>
+              </p:ext>
+            </p:extLst>
+          </p:nvPr>
+        </p:nvGraphicFramePr>
+        <p:xfrm>
+          <a:off x="365760" y="1554480"/>
+          <a:ext cx="4846320" cy="914400"/>
+        </p:xfrm>
+        <a:graphic>
+          <a:graphicData uri="http://schemas.openxmlformats.org/drawingml/2006/table">
+            <a:tbl>
+              <a:tblPr/>
+              <a:tblGrid>
+                <a:gridCol w="960120"/>
+                <a:gridCol w="1325880"/>
+                <a:gridCol w="640080"/>
+                <a:gridCol w="640080"/>
+                <a:gridCol w="640080"/>
+                <a:gridCol w="640080"/>
+              </a:tblGrid>
+              <a:tr h="292608">
+                <a:tc>
+                  <a:txBody>
+                    <a:bodyPr/>
+                    <a:lstStyle/>
+                    <a:p>
+                      <a:pPr algn="l" indent="0" marL="0">
+                        <a:buNone/>
+                      </a:pPr>
+                      <a:r>
+                        <a:rPr lang="en-US" sz="850" b="1" dirty="0">
+                          <a:solidFill>
+                            <a:srgbClr val="1A1A1A"/>
+                          </a:solidFill>
+                          <a:latin typeface="Meiryo" pitchFamily="34" charset="0"/>
+                          <a:ea typeface="Meiryo" pitchFamily="34" charset="-122"/>
+                          <a:cs typeface="Meiryo" pitchFamily="34" charset="-120"/>
+                        </a:rPr>
+                        <a:t>新規の達成度</a:t>
+                      </a:r>
+                      <a:endParaRPr lang="en-US" sz="850" dirty="0">
+                        <a:latin typeface="Meiryo" charset="0"/>
+                        <a:ea typeface="Meiryo" charset="0"/>
+                        <a:cs typeface="Meiryo" charset="0"/>
+                      </a:endParaRPr>
+                    </a:p>
+                  </a:txBody>
+                  <a:tcPr marL="54864" marR="54864" marT="18288" marB="18288" anchor="ctr">
+                    <a:lnL w="0" cap="flat" cmpd="sng" algn="ctr">
+                      <a:noFill/>
+                    </a:lnL>
+                    <a:lnR w="0" cap="flat" cmpd="sng" algn="ctr">
+                      <a:noFill/>
+                    </a:lnR>
+                    <a:lnT w="0" cap="flat" cmpd="sng" algn="ctr">
+                      <a:noFill/>
+                    </a:lnT>
+                    <a:lnB w="19050" cap="flat" cmpd="sng" algn="ctr">
+                      <a:solidFill>
+                        <a:srgbClr val="1A1A1A"/>
+                      </a:solidFill>
+                      <a:prstDash val="solid"/>
+                      <a:round/>
+                      <a:headEnd type="none" w="med" len="med"/>
+                      <a:tailEnd type="none" w="med" len="med"/>
+                    </a:lnB>
+                    <a:solidFill>
+                      <a:srgbClr val="F2F2F2"/>
+                    </a:solidFill>
+                  </a:tcPr>
+                </a:tc>
+                <a:tc>
+                  <a:txBody>
+                    <a:bodyPr/>
+                    <a:lstStyle/>
+                    <a:p>
+                      <a:pPr algn="ctr" indent="0" marL="0">
+                        <a:buNone/>
+                      </a:pPr>
+                      <a:r>
+                        <a:rPr lang="en-US" sz="850" b="1" dirty="0">
+                          <a:solidFill>
+                            <a:srgbClr val="1A1A1A"/>
+                          </a:solidFill>
+                          <a:latin typeface="Meiryo" pitchFamily="34" charset="0"/>
+                          <a:ea typeface="Meiryo" pitchFamily="34" charset="-122"/>
+                          <a:cs typeface="Meiryo" pitchFamily="34" charset="-120"/>
+                        </a:rPr>
+                        <a:t>新規拠点（1〜5年目）</a:t>
+                      </a:r>
+                      <a:endParaRPr lang="en-US" sz="850" dirty="0">
+                        <a:latin typeface="Meiryo" charset="0"/>
+                        <a:ea typeface="Meiryo" charset="0"/>
+                        <a:cs typeface="Meiryo" charset="0"/>
+                      </a:endParaRPr>
+                    </a:p>
+                  </a:txBody>
+                  <a:tcPr marL="54864" marR="54864" marT="18288" marB="18288" anchor="ctr">
+                    <a:lnL w="0" cap="flat" cmpd="sng" algn="ctr">
+                      <a:noFill/>
+                    </a:lnL>
+                    <a:lnR w="0" cap="flat" cmpd="sng" algn="ctr">
+                      <a:noFill/>
+                    </a:lnR>
+                    <a:lnT w="0" cap="flat" cmpd="sng" algn="ctr">
+                      <a:noFill/>
+                    </a:lnT>
+                    <a:lnB w="19050" cap="flat" cmpd="sng" algn="ctr">
+                      <a:solidFill>
+                        <a:srgbClr val="1A1A1A"/>
+                      </a:solidFill>
+                      <a:prstDash val="solid"/>
+                      <a:round/>
+                      <a:headEnd type="none" w="med" len="med"/>
+                      <a:tailEnd type="none" w="med" len="med"/>
+                    </a:lnB>
+                    <a:solidFill>
+                      <a:srgbClr val="F2F2F2"/>
+                    </a:solidFill>
+                  </a:tcPr>
+                </a:tc>
+                <a:tc>
+                  <a:txBody>
+                    <a:bodyPr/>
+                    <a:lstStyle/>
+                    <a:p>
+                      <a:pPr algn="ctr" indent="0" marL="0">
+                        <a:buNone/>
+                      </a:pPr>
+                      <a:r>
+                        <a:rPr lang="en-US" sz="850" b="1" dirty="0">
+                          <a:solidFill>
+                            <a:srgbClr val="1A1A1A"/>
+                          </a:solidFill>
+                          <a:latin typeface="Meiryo" pitchFamily="34" charset="0"/>
+                          <a:ea typeface="Meiryo" pitchFamily="34" charset="-122"/>
+                          <a:cs typeface="Meiryo" pitchFamily="34" charset="-120"/>
+                        </a:rPr>
+                        <a:t>黒字化</a:t>
+                      </a:r>
+                      <a:endParaRPr lang="en-US" sz="850" dirty="0">
+                        <a:latin typeface="Meiryo" charset="0"/>
+                        <a:ea typeface="Meiryo" charset="0"/>
+                        <a:cs typeface="Meiryo" charset="0"/>
+                      </a:endParaRPr>
+                    </a:p>
+                  </a:txBody>
+                  <a:tcPr marL="54864" marR="54864" marT="18288" marB="18288" anchor="ctr">
+                    <a:lnL w="0" cap="flat" cmpd="sng" algn="ctr">
+                      <a:noFill/>
+                    </a:lnL>
+                    <a:lnR w="0" cap="flat" cmpd="sng" algn="ctr">
+                      <a:noFill/>
+                    </a:lnR>
+                    <a:lnT w="0" cap="flat" cmpd="sng" algn="ctr">
+                      <a:noFill/>
+                    </a:lnT>
+                    <a:lnB w="19050" cap="flat" cmpd="sng" algn="ctr">
+                      <a:solidFill>
+                        <a:srgbClr val="1A1A1A"/>
+                      </a:solidFill>
+                      <a:prstDash val="solid"/>
+                      <a:round/>
+                      <a:headEnd type="none" w="med" len="med"/>
+                      <a:tailEnd type="none" w="med" len="med"/>
+                    </a:lnB>
+                    <a:solidFill>
+                      <a:srgbClr val="F2F2F2"/>
+                    </a:solidFill>
+                  </a:tcPr>
+                </a:tc>
+                <a:tc>
+                  <a:txBody>
+                    <a:bodyPr/>
+                    <a:lstStyle/>
+                    <a:p>
+                      <a:pPr algn="ctr" indent="0" marL="0">
+                        <a:buNone/>
+                      </a:pPr>
+                      <a:r>
+                        <a:rPr lang="en-US" sz="850" b="1" dirty="0">
+                          <a:solidFill>
+                            <a:srgbClr val="1A1A1A"/>
+                          </a:solidFill>
+                          <a:latin typeface="Meiryo" pitchFamily="34" charset="0"/>
+                          <a:ea typeface="Meiryo" pitchFamily="34" charset="-122"/>
+                          <a:cs typeface="Meiryo" pitchFamily="34" charset="-120"/>
+                        </a:rPr>
+                        <a:t>最低現金</a:t>
+                      </a:r>
+                      <a:endParaRPr lang="en-US" sz="850" dirty="0">
+                        <a:latin typeface="Meiryo" charset="0"/>
+                        <a:ea typeface="Meiryo" charset="0"/>
+                        <a:cs typeface="Meiryo" charset="0"/>
+                      </a:endParaRPr>
+                    </a:p>
+                  </a:txBody>
+                  <a:tcPr marL="54864" marR="54864" marT="18288" marB="18288" anchor="ctr">
+                    <a:lnL w="0" cap="flat" cmpd="sng" algn="ctr">
+                      <a:noFill/>
+                    </a:lnL>
+                    <a:lnR w="0" cap="flat" cmpd="sng" algn="ctr">
+                      <a:noFill/>
+                    </a:lnR>
+                    <a:lnT w="0" cap="flat" cmpd="sng" algn="ctr">
+                      <a:noFill/>
+                    </a:lnT>
+                    <a:lnB w="19050" cap="flat" cmpd="sng" algn="ctr">
+                      <a:solidFill>
+                        <a:srgbClr val="1A1A1A"/>
+                      </a:solidFill>
+                      <a:prstDash val="solid"/>
+                      <a:round/>
+                      <a:headEnd type="none" w="med" len="med"/>
+                      <a:tailEnd type="none" w="med" len="med"/>
+                    </a:lnB>
+                    <a:solidFill>
+                      <a:srgbClr val="F2F2F2"/>
+                    </a:solidFill>
+                  </a:tcPr>
+                </a:tc>
+                <a:tc>
+                  <a:txBody>
+                    <a:bodyPr/>
+                    <a:lstStyle/>
+                    <a:p>
+                      <a:pPr algn="ctr" indent="0" marL="0">
+                        <a:buNone/>
+                      </a:pPr>
+                      <a:r>
+                        <a:rPr lang="en-US" sz="850" b="1" dirty="0">
+                          <a:solidFill>
+                            <a:srgbClr val="1A1A1A"/>
+                          </a:solidFill>
+                          <a:latin typeface="Meiryo" pitchFamily="34" charset="0"/>
+                          <a:ea typeface="Meiryo" pitchFamily="34" charset="-122"/>
+                          <a:cs typeface="Meiryo" pitchFamily="34" charset="-120"/>
+                        </a:rPr>
+                        <a:t>黒字化</a:t>
+                      </a:r>
+                      <a:endParaRPr lang="en-US" sz="850" dirty="0">
+                        <a:latin typeface="Meiryo" charset="0"/>
+                        <a:ea typeface="Meiryo" charset="0"/>
+                        <a:cs typeface="Meiryo" charset="0"/>
+                      </a:endParaRPr>
+                    </a:p>
+                  </a:txBody>
+                  <a:tcPr marL="54864" marR="54864" marT="18288" marB="18288" anchor="ctr">
+                    <a:lnL w="0" cap="flat" cmpd="sng" algn="ctr">
+                      <a:noFill/>
+                    </a:lnL>
+                    <a:lnR w="0" cap="flat" cmpd="sng" algn="ctr">
+                      <a:noFill/>
+                    </a:lnR>
+                    <a:lnT w="0" cap="flat" cmpd="sng" algn="ctr">
+                      <a:noFill/>
+                    </a:lnT>
+                    <a:lnB w="19050" cap="flat" cmpd="sng" algn="ctr">
+                      <a:solidFill>
+                        <a:srgbClr val="1A1A1A"/>
+                      </a:solidFill>
+                      <a:prstDash val="solid"/>
+                      <a:round/>
+                      <a:headEnd type="none" w="med" len="med"/>
+                      <a:tailEnd type="none" w="med" len="med"/>
+                    </a:lnB>
+                    <a:solidFill>
+                      <a:srgbClr val="F2F2F2"/>
+                    </a:solidFill>
+                  </a:tcPr>
+                </a:tc>
+                <a:tc>
+                  <a:txBody>
+                    <a:bodyPr/>
+                    <a:lstStyle/>
+                    <a:p>
+                      <a:pPr algn="ctr" indent="0" marL="0">
+                        <a:buNone/>
+                      </a:pPr>
+                      <a:r>
+                        <a:rPr lang="en-US" sz="850" b="1" dirty="0">
+                          <a:solidFill>
+                            <a:srgbClr val="1A1A1A"/>
+                          </a:solidFill>
+                          <a:latin typeface="Meiryo" pitchFamily="34" charset="0"/>
+                          <a:ea typeface="Meiryo" pitchFamily="34" charset="-122"/>
+                          <a:cs typeface="Meiryo" pitchFamily="34" charset="-120"/>
+                        </a:rPr>
+                        <a:t>最低現金</a:t>
+                      </a:r>
+                      <a:endParaRPr lang="en-US" sz="850" dirty="0">
+                        <a:latin typeface="Meiryo" charset="0"/>
+                        <a:ea typeface="Meiryo" charset="0"/>
+                        <a:cs typeface="Meiryo" charset="0"/>
+                      </a:endParaRPr>
+                    </a:p>
+                  </a:txBody>
+                  <a:tcPr marL="54864" marR="54864" marT="18288" marB="18288" anchor="ctr">
+                    <a:lnL w="0" cap="flat" cmpd="sng" algn="ctr">
+                      <a:noFill/>
+                    </a:lnL>
+                    <a:lnR w="0" cap="flat" cmpd="sng" algn="ctr">
+                      <a:noFill/>
+                    </a:lnR>
+                    <a:lnT w="0" cap="flat" cmpd="sng" algn="ctr">
+                      <a:noFill/>
+                    </a:lnT>
+                    <a:lnB w="19050" cap="flat" cmpd="sng" algn="ctr">
+                      <a:solidFill>
+                        <a:srgbClr val="1A1A1A"/>
+                      </a:solidFill>
+                      <a:prstDash val="solid"/>
+                      <a:round/>
+                      <a:headEnd type="none" w="med" len="med"/>
+                      <a:tailEnd type="none" w="med" len="med"/>
+                    </a:lnB>
+                    <a:solidFill>
+                      <a:srgbClr val="F2F2F2"/>
+                    </a:solidFill>
+                  </a:tcPr>
+                </a:tc>
+              </a:tr>
+              <a:tr h="292608">
+                <a:tc>
+                  <a:txBody>
+                    <a:bodyPr/>
+                    <a:lstStyle/>
+                    <a:p>
+                      <a:pPr algn="l" indent="0" marL="0">
+                        <a:buNone/>
+                      </a:pPr>
+                      <a:r>
+                        <a:rPr lang="en-US" sz="850" dirty="0">
+                          <a:solidFill>
+                            <a:srgbClr val="1A1A1A"/>
+                          </a:solidFill>
+                          <a:latin typeface="Meiryo" pitchFamily="34" charset="0"/>
+                          <a:ea typeface="Meiryo" pitchFamily="34" charset="-122"/>
+                          <a:cs typeface="Meiryo" pitchFamily="34" charset="-120"/>
+                        </a:rPr>
+                        <a:t>計画どおり</a:t>
+                      </a:r>
+                      <a:endParaRPr lang="en-US" sz="850" dirty="0">
+                        <a:latin typeface="Meiryo" charset="0"/>
+                        <a:ea typeface="Meiryo" charset="0"/>
+                        <a:cs typeface="Meiryo" charset="0"/>
+                      </a:endParaRPr>
+                    </a:p>
+                  </a:txBody>
+                  <a:tcPr marL="54864" marR="54864" marT="18288" marB="18288" anchor="ctr">
+                    <a:lnL w="0" cap="flat" cmpd="sng" algn="ctr">
+                      <a:noFill/>
+                    </a:lnL>
+                    <a:lnR w="0" cap="flat" cmpd="sng" algn="ctr">
+                      <a:noFill/>
+                    </a:lnR>
+                    <a:lnT w="0" cap="flat" cmpd="sng" algn="ctr">
+                      <a:noFill/>
+                    </a:lnT>
+                    <a:lnB w="9525" cap="flat" cmpd="sng" algn="ctr">
+                      <a:solidFill>
+                        <a:srgbClr val="BFBFBF"/>
+                      </a:solidFill>
+                      <a:prstDash val="solid"/>
+                      <a:round/>
+                      <a:headEnd type="none" w="med" len="med"/>
+                      <a:tailEnd type="none" w="med" len="med"/>
+                    </a:lnB>
+                    <a:solidFill>
+                      <a:srgbClr val="FFFFFF"/>
+                    </a:solidFill>
+                  </a:tcPr>
+                </a:tc>
+                <a:tc>
+                  <a:txBody>
+                    <a:bodyPr/>
+                    <a:lstStyle/>
+                    <a:p>
+                      <a:pPr algn="ctr" indent="0" marL="0">
+                        <a:buNone/>
+                      </a:pPr>
+                      <a:r>
+                        <a:rPr lang="en-US" sz="850" dirty="0">
+                          <a:solidFill>
+                            <a:srgbClr val="4D4D4D"/>
+                          </a:solidFill>
+                          <a:latin typeface="Meiryo" pitchFamily="34" charset="0"/>
+                          <a:ea typeface="Meiryo" pitchFamily="34" charset="-122"/>
+                          <a:cs typeface="Meiryo" pitchFamily="34" charset="-120"/>
+                        </a:rPr>
+                        <a:t>3・9・18・27・33</a:t>
+                      </a:r>
+                      <a:endParaRPr lang="en-US" sz="850" dirty="0">
+                        <a:latin typeface="Meiryo" charset="0"/>
+                        <a:ea typeface="Meiryo" charset="0"/>
+                        <a:cs typeface="Meiryo" charset="0"/>
+                      </a:endParaRPr>
+                    </a:p>
+                  </a:txBody>
+                  <a:tcPr marL="54864" marR="54864" marT="18288" marB="18288" anchor="ctr">
+                    <a:lnL w="0" cap="flat" cmpd="sng" algn="ctr">
+                      <a:noFill/>
+                    </a:lnL>
+                    <a:lnR w="0" cap="flat" cmpd="sng" algn="ctr">
+                      <a:noFill/>
+                    </a:lnR>
+                    <a:lnT w="0" cap="flat" cmpd="sng" algn="ctr">
+                      <a:noFill/>
+                    </a:lnT>
+                    <a:lnB w="9525" cap="flat" cmpd="sng" algn="ctr">
+                      <a:solidFill>
+                        <a:srgbClr val="BFBFBF"/>
+                      </a:solidFill>
+                      <a:prstDash val="solid"/>
+                      <a:round/>
+                      <a:headEnd type="none" w="med" len="med"/>
+                      <a:tailEnd type="none" w="med" len="med"/>
+                    </a:lnB>
+                    <a:solidFill>
+                      <a:srgbClr val="FFFFFF"/>
+                    </a:solidFill>
+                  </a:tcPr>
+                </a:tc>
+                <a:tc>
+                  <a:txBody>
+                    <a:bodyPr/>
+                    <a:lstStyle/>
+                    <a:p>
+                      <a:pPr algn="ctr" indent="0" marL="0">
+                        <a:buNone/>
+                      </a:pPr>
+                      <a:r>
+                        <a:rPr lang="en-US" sz="850" dirty="0">
+                          <a:solidFill>
+                            <a:srgbClr val="1A1A1A"/>
+                          </a:solidFill>
+                          <a:latin typeface="Meiryo" pitchFamily="34" charset="0"/>
+                          <a:ea typeface="Meiryo" pitchFamily="34" charset="-122"/>
+                          <a:cs typeface="Meiryo" pitchFamily="34" charset="-120"/>
+                        </a:rPr>
+                        <a:t>4年目</a:t>
+                      </a:r>
+                      <a:endParaRPr lang="en-US" sz="850" dirty="0">
+                        <a:latin typeface="Meiryo" charset="0"/>
+                        <a:ea typeface="Meiryo" charset="0"/>
+                        <a:cs typeface="Meiryo" charset="0"/>
+                      </a:endParaRPr>
+                    </a:p>
+                  </a:txBody>
+                  <a:tcPr marL="54864" marR="54864" marT="18288" marB="18288" anchor="ctr">
+                    <a:lnL w="0" cap="flat" cmpd="sng" algn="ctr">
+                      <a:noFill/>
+                    </a:lnL>
+                    <a:lnR w="0" cap="flat" cmpd="sng" algn="ctr">
+                      <a:noFill/>
+                    </a:lnR>
+                    <a:lnT w="0" cap="flat" cmpd="sng" algn="ctr">
+                      <a:noFill/>
+                    </a:lnT>
+                    <a:lnB w="9525" cap="flat" cmpd="sng" algn="ctr">
+                      <a:solidFill>
+                        <a:srgbClr val="BFBFBF"/>
+                      </a:solidFill>
+                      <a:prstDash val="solid"/>
+                      <a:round/>
+                      <a:headEnd type="none" w="med" len="med"/>
+                      <a:tailEnd type="none" w="med" len="med"/>
+                    </a:lnB>
+                    <a:solidFill>
+                      <a:srgbClr val="FFFFFF"/>
+                    </a:solidFill>
+                  </a:tcPr>
+                </a:tc>
+                <a:tc>
+                  <a:txBody>
+                    <a:bodyPr/>
+                    <a:lstStyle/>
+                    <a:p>
+                      <a:pPr algn="ctr" indent="0" marL="0">
+                        <a:buNone/>
+                      </a:pPr>
+                      <a:r>
+                        <a:rPr lang="en-US" sz="850" dirty="0">
+                          <a:solidFill>
+                            <a:srgbClr val="1A1A1A"/>
+                          </a:solidFill>
+                          <a:latin typeface="Meiryo" pitchFamily="34" charset="0"/>
+                          <a:ea typeface="Meiryo" pitchFamily="34" charset="-122"/>
+                          <a:cs typeface="Meiryo" pitchFamily="34" charset="-120"/>
+                        </a:rPr>
+                        <a:t>60</a:t>
+                      </a:r>
+                      <a:endParaRPr lang="en-US" sz="850" dirty="0">
+                        <a:latin typeface="Meiryo" charset="0"/>
+                        <a:ea typeface="Meiryo" charset="0"/>
+                        <a:cs typeface="Meiryo" charset="0"/>
+                      </a:endParaRPr>
+                    </a:p>
+                  </a:txBody>
+                  <a:tcPr marL="54864" marR="54864" marT="18288" marB="18288" anchor="ctr">
+                    <a:lnL w="0" cap="flat" cmpd="sng" algn="ctr">
+                      <a:noFill/>
+                    </a:lnL>
+                    <a:lnR w="0" cap="flat" cmpd="sng" algn="ctr">
+                      <a:noFill/>
+                    </a:lnR>
+                    <a:lnT w="0" cap="flat" cmpd="sng" algn="ctr">
+                      <a:noFill/>
+                    </a:lnT>
+                    <a:lnB w="9525" cap="flat" cmpd="sng" algn="ctr">
+                      <a:solidFill>
+                        <a:srgbClr val="BFBFBF"/>
+                      </a:solidFill>
+                      <a:prstDash val="solid"/>
+                      <a:round/>
+                      <a:headEnd type="none" w="med" len="med"/>
+                      <a:tailEnd type="none" w="med" len="med"/>
+                    </a:lnB>
+                    <a:solidFill>
+                      <a:srgbClr val="FFFFFF"/>
+                    </a:solidFill>
+                  </a:tcPr>
+                </a:tc>
+                <a:tc>
+                  <a:txBody>
+                    <a:bodyPr/>
+                    <a:lstStyle/>
+                    <a:p>
+                      <a:pPr algn="ctr" indent="0" marL="0">
+                        <a:buNone/>
+                      </a:pPr>
+                      <a:r>
+                        <a:rPr lang="en-US" sz="850" dirty="0">
+                          <a:solidFill>
+                            <a:srgbClr val="1A1A1A"/>
+                          </a:solidFill>
+                          <a:latin typeface="Meiryo" pitchFamily="34" charset="0"/>
+                          <a:ea typeface="Meiryo" pitchFamily="34" charset="-122"/>
+                          <a:cs typeface="Meiryo" pitchFamily="34" charset="-120"/>
+                        </a:rPr>
+                        <a:t>4年目</a:t>
+                      </a:r>
+                      <a:endParaRPr lang="en-US" sz="850" dirty="0">
+                        <a:latin typeface="Meiryo" charset="0"/>
+                        <a:ea typeface="Meiryo" charset="0"/>
+                        <a:cs typeface="Meiryo" charset="0"/>
+                      </a:endParaRPr>
+                    </a:p>
+                  </a:txBody>
+                  <a:tcPr marL="54864" marR="54864" marT="18288" marB="18288" anchor="ctr">
+                    <a:lnL w="0" cap="flat" cmpd="sng" algn="ctr">
+                      <a:noFill/>
+                    </a:lnL>
+                    <a:lnR w="0" cap="flat" cmpd="sng" algn="ctr">
+                      <a:noFill/>
+                    </a:lnR>
+                    <a:lnT w="0" cap="flat" cmpd="sng" algn="ctr">
+                      <a:noFill/>
+                    </a:lnT>
+                    <a:lnB w="9525" cap="flat" cmpd="sng" algn="ctr">
+                      <a:solidFill>
+                        <a:srgbClr val="BFBFBF"/>
+                      </a:solidFill>
+                      <a:prstDash val="solid"/>
+                      <a:round/>
+                      <a:headEnd type="none" w="med" len="med"/>
+                      <a:tailEnd type="none" w="med" len="med"/>
+                    </a:lnB>
+                    <a:solidFill>
+                      <a:srgbClr val="FFFFFF"/>
+                    </a:solidFill>
+                  </a:tcPr>
+                </a:tc>
+                <a:tc>
+                  <a:txBody>
+                    <a:bodyPr/>
+                    <a:lstStyle/>
+                    <a:p>
+                      <a:pPr algn="ctr" indent="0" marL="0">
+                        <a:buNone/>
+                      </a:pPr>
+                      <a:r>
+                        <a:rPr lang="en-US" sz="850" dirty="0">
+                          <a:solidFill>
+                            <a:srgbClr val="1A1A1A"/>
+                          </a:solidFill>
+                          <a:latin typeface="Meiryo" pitchFamily="34" charset="0"/>
+                          <a:ea typeface="Meiryo" pitchFamily="34" charset="-122"/>
+                          <a:cs typeface="Meiryo" pitchFamily="34" charset="-120"/>
+                        </a:rPr>
+                        <a:t>60</a:t>
+                      </a:r>
+                      <a:endParaRPr lang="en-US" sz="850" dirty="0">
+                        <a:latin typeface="Meiryo" charset="0"/>
+                        <a:ea typeface="Meiryo" charset="0"/>
+                        <a:cs typeface="Meiryo" charset="0"/>
+                      </a:endParaRPr>
+                    </a:p>
+                  </a:txBody>
+                  <a:tcPr marL="54864" marR="54864" marT="18288" marB="18288" anchor="ctr">
+                    <a:lnL w="0" cap="flat" cmpd="sng" algn="ctr">
+                      <a:noFill/>
+                    </a:lnL>
+                    <a:lnR w="0" cap="flat" cmpd="sng" algn="ctr">
+                      <a:noFill/>
+                    </a:lnR>
+                    <a:lnT w="0" cap="flat" cmpd="sng" algn="ctr">
+                      <a:noFill/>
+                    </a:lnT>
+                    <a:lnB w="9525" cap="flat" cmpd="sng" algn="ctr">
+                      <a:solidFill>
+                        <a:srgbClr val="BFBFBF"/>
+                      </a:solidFill>
+                      <a:prstDash val="solid"/>
+                      <a:round/>
+                      <a:headEnd type="none" w="med" len="med"/>
+                      <a:tailEnd type="none" w="med" len="med"/>
+                    </a:lnB>
+                    <a:solidFill>
+                      <a:srgbClr val="FFFFFF"/>
+                    </a:solidFill>
+                  </a:tcPr>
+                </a:tc>
+              </a:tr>
+              <a:tr h="292608">
+                <a:tc>
+                  <a:txBody>
+                    <a:bodyPr/>
+                    <a:lstStyle/>
+                    <a:p>
+                      <a:pPr algn="l" indent="0" marL="0">
+                        <a:buNone/>
+                      </a:pPr>
+                      <a:r>
+                        <a:rPr lang="en-US" sz="850" dirty="0">
+                          <a:solidFill>
+                            <a:srgbClr val="1A1A1A"/>
+                          </a:solidFill>
+                          <a:latin typeface="Meiryo" pitchFamily="34" charset="0"/>
+                          <a:ea typeface="Meiryo" pitchFamily="34" charset="-122"/>
+                          <a:cs typeface="Meiryo" pitchFamily="34" charset="-120"/>
+                        </a:rPr>
+                        <a:t>計画の8割</a:t>
+                      </a:r>
+                      <a:endParaRPr lang="en-US" sz="850" dirty="0">
+                        <a:latin typeface="Meiryo" charset="0"/>
+                        <a:ea typeface="Meiryo" charset="0"/>
+                        <a:cs typeface="Meiryo" charset="0"/>
+                      </a:endParaRPr>
+                    </a:p>
+                  </a:txBody>
+                  <a:tcPr marL="54864" marR="54864" marT="18288" marB="18288" anchor="ctr">
+                    <a:lnL w="0" cap="flat" cmpd="sng" algn="ctr">
+                      <a:noFill/>
+                    </a:lnL>
+                    <a:lnR w="0" cap="flat" cmpd="sng" algn="ctr">
+                      <a:noFill/>
+                    </a:lnR>
+                    <a:lnT w="0" cap="flat" cmpd="sng" algn="ctr">
+                      <a:noFill/>
+                    </a:lnT>
+                    <a:lnB w="9525" cap="flat" cmpd="sng" algn="ctr">
+                      <a:solidFill>
+                        <a:srgbClr val="BFBFBF"/>
+                      </a:solidFill>
+                      <a:prstDash val="solid"/>
+                      <a:round/>
+                      <a:headEnd type="none" w="med" len="med"/>
+                      <a:tailEnd type="none" w="med" len="med"/>
+                    </a:lnB>
+                    <a:solidFill>
+                      <a:srgbClr val="FFFFFF"/>
+                    </a:solidFill>
+                  </a:tcPr>
+                </a:tc>
+                <a:tc>
+                  <a:txBody>
+                    <a:bodyPr/>
+                    <a:lstStyle/>
+                    <a:p>
+                      <a:pPr algn="ctr" indent="0" marL="0">
+                        <a:buNone/>
+                      </a:pPr>
+                      <a:r>
+                        <a:rPr lang="en-US" sz="850" dirty="0">
+                          <a:solidFill>
+                            <a:srgbClr val="4D4D4D"/>
+                          </a:solidFill>
+                          <a:latin typeface="Meiryo" pitchFamily="34" charset="0"/>
+                          <a:ea typeface="Meiryo" pitchFamily="34" charset="-122"/>
+                          <a:cs typeface="Meiryo" pitchFamily="34" charset="-120"/>
+                        </a:rPr>
+                        <a:t>2・7・14・22・26</a:t>
+                      </a:r>
+                      <a:endParaRPr lang="en-US" sz="850" dirty="0">
+                        <a:latin typeface="Meiryo" charset="0"/>
+                        <a:ea typeface="Meiryo" charset="0"/>
+                        <a:cs typeface="Meiryo" charset="0"/>
+                      </a:endParaRPr>
+                    </a:p>
+                  </a:txBody>
+                  <a:tcPr marL="54864" marR="54864" marT="18288" marB="18288" anchor="ctr">
+                    <a:lnL w="0" cap="flat" cmpd="sng" algn="ctr">
+                      <a:noFill/>
+                    </a:lnL>
+                    <a:lnR w="0" cap="flat" cmpd="sng" algn="ctr">
+                      <a:noFill/>
+                    </a:lnR>
+                    <a:lnT w="0" cap="flat" cmpd="sng" algn="ctr">
+                      <a:noFill/>
+                    </a:lnT>
+                    <a:lnB w="9525" cap="flat" cmpd="sng" algn="ctr">
+                      <a:solidFill>
+                        <a:srgbClr val="BFBFBF"/>
+                      </a:solidFill>
+                      <a:prstDash val="solid"/>
+                      <a:round/>
+                      <a:headEnd type="none" w="med" len="med"/>
+                      <a:tailEnd type="none" w="med" len="med"/>
+                    </a:lnB>
+                    <a:solidFill>
+                      <a:srgbClr val="FFFFFF"/>
+                    </a:solidFill>
+                  </a:tcPr>
+                </a:tc>
+                <a:tc>
+                  <a:txBody>
+                    <a:bodyPr/>
+                    <a:lstStyle/>
+                    <a:p>
+                      <a:pPr algn="ctr" indent="0" marL="0">
+                        <a:buNone/>
+                      </a:pPr>
+                      <a:r>
+                        <a:rPr lang="en-US" sz="850" dirty="0">
+                          <a:solidFill>
+                            <a:srgbClr val="1A1A1A"/>
+                          </a:solidFill>
+                          <a:latin typeface="Meiryo" pitchFamily="34" charset="0"/>
+                          <a:ea typeface="Meiryo" pitchFamily="34" charset="-122"/>
+                          <a:cs typeface="Meiryo" pitchFamily="34" charset="-120"/>
+                        </a:rPr>
+                        <a:t>4年目</a:t>
+                      </a:r>
+                      <a:endParaRPr lang="en-US" sz="850" dirty="0">
+                        <a:latin typeface="Meiryo" charset="0"/>
+                        <a:ea typeface="Meiryo" charset="0"/>
+                        <a:cs typeface="Meiryo" charset="0"/>
+                      </a:endParaRPr>
+                    </a:p>
+                  </a:txBody>
+                  <a:tcPr marL="54864" marR="54864" marT="18288" marB="18288" anchor="ctr">
+                    <a:lnL w="0" cap="flat" cmpd="sng" algn="ctr">
+                      <a:noFill/>
+                    </a:lnL>
+                    <a:lnR w="0" cap="flat" cmpd="sng" algn="ctr">
+                      <a:noFill/>
+                    </a:lnR>
+                    <a:lnT w="0" cap="flat" cmpd="sng" algn="ctr">
+                      <a:noFill/>
+                    </a:lnT>
+                    <a:lnB w="9525" cap="flat" cmpd="sng" algn="ctr">
+                      <a:solidFill>
+                        <a:srgbClr val="BFBFBF"/>
+                      </a:solidFill>
+                      <a:prstDash val="solid"/>
+                      <a:round/>
+                      <a:headEnd type="none" w="med" len="med"/>
+                      <a:tailEnd type="none" w="med" len="med"/>
+                    </a:lnB>
+                    <a:solidFill>
+                      <a:srgbClr val="FFFFFF"/>
+                    </a:solidFill>
+                  </a:tcPr>
+                </a:tc>
+                <a:tc>
+                  <a:txBody>
+                    <a:bodyPr/>
+                    <a:lstStyle/>
+                    <a:p>
+                      <a:pPr algn="ctr" indent="0" marL="0">
+                        <a:buNone/>
+                      </a:pPr>
+                      <a:r>
+                        <a:rPr lang="en-US" sz="850" dirty="0">
+                          <a:solidFill>
+                            <a:srgbClr val="1A1A1A"/>
+                          </a:solidFill>
+                          <a:latin typeface="Meiryo" pitchFamily="34" charset="0"/>
+                          <a:ea typeface="Meiryo" pitchFamily="34" charset="-122"/>
+                          <a:cs typeface="Meiryo" pitchFamily="34" charset="-120"/>
+                        </a:rPr>
+                        <a:t>39</a:t>
+                      </a:r>
+                      <a:endParaRPr lang="en-US" sz="850" dirty="0">
+                        <a:latin typeface="Meiryo" charset="0"/>
+                        <a:ea typeface="Meiryo" charset="0"/>
+                        <a:cs typeface="Meiryo" charset="0"/>
+                      </a:endParaRPr>
+                    </a:p>
+                  </a:txBody>
+                  <a:tcPr marL="54864" marR="54864" marT="18288" marB="18288" anchor="ctr">
+                    <a:lnL w="0" cap="flat" cmpd="sng" algn="ctr">
+                      <a:noFill/>
+                    </a:lnL>
+                    <a:lnR w="0" cap="flat" cmpd="sng" algn="ctr">
+                      <a:noFill/>
+                    </a:lnR>
+                    <a:lnT w="0" cap="flat" cmpd="sng" algn="ctr">
+                      <a:noFill/>
+                    </a:lnT>
+                    <a:lnB w="9525" cap="flat" cmpd="sng" algn="ctr">
+                      <a:solidFill>
+                        <a:srgbClr val="BFBFBF"/>
+                      </a:solidFill>
+                      <a:prstDash val="solid"/>
+                      <a:round/>
+                      <a:headEnd type="none" w="med" len="med"/>
+                      <a:tailEnd type="none" w="med" len="med"/>
+                    </a:lnB>
+                    <a:solidFill>
+                      <a:srgbClr val="FFFFFF"/>
+                    </a:solidFill>
+                  </a:tcPr>
+                </a:tc>
+                <a:tc>
+                  <a:txBody>
+                    <a:bodyPr/>
+                    <a:lstStyle/>
+                    <a:p>
+                      <a:pPr algn="ctr" indent="0" marL="0">
+                        <a:buNone/>
+                      </a:pPr>
+                      <a:r>
+                        <a:rPr lang="en-US" sz="850" dirty="0">
+                          <a:solidFill>
+                            <a:srgbClr val="1A1A1A"/>
+                          </a:solidFill>
+                          <a:latin typeface="Meiryo" pitchFamily="34" charset="0"/>
+                          <a:ea typeface="Meiryo" pitchFamily="34" charset="-122"/>
+                          <a:cs typeface="Meiryo" pitchFamily="34" charset="-120"/>
+                        </a:rPr>
+                        <a:t>5年目</a:t>
+                      </a:r>
+                      <a:endParaRPr lang="en-US" sz="850" dirty="0">
+                        <a:latin typeface="Meiryo" charset="0"/>
+                        <a:ea typeface="Meiryo" charset="0"/>
+                        <a:cs typeface="Meiryo" charset="0"/>
+                      </a:endParaRPr>
+                    </a:p>
+                  </a:txBody>
+                  <a:tcPr marL="54864" marR="54864" marT="18288" marB="18288" anchor="ctr">
+                    <a:lnL w="0" cap="flat" cmpd="sng" algn="ctr">
+                      <a:noFill/>
+                    </a:lnL>
+                    <a:lnR w="0" cap="flat" cmpd="sng" algn="ctr">
+                      <a:noFill/>
+                    </a:lnR>
+                    <a:lnT w="0" cap="flat" cmpd="sng" algn="ctr">
+                      <a:noFill/>
+                    </a:lnT>
+                    <a:lnB w="9525" cap="flat" cmpd="sng" algn="ctr">
+                      <a:solidFill>
+                        <a:srgbClr val="BFBFBF"/>
+                      </a:solidFill>
+                      <a:prstDash val="solid"/>
+                      <a:round/>
+                      <a:headEnd type="none" w="med" len="med"/>
+                      <a:tailEnd type="none" w="med" len="med"/>
+                    </a:lnB>
+                    <a:solidFill>
+                      <a:srgbClr val="FFFFFF"/>
+                    </a:solidFill>
+                  </a:tcPr>
+                </a:tc>
+                <a:tc>
+                  <a:txBody>
+                    <a:bodyPr/>
+                    <a:lstStyle/>
+                    <a:p>
+                      <a:pPr algn="ctr" indent="0" marL="0">
+                        <a:buNone/>
+                      </a:pPr>
+                      <a:r>
+                        <a:rPr lang="en-US" sz="850" dirty="0">
+                          <a:solidFill>
+                            <a:srgbClr val="1A1A1A"/>
+                          </a:solidFill>
+                          <a:latin typeface="Meiryo" pitchFamily="34" charset="0"/>
+                          <a:ea typeface="Meiryo" pitchFamily="34" charset="-122"/>
+                          <a:cs typeface="Meiryo" pitchFamily="34" charset="-120"/>
+                        </a:rPr>
+                        <a:t>8</a:t>
+                      </a:r>
+                      <a:endParaRPr lang="en-US" sz="850" dirty="0">
+                        <a:latin typeface="Meiryo" charset="0"/>
+                        <a:ea typeface="Meiryo" charset="0"/>
+                        <a:cs typeface="Meiryo" charset="0"/>
+                      </a:endParaRPr>
+                    </a:p>
+                  </a:txBody>
+                  <a:tcPr marL="54864" marR="54864" marT="18288" marB="18288" anchor="ctr">
+                    <a:lnL w="0" cap="flat" cmpd="sng" algn="ctr">
+                      <a:noFill/>
+                    </a:lnL>
+                    <a:lnR w="0" cap="flat" cmpd="sng" algn="ctr">
+                      <a:noFill/>
+                    </a:lnR>
+                    <a:lnT w="0" cap="flat" cmpd="sng" algn="ctr">
+                      <a:noFill/>
+                    </a:lnT>
+                    <a:lnB w="9525" cap="flat" cmpd="sng" algn="ctr">
+                      <a:solidFill>
+                        <a:srgbClr val="BFBFBF"/>
+                      </a:solidFill>
+                      <a:prstDash val="solid"/>
+                      <a:round/>
+                      <a:headEnd type="none" w="med" len="med"/>
+                      <a:tailEnd type="none" w="med" len="med"/>
+                    </a:lnB>
+                    <a:solidFill>
+                      <a:srgbClr val="FFFFFF"/>
+                    </a:solidFill>
+                  </a:tcPr>
+                </a:tc>
+              </a:tr>
+              <a:tr h="292608">
+                <a:tc>
+                  <a:txBody>
+                    <a:bodyPr/>
+                    <a:lstStyle/>
+                    <a:p>
+                      <a:pPr algn="l" indent="0" marL="0">
+                        <a:buNone/>
+                      </a:pPr>
+                      <a:r>
+                        <a:rPr lang="en-US" sz="850" dirty="0">
+                          <a:solidFill>
+                            <a:srgbClr val="1A1A1A"/>
+                          </a:solidFill>
+                          <a:latin typeface="Meiryo" pitchFamily="34" charset="0"/>
+                          <a:ea typeface="Meiryo" pitchFamily="34" charset="-122"/>
+                          <a:cs typeface="Meiryo" pitchFamily="34" charset="-120"/>
+                        </a:rPr>
+                        <a:t>計画の7割</a:t>
+                      </a:r>
+                      <a:endParaRPr lang="en-US" sz="850" dirty="0">
+                        <a:latin typeface="Meiryo" charset="0"/>
+                        <a:ea typeface="Meiryo" charset="0"/>
+                        <a:cs typeface="Meiryo" charset="0"/>
+                      </a:endParaRPr>
+                    </a:p>
+                  </a:txBody>
+                  <a:tcPr marL="54864" marR="54864" marT="18288" marB="18288" anchor="ctr">
+                    <a:lnL w="0" cap="flat" cmpd="sng" algn="ctr">
+                      <a:noFill/>
+                    </a:lnL>
+                    <a:lnR w="0" cap="flat" cmpd="sng" algn="ctr">
+                      <a:noFill/>
+                    </a:lnR>
+                    <a:lnT w="0" cap="flat" cmpd="sng" algn="ctr">
+                      <a:noFill/>
+                    </a:lnT>
+                    <a:lnB w="9525" cap="flat" cmpd="sng" algn="ctr">
+                      <a:solidFill>
+                        <a:srgbClr val="BFBFBF"/>
+                      </a:solidFill>
+                      <a:prstDash val="solid"/>
+                      <a:round/>
+                      <a:headEnd type="none" w="med" len="med"/>
+                      <a:tailEnd type="none" w="med" len="med"/>
+                    </a:lnB>
+                    <a:solidFill>
+                      <a:srgbClr val="FFFFFF"/>
+                    </a:solidFill>
+                  </a:tcPr>
+                </a:tc>
+                <a:tc>
+                  <a:txBody>
+                    <a:bodyPr/>
+                    <a:lstStyle/>
+                    <a:p>
+                      <a:pPr algn="ctr" indent="0" marL="0">
+                        <a:buNone/>
+                      </a:pPr>
+                      <a:r>
+                        <a:rPr lang="en-US" sz="850" dirty="0">
+                          <a:solidFill>
+                            <a:srgbClr val="4D4D4D"/>
+                          </a:solidFill>
+                          <a:latin typeface="Meiryo" pitchFamily="34" charset="0"/>
+                          <a:ea typeface="Meiryo" pitchFamily="34" charset="-122"/>
+                          <a:cs typeface="Meiryo" pitchFamily="34" charset="-120"/>
+                        </a:rPr>
+                        <a:t>2・6・13・19・23</a:t>
+                      </a:r>
+                      <a:endParaRPr lang="en-US" sz="850" dirty="0">
+                        <a:latin typeface="Meiryo" charset="0"/>
+                        <a:ea typeface="Meiryo" charset="0"/>
+                        <a:cs typeface="Meiryo" charset="0"/>
+                      </a:endParaRPr>
+                    </a:p>
+                  </a:txBody>
+                  <a:tcPr marL="54864" marR="54864" marT="18288" marB="18288" anchor="ctr">
+                    <a:lnL w="0" cap="flat" cmpd="sng" algn="ctr">
+                      <a:noFill/>
+                    </a:lnL>
+                    <a:lnR w="0" cap="flat" cmpd="sng" algn="ctr">
+                      <a:noFill/>
+                    </a:lnR>
+                    <a:lnT w="0" cap="flat" cmpd="sng" algn="ctr">
+                      <a:noFill/>
+                    </a:lnT>
+                    <a:lnB w="9525" cap="flat" cmpd="sng" algn="ctr">
+                      <a:solidFill>
+                        <a:srgbClr val="BFBFBF"/>
+                      </a:solidFill>
+                      <a:prstDash val="solid"/>
+                      <a:round/>
+                      <a:headEnd type="none" w="med" len="med"/>
+                      <a:tailEnd type="none" w="med" len="med"/>
+                    </a:lnB>
+                    <a:solidFill>
+                      <a:srgbClr val="FFFFFF"/>
+                    </a:solidFill>
+                  </a:tcPr>
+                </a:tc>
+                <a:tc>
+                  <a:txBody>
+                    <a:bodyPr/>
+                    <a:lstStyle/>
+                    <a:p>
+                      <a:pPr algn="ctr" indent="0" marL="0">
+                        <a:buNone/>
+                      </a:pPr>
+                      <a:r>
+                        <a:rPr lang="en-US" sz="850" dirty="0">
+                          <a:solidFill>
+                            <a:srgbClr val="1A1A1A"/>
+                          </a:solidFill>
+                          <a:latin typeface="Meiryo" pitchFamily="34" charset="0"/>
+                          <a:ea typeface="Meiryo" pitchFamily="34" charset="-122"/>
+                          <a:cs typeface="Meiryo" pitchFamily="34" charset="-120"/>
+                        </a:rPr>
+                        <a:t>4年目</a:t>
+                      </a:r>
+                      <a:endParaRPr lang="en-US" sz="850" dirty="0">
+                        <a:latin typeface="Meiryo" charset="0"/>
+                        <a:ea typeface="Meiryo" charset="0"/>
+                        <a:cs typeface="Meiryo" charset="0"/>
+                      </a:endParaRPr>
+                    </a:p>
+                  </a:txBody>
+                  <a:tcPr marL="54864" marR="54864" marT="18288" marB="18288" anchor="ctr">
+                    <a:lnL w="0" cap="flat" cmpd="sng" algn="ctr">
+                      <a:noFill/>
+                    </a:lnL>
+                    <a:lnR w="0" cap="flat" cmpd="sng" algn="ctr">
+                      <a:noFill/>
+                    </a:lnR>
+                    <a:lnT w="0" cap="flat" cmpd="sng" algn="ctr">
+                      <a:noFill/>
+                    </a:lnT>
+                    <a:lnB w="9525" cap="flat" cmpd="sng" algn="ctr">
+                      <a:solidFill>
+                        <a:srgbClr val="BFBFBF"/>
+                      </a:solidFill>
+                      <a:prstDash val="solid"/>
+                      <a:round/>
+                      <a:headEnd type="none" w="med" len="med"/>
+                      <a:tailEnd type="none" w="med" len="med"/>
+                    </a:lnB>
+                    <a:solidFill>
+                      <a:srgbClr val="FFFFFF"/>
+                    </a:solidFill>
+                  </a:tcPr>
+                </a:tc>
+                <a:tc>
+                  <a:txBody>
+                    <a:bodyPr/>
+                    <a:lstStyle/>
+                    <a:p>
+                      <a:pPr algn="ctr" indent="0" marL="0">
+                        <a:buNone/>
+                      </a:pPr>
+                      <a:r>
+                        <a:rPr lang="en-US" sz="850" dirty="0">
+                          <a:solidFill>
+                            <a:srgbClr val="1A1A1A"/>
+                          </a:solidFill>
+                          <a:latin typeface="Meiryo" pitchFamily="34" charset="0"/>
+                          <a:ea typeface="Meiryo" pitchFamily="34" charset="-122"/>
+                          <a:cs typeface="Meiryo" pitchFamily="34" charset="-120"/>
+                        </a:rPr>
+                        <a:t>36</a:t>
+                      </a:r>
+                      <a:endParaRPr lang="en-US" sz="850" dirty="0">
+                        <a:latin typeface="Meiryo" charset="0"/>
+                        <a:ea typeface="Meiryo" charset="0"/>
+                        <a:cs typeface="Meiryo" charset="0"/>
+                      </a:endParaRPr>
+                    </a:p>
+                  </a:txBody>
+                  <a:tcPr marL="54864" marR="54864" marT="18288" marB="18288" anchor="ctr">
+                    <a:lnL w="0" cap="flat" cmpd="sng" algn="ctr">
+                      <a:noFill/>
+                    </a:lnL>
+                    <a:lnR w="0" cap="flat" cmpd="sng" algn="ctr">
+                      <a:noFill/>
+                    </a:lnR>
+                    <a:lnT w="0" cap="flat" cmpd="sng" algn="ctr">
+                      <a:noFill/>
+                    </a:lnT>
+                    <a:lnB w="9525" cap="flat" cmpd="sng" algn="ctr">
+                      <a:solidFill>
+                        <a:srgbClr val="BFBFBF"/>
+                      </a:solidFill>
+                      <a:prstDash val="solid"/>
+                      <a:round/>
+                      <a:headEnd type="none" w="med" len="med"/>
+                      <a:tailEnd type="none" w="med" len="med"/>
+                    </a:lnB>
+                    <a:solidFill>
+                      <a:srgbClr val="FFFFFF"/>
+                    </a:solidFill>
+                  </a:tcPr>
+                </a:tc>
+                <a:tc>
+                  <a:txBody>
+                    <a:bodyPr/>
+                    <a:lstStyle/>
+                    <a:p>
+                      <a:pPr algn="ctr" indent="0" marL="0">
+                        <a:buNone/>
+                      </a:pPr>
+                      <a:r>
+                        <a:rPr lang="en-US" sz="850" b="1" dirty="0">
+                          <a:solidFill>
+                            <a:srgbClr val="B8692E"/>
+                          </a:solidFill>
+                          <a:latin typeface="Meiryo" pitchFamily="34" charset="0"/>
+                          <a:ea typeface="Meiryo" pitchFamily="34" charset="-122"/>
+                          <a:cs typeface="Meiryo" pitchFamily="34" charset="-120"/>
+                        </a:rPr>
+                        <a:t>しない</a:t>
+                      </a:r>
+                      <a:endParaRPr lang="en-US" sz="850" dirty="0">
+                        <a:latin typeface="Meiryo" charset="0"/>
+                        <a:ea typeface="Meiryo" charset="0"/>
+                        <a:cs typeface="Meiryo" charset="0"/>
+                      </a:endParaRPr>
+                    </a:p>
+                  </a:txBody>
+                  <a:tcPr marL="54864" marR="54864" marT="18288" marB="18288" anchor="ctr">
+                    <a:lnL w="0" cap="flat" cmpd="sng" algn="ctr">
+                      <a:noFill/>
+                    </a:lnL>
+                    <a:lnR w="0" cap="flat" cmpd="sng" algn="ctr">
+                      <a:noFill/>
+                    </a:lnR>
+                    <a:lnT w="0" cap="flat" cmpd="sng" algn="ctr">
+                      <a:noFill/>
+                    </a:lnT>
+                    <a:lnB w="9525" cap="flat" cmpd="sng" algn="ctr">
+                      <a:solidFill>
+                        <a:srgbClr val="BFBFBF"/>
+                      </a:solidFill>
+                      <a:prstDash val="solid"/>
+                      <a:round/>
+                      <a:headEnd type="none" w="med" len="med"/>
+                      <a:tailEnd type="none" w="med" len="med"/>
+                    </a:lnB>
+                    <a:solidFill>
+                      <a:srgbClr val="FFFFFF"/>
+                    </a:solidFill>
+                  </a:tcPr>
+                </a:tc>
+                <a:tc>
+                  <a:txBody>
+                    <a:bodyPr/>
+                    <a:lstStyle/>
+                    <a:p>
+                      <a:pPr algn="ctr" indent="0" marL="0">
+                        <a:buNone/>
+                      </a:pPr>
+                      <a:r>
+                        <a:rPr lang="en-US" sz="850" b="1" dirty="0">
+                          <a:solidFill>
+                            <a:srgbClr val="B8692E"/>
+                          </a:solidFill>
+                          <a:latin typeface="Meiryo" pitchFamily="34" charset="0"/>
+                          <a:ea typeface="Meiryo" pitchFamily="34" charset="-122"/>
+                          <a:cs typeface="Meiryo" pitchFamily="34" charset="-120"/>
+                        </a:rPr>
+                        <a:t>-38</a:t>
+                      </a:r>
+                      <a:endParaRPr lang="en-US" sz="850" dirty="0">
+                        <a:latin typeface="Meiryo" charset="0"/>
+                        <a:ea typeface="Meiryo" charset="0"/>
+                        <a:cs typeface="Meiryo" charset="0"/>
+                      </a:endParaRPr>
+                    </a:p>
+                  </a:txBody>
+                  <a:tcPr marL="54864" marR="54864" marT="18288" marB="18288" anchor="ctr">
+                    <a:lnL w="0" cap="flat" cmpd="sng" algn="ctr">
+                      <a:noFill/>
+                    </a:lnL>
+                    <a:lnR w="0" cap="flat" cmpd="sng" algn="ctr">
+                      <a:noFill/>
+                    </a:lnR>
+                    <a:lnT w="0" cap="flat" cmpd="sng" algn="ctr">
+                      <a:noFill/>
+                    </a:lnT>
+                    <a:lnB w="9525" cap="flat" cmpd="sng" algn="ctr">
+                      <a:solidFill>
+                        <a:srgbClr val="BFBFBF"/>
+                      </a:solidFill>
+                      <a:prstDash val="solid"/>
+                      <a:round/>
+                      <a:headEnd type="none" w="med" len="med"/>
+                      <a:tailEnd type="none" w="med" len="med"/>
+                    </a:lnB>
+                    <a:solidFill>
+                      <a:srgbClr val="FFFFFF"/>
+                    </a:solidFill>
+                  </a:tcPr>
+                </a:tc>
+              </a:tr>
+              <a:tr h="292608">
+                <a:tc>
+                  <a:txBody>
+                    <a:bodyPr/>
+                    <a:lstStyle/>
+                    <a:p>
+                      <a:pPr algn="l" indent="0" marL="0">
+                        <a:buNone/>
+                      </a:pPr>
+                      <a:r>
+                        <a:rPr lang="en-US" sz="850" b="1" dirty="0">
+                          <a:solidFill>
+                            <a:srgbClr val="B8692E"/>
+                          </a:solidFill>
+                          <a:latin typeface="Meiryo" pitchFamily="34" charset="0"/>
+                          <a:ea typeface="Meiryo" pitchFamily="34" charset="-122"/>
+                          <a:cs typeface="Meiryo" pitchFamily="34" charset="-120"/>
+                        </a:rPr>
+                        <a:t>計画の6割</a:t>
+                      </a:r>
+                      <a:endParaRPr lang="en-US" sz="850" dirty="0">
+                        <a:latin typeface="Meiryo" charset="0"/>
+                        <a:ea typeface="Meiryo" charset="0"/>
+                        <a:cs typeface="Meiryo" charset="0"/>
+                      </a:endParaRPr>
+                    </a:p>
+                  </a:txBody>
+                  <a:tcPr marL="54864" marR="54864" marT="18288" marB="18288" anchor="ctr">
+                    <a:lnL w="0" cap="flat" cmpd="sng" algn="ctr">
+                      <a:noFill/>
+                    </a:lnL>
+                    <a:lnR w="0" cap="flat" cmpd="sng" algn="ctr">
+                      <a:noFill/>
+                    </a:lnR>
+                    <a:lnT w="19050" cap="flat" cmpd="sng" algn="ctr">
+                      <a:solidFill>
+                        <a:srgbClr val="1A1A1A"/>
+                      </a:solidFill>
+                      <a:prstDash val="solid"/>
+                      <a:round/>
+                      <a:headEnd type="none" w="med" len="med"/>
+                      <a:tailEnd type="none" w="med" len="med"/>
+                    </a:lnT>
+                    <a:lnB w="9525" cap="flat" cmpd="sng" algn="ctr">
+                      <a:solidFill>
+                        <a:srgbClr val="BFBFBF"/>
+                      </a:solidFill>
+                      <a:prstDash val="solid"/>
+                      <a:round/>
+                      <a:headEnd type="none" w="med" len="med"/>
+                      <a:tailEnd type="none" w="med" len="med"/>
+                    </a:lnB>
+                    <a:solidFill>
+                      <a:srgbClr val="FFFFFF"/>
+                    </a:solidFill>
+                  </a:tcPr>
+                </a:tc>
+                <a:tc>
+                  <a:txBody>
+                    <a:bodyPr/>
+                    <a:lstStyle/>
+                    <a:p>
+                      <a:pPr algn="ctr" indent="0" marL="0">
+                        <a:buNone/>
+                      </a:pPr>
+                      <a:r>
+                        <a:rPr lang="en-US" sz="850" b="1" dirty="0">
+                          <a:solidFill>
+                            <a:srgbClr val="4D4D4D"/>
+                          </a:solidFill>
+                          <a:latin typeface="Meiryo" pitchFamily="34" charset="0"/>
+                          <a:ea typeface="Meiryo" pitchFamily="34" charset="-122"/>
+                          <a:cs typeface="Meiryo" pitchFamily="34" charset="-120"/>
+                        </a:rPr>
+                        <a:t>2・5・11・16・20</a:t>
+                      </a:r>
+                      <a:endParaRPr lang="en-US" sz="850" dirty="0">
+                        <a:latin typeface="Meiryo" charset="0"/>
+                        <a:ea typeface="Meiryo" charset="0"/>
+                        <a:cs typeface="Meiryo" charset="0"/>
+                      </a:endParaRPr>
+                    </a:p>
+                  </a:txBody>
+                  <a:tcPr marL="54864" marR="54864" marT="18288" marB="18288" anchor="ctr">
+                    <a:lnL w="0" cap="flat" cmpd="sng" algn="ctr">
+                      <a:noFill/>
+                    </a:lnL>
+                    <a:lnR w="0" cap="flat" cmpd="sng" algn="ctr">
+                      <a:noFill/>
+                    </a:lnR>
+                    <a:lnT w="19050" cap="flat" cmpd="sng" algn="ctr">
+                      <a:solidFill>
+                        <a:srgbClr val="1A1A1A"/>
+                      </a:solidFill>
+                      <a:prstDash val="solid"/>
+                      <a:round/>
+                      <a:headEnd type="none" w="med" len="med"/>
+                      <a:tailEnd type="none" w="med" len="med"/>
+                    </a:lnT>
+                    <a:lnB w="9525" cap="flat" cmpd="sng" algn="ctr">
+                      <a:solidFill>
+                        <a:srgbClr val="BFBFBF"/>
+                      </a:solidFill>
+                      <a:prstDash val="solid"/>
+                      <a:round/>
+                      <a:headEnd type="none" w="med" len="med"/>
+                      <a:tailEnd type="none" w="med" len="med"/>
+                    </a:lnB>
+                    <a:solidFill>
+                      <a:srgbClr val="FFFFFF"/>
+                    </a:solidFill>
+                  </a:tcPr>
+                </a:tc>
+                <a:tc>
+                  <a:txBody>
+                    <a:bodyPr/>
+                    <a:lstStyle/>
+                    <a:p>
+                      <a:pPr algn="ctr" indent="0" marL="0">
+                        <a:buNone/>
+                      </a:pPr>
+                      <a:r>
+                        <a:rPr lang="en-US" sz="850" b="1" dirty="0">
+                          <a:solidFill>
+                            <a:srgbClr val="1A1A1A"/>
+                          </a:solidFill>
+                          <a:latin typeface="Meiryo" pitchFamily="34" charset="0"/>
+                          <a:ea typeface="Meiryo" pitchFamily="34" charset="-122"/>
+                          <a:cs typeface="Meiryo" pitchFamily="34" charset="-120"/>
+                        </a:rPr>
+                        <a:t>5年目</a:t>
+                      </a:r>
+                      <a:endParaRPr lang="en-US" sz="850" dirty="0">
+                        <a:latin typeface="Meiryo" charset="0"/>
+                        <a:ea typeface="Meiryo" charset="0"/>
+                        <a:cs typeface="Meiryo" charset="0"/>
+                      </a:endParaRPr>
+                    </a:p>
+                  </a:txBody>
+                  <a:tcPr marL="54864" marR="54864" marT="18288" marB="18288" anchor="ctr">
+                    <a:lnL w="0" cap="flat" cmpd="sng" algn="ctr">
+                      <a:noFill/>
+                    </a:lnL>
+                    <a:lnR w="0" cap="flat" cmpd="sng" algn="ctr">
+                      <a:noFill/>
+                    </a:lnR>
+                    <a:lnT w="19050" cap="flat" cmpd="sng" algn="ctr">
+                      <a:solidFill>
+                        <a:srgbClr val="1A1A1A"/>
+                      </a:solidFill>
+                      <a:prstDash val="solid"/>
+                      <a:round/>
+                      <a:headEnd type="none" w="med" len="med"/>
+                      <a:tailEnd type="none" w="med" len="med"/>
+                    </a:lnT>
+                    <a:lnB w="9525" cap="flat" cmpd="sng" algn="ctr">
+                      <a:solidFill>
+                        <a:srgbClr val="BFBFBF"/>
+                      </a:solidFill>
+                      <a:prstDash val="solid"/>
+                      <a:round/>
+                      <a:headEnd type="none" w="med" len="med"/>
+                      <a:tailEnd type="none" w="med" len="med"/>
+                    </a:lnB>
+                    <a:solidFill>
+                      <a:srgbClr val="FFFFFF"/>
+                    </a:solidFill>
+                  </a:tcPr>
+                </a:tc>
+                <a:tc>
+                  <a:txBody>
+                    <a:bodyPr/>
+                    <a:lstStyle/>
+                    <a:p>
+                      <a:pPr algn="ctr" indent="0" marL="0">
+                        <a:buNone/>
+                      </a:pPr>
+                      <a:r>
+                        <a:rPr lang="en-US" sz="850" b="1" dirty="0">
+                          <a:solidFill>
+                            <a:srgbClr val="1A1A1A"/>
+                          </a:solidFill>
+                          <a:latin typeface="Meiryo" pitchFamily="34" charset="0"/>
+                          <a:ea typeface="Meiryo" pitchFamily="34" charset="-122"/>
+                          <a:cs typeface="Meiryo" pitchFamily="34" charset="-120"/>
+                        </a:rPr>
+                        <a:t>20</a:t>
+                      </a:r>
+                      <a:endParaRPr lang="en-US" sz="850" dirty="0">
+                        <a:latin typeface="Meiryo" charset="0"/>
+                        <a:ea typeface="Meiryo" charset="0"/>
+                        <a:cs typeface="Meiryo" charset="0"/>
+                      </a:endParaRPr>
+                    </a:p>
+                  </a:txBody>
+                  <a:tcPr marL="54864" marR="54864" marT="18288" marB="18288" anchor="ctr">
+                    <a:lnL w="0" cap="flat" cmpd="sng" algn="ctr">
+                      <a:noFill/>
+                    </a:lnL>
+                    <a:lnR w="0" cap="flat" cmpd="sng" algn="ctr">
+                      <a:noFill/>
+                    </a:lnR>
+                    <a:lnT w="19050" cap="flat" cmpd="sng" algn="ctr">
+                      <a:solidFill>
+                        <a:srgbClr val="1A1A1A"/>
+                      </a:solidFill>
+                      <a:prstDash val="solid"/>
+                      <a:round/>
+                      <a:headEnd type="none" w="med" len="med"/>
+                      <a:tailEnd type="none" w="med" len="med"/>
+                    </a:lnT>
+                    <a:lnB w="9525" cap="flat" cmpd="sng" algn="ctr">
+                      <a:solidFill>
+                        <a:srgbClr val="BFBFBF"/>
+                      </a:solidFill>
+                      <a:prstDash val="solid"/>
+                      <a:round/>
+                      <a:headEnd type="none" w="med" len="med"/>
+                      <a:tailEnd type="none" w="med" len="med"/>
+                    </a:lnB>
+                    <a:solidFill>
+                      <a:srgbClr val="FFFFFF"/>
+                    </a:solidFill>
+                  </a:tcPr>
+                </a:tc>
+                <a:tc>
+                  <a:txBody>
+                    <a:bodyPr/>
+                    <a:lstStyle/>
+                    <a:p>
+                      <a:pPr algn="ctr" indent="0" marL="0">
+                        <a:buNone/>
+                      </a:pPr>
+                      <a:r>
+                        <a:rPr lang="en-US" sz="850" b="1" dirty="0">
+                          <a:solidFill>
+                            <a:srgbClr val="B8692E"/>
+                          </a:solidFill>
+                          <a:latin typeface="Meiryo" pitchFamily="34" charset="0"/>
+                          <a:ea typeface="Meiryo" pitchFamily="34" charset="-122"/>
+                          <a:cs typeface="Meiryo" pitchFamily="34" charset="-120"/>
+                        </a:rPr>
+                        <a:t>しない</a:t>
+                      </a:r>
+                      <a:endParaRPr lang="en-US" sz="850" dirty="0">
+                        <a:latin typeface="Meiryo" charset="0"/>
+                        <a:ea typeface="Meiryo" charset="0"/>
+                        <a:cs typeface="Meiryo" charset="0"/>
+                      </a:endParaRPr>
+                    </a:p>
+                  </a:txBody>
+                  <a:tcPr marL="54864" marR="54864" marT="18288" marB="18288" anchor="ctr">
+                    <a:lnL w="0" cap="flat" cmpd="sng" algn="ctr">
+                      <a:noFill/>
+                    </a:lnL>
+                    <a:lnR w="0" cap="flat" cmpd="sng" algn="ctr">
+                      <a:noFill/>
+                    </a:lnR>
+                    <a:lnT w="19050" cap="flat" cmpd="sng" algn="ctr">
+                      <a:solidFill>
+                        <a:srgbClr val="1A1A1A"/>
+                      </a:solidFill>
+                      <a:prstDash val="solid"/>
+                      <a:round/>
+                      <a:headEnd type="none" w="med" len="med"/>
+                      <a:tailEnd type="none" w="med" len="med"/>
+                    </a:lnT>
+                    <a:lnB w="9525" cap="flat" cmpd="sng" algn="ctr">
+                      <a:solidFill>
+                        <a:srgbClr val="BFBFBF"/>
+                      </a:solidFill>
+                      <a:prstDash val="solid"/>
+                      <a:round/>
+                      <a:headEnd type="none" w="med" len="med"/>
+                      <a:tailEnd type="none" w="med" len="med"/>
+                    </a:lnB>
+                    <a:solidFill>
+                      <a:srgbClr val="FFFFFF"/>
+                    </a:solidFill>
+                  </a:tcPr>
+                </a:tc>
+                <a:tc>
+                  <a:txBody>
+                    <a:bodyPr/>
+                    <a:lstStyle/>
+                    <a:p>
+                      <a:pPr algn="ctr" indent="0" marL="0">
+                        <a:buNone/>
+                      </a:pPr>
+                      <a:r>
+                        <a:rPr lang="en-US" sz="850" b="1" dirty="0">
+                          <a:solidFill>
+                            <a:srgbClr val="B8692E"/>
+                          </a:solidFill>
+                          <a:latin typeface="Meiryo" pitchFamily="34" charset="0"/>
+                          <a:ea typeface="Meiryo" pitchFamily="34" charset="-122"/>
+                          <a:cs typeface="Meiryo" pitchFamily="34" charset="-120"/>
+                        </a:rPr>
+                        <a:t>-97</a:t>
+                      </a:r>
+                      <a:endParaRPr lang="en-US" sz="850" dirty="0">
+                        <a:latin typeface="Meiryo" charset="0"/>
+                        <a:ea typeface="Meiryo" charset="0"/>
+                        <a:cs typeface="Meiryo" charset="0"/>
+                      </a:endParaRPr>
+                    </a:p>
+                  </a:txBody>
+                  <a:tcPr marL="54864" marR="54864" marT="18288" marB="18288" anchor="ctr">
+                    <a:lnL w="0" cap="flat" cmpd="sng" algn="ctr">
+                      <a:noFill/>
+                    </a:lnL>
+                    <a:lnR w="0" cap="flat" cmpd="sng" algn="ctr">
+                      <a:noFill/>
+                    </a:lnR>
+                    <a:lnT w="19050" cap="flat" cmpd="sng" algn="ctr">
+                      <a:solidFill>
+                        <a:srgbClr val="1A1A1A"/>
+                      </a:solidFill>
+                      <a:prstDash val="solid"/>
+                      <a:round/>
+                      <a:headEnd type="none" w="med" len="med"/>
+                      <a:tailEnd type="none" w="med" len="med"/>
+                    </a:lnT>
+                    <a:lnB w="9525" cap="flat" cmpd="sng" algn="ctr">
+                      <a:solidFill>
+                        <a:srgbClr val="BFBFBF"/>
+                      </a:solidFill>
+                      <a:prstDash val="solid"/>
+                      <a:round/>
+                      <a:headEnd type="none" w="med" len="med"/>
+                      <a:tailEnd type="none" w="med" len="med"/>
+                    </a:lnB>
+                    <a:solidFill>
+                      <a:srgbClr val="FFFFFF"/>
+                    </a:solidFill>
+                  </a:tcPr>
+                </a:tc>
+              </a:tr>
+              <a:tr h="292608">
+                <a:tc>
+                  <a:txBody>
+                    <a:bodyPr/>
+                    <a:lstStyle/>
+                    <a:p>
+                      <a:pPr algn="l" indent="0" marL="0">
+                        <a:buNone/>
+                      </a:pPr>
+                      <a:r>
+                        <a:rPr lang="en-US" sz="850" dirty="0">
+                          <a:solidFill>
+                            <a:srgbClr val="1A1A1A"/>
+                          </a:solidFill>
+                          <a:latin typeface="Meiryo" pitchFamily="34" charset="0"/>
+                          <a:ea typeface="Meiryo" pitchFamily="34" charset="-122"/>
+                          <a:cs typeface="Meiryo" pitchFamily="34" charset="-120"/>
+                        </a:rPr>
+                        <a:t>計画の5割</a:t>
+                      </a:r>
+                      <a:endParaRPr lang="en-US" sz="850" dirty="0">
+                        <a:latin typeface="Meiryo" charset="0"/>
+                        <a:ea typeface="Meiryo" charset="0"/>
+                        <a:cs typeface="Meiryo" charset="0"/>
+                      </a:endParaRPr>
+                    </a:p>
+                  </a:txBody>
+                  <a:tcPr marL="54864" marR="54864" marT="18288" marB="18288" anchor="ctr">
+                    <a:lnL w="0" cap="flat" cmpd="sng" algn="ctr">
+                      <a:noFill/>
+                    </a:lnL>
+                    <a:lnR w="0" cap="flat" cmpd="sng" algn="ctr">
+                      <a:noFill/>
+                    </a:lnR>
+                    <a:lnT w="0" cap="flat" cmpd="sng" algn="ctr">
+                      <a:noFill/>
+                    </a:lnT>
+                    <a:lnB w="9525" cap="flat" cmpd="sng" algn="ctr">
+                      <a:solidFill>
+                        <a:srgbClr val="BFBFBF"/>
+                      </a:solidFill>
+                      <a:prstDash val="solid"/>
+                      <a:round/>
+                      <a:headEnd type="none" w="med" len="med"/>
+                      <a:tailEnd type="none" w="med" len="med"/>
+                    </a:lnB>
+                    <a:solidFill>
+                      <a:srgbClr val="FFFFFF"/>
+                    </a:solidFill>
+                  </a:tcPr>
+                </a:tc>
+                <a:tc>
+                  <a:txBody>
+                    <a:bodyPr/>
+                    <a:lstStyle/>
+                    <a:p>
+                      <a:pPr algn="ctr" indent="0" marL="0">
+                        <a:buNone/>
+                      </a:pPr>
+                      <a:r>
+                        <a:rPr lang="en-US" sz="850" dirty="0">
+                          <a:solidFill>
+                            <a:srgbClr val="4D4D4D"/>
+                          </a:solidFill>
+                          <a:latin typeface="Meiryo" pitchFamily="34" charset="0"/>
+                          <a:ea typeface="Meiryo" pitchFamily="34" charset="-122"/>
+                          <a:cs typeface="Meiryo" pitchFamily="34" charset="-120"/>
+                        </a:rPr>
+                        <a:t>2・5・9・14・17</a:t>
+                      </a:r>
+                      <a:endParaRPr lang="en-US" sz="850" dirty="0">
+                        <a:latin typeface="Meiryo" charset="0"/>
+                        <a:ea typeface="Meiryo" charset="0"/>
+                        <a:cs typeface="Meiryo" charset="0"/>
+                      </a:endParaRPr>
+                    </a:p>
+                  </a:txBody>
+                  <a:tcPr marL="54864" marR="54864" marT="18288" marB="18288" anchor="ctr">
+                    <a:lnL w="0" cap="flat" cmpd="sng" algn="ctr">
+                      <a:noFill/>
+                    </a:lnL>
+                    <a:lnR w="0" cap="flat" cmpd="sng" algn="ctr">
+                      <a:noFill/>
+                    </a:lnR>
+                    <a:lnT w="0" cap="flat" cmpd="sng" algn="ctr">
+                      <a:noFill/>
+                    </a:lnT>
+                    <a:lnB w="9525" cap="flat" cmpd="sng" algn="ctr">
+                      <a:solidFill>
+                        <a:srgbClr val="BFBFBF"/>
+                      </a:solidFill>
+                      <a:prstDash val="solid"/>
+                      <a:round/>
+                      <a:headEnd type="none" w="med" len="med"/>
+                      <a:tailEnd type="none" w="med" len="med"/>
+                    </a:lnB>
+                    <a:solidFill>
+                      <a:srgbClr val="FFFFFF"/>
+                    </a:solidFill>
+                  </a:tcPr>
+                </a:tc>
+                <a:tc>
+                  <a:txBody>
+                    <a:bodyPr/>
+                    <a:lstStyle/>
+                    <a:p>
+                      <a:pPr algn="ctr" indent="0" marL="0">
+                        <a:buNone/>
+                      </a:pPr>
+                      <a:r>
+                        <a:rPr lang="en-US" sz="850" b="1" dirty="0">
+                          <a:solidFill>
+                            <a:srgbClr val="B8692E"/>
+                          </a:solidFill>
+                          <a:latin typeface="Meiryo" pitchFamily="34" charset="0"/>
+                          <a:ea typeface="Meiryo" pitchFamily="34" charset="-122"/>
+                          <a:cs typeface="Meiryo" pitchFamily="34" charset="-120"/>
+                        </a:rPr>
+                        <a:t>しない</a:t>
+                      </a:r>
+                      <a:endParaRPr lang="en-US" sz="850" dirty="0">
+                        <a:latin typeface="Meiryo" charset="0"/>
+                        <a:ea typeface="Meiryo" charset="0"/>
+                        <a:cs typeface="Meiryo" charset="0"/>
+                      </a:endParaRPr>
+                    </a:p>
+                  </a:txBody>
+                  <a:tcPr marL="54864" marR="54864" marT="18288" marB="18288" anchor="ctr">
+                    <a:lnL w="0" cap="flat" cmpd="sng" algn="ctr">
+                      <a:noFill/>
+                    </a:lnL>
+                    <a:lnR w="0" cap="flat" cmpd="sng" algn="ctr">
+                      <a:noFill/>
+                    </a:lnR>
+                    <a:lnT w="0" cap="flat" cmpd="sng" algn="ctr">
+                      <a:noFill/>
+                    </a:lnT>
+                    <a:lnB w="9525" cap="flat" cmpd="sng" algn="ctr">
+                      <a:solidFill>
+                        <a:srgbClr val="BFBFBF"/>
+                      </a:solidFill>
+                      <a:prstDash val="solid"/>
+                      <a:round/>
+                      <a:headEnd type="none" w="med" len="med"/>
+                      <a:tailEnd type="none" w="med" len="med"/>
+                    </a:lnB>
+                    <a:solidFill>
+                      <a:srgbClr val="FFFFFF"/>
+                    </a:solidFill>
+                  </a:tcPr>
+                </a:tc>
+                <a:tc>
+                  <a:txBody>
+                    <a:bodyPr/>
+                    <a:lstStyle/>
+                    <a:p>
+                      <a:pPr algn="ctr" indent="0" marL="0">
+                        <a:buNone/>
+                      </a:pPr>
+                      <a:r>
+                        <a:rPr lang="en-US" sz="850" dirty="0">
+                          <a:solidFill>
+                            <a:srgbClr val="1A1A1A"/>
+                          </a:solidFill>
+                          <a:latin typeface="Meiryo" pitchFamily="34" charset="0"/>
+                          <a:ea typeface="Meiryo" pitchFamily="34" charset="-122"/>
+                          <a:cs typeface="Meiryo" pitchFamily="34" charset="-120"/>
+                        </a:rPr>
+                        <a:t>5</a:t>
+                      </a:r>
+                      <a:endParaRPr lang="en-US" sz="850" dirty="0">
+                        <a:latin typeface="Meiryo" charset="0"/>
+                        <a:ea typeface="Meiryo" charset="0"/>
+                        <a:cs typeface="Meiryo" charset="0"/>
+                      </a:endParaRPr>
+                    </a:p>
+                  </a:txBody>
+                  <a:tcPr marL="54864" marR="54864" marT="18288" marB="18288" anchor="ctr">
+                    <a:lnL w="0" cap="flat" cmpd="sng" algn="ctr">
+                      <a:noFill/>
+                    </a:lnL>
+                    <a:lnR w="0" cap="flat" cmpd="sng" algn="ctr">
+                      <a:noFill/>
+                    </a:lnR>
+                    <a:lnT w="0" cap="flat" cmpd="sng" algn="ctr">
+                      <a:noFill/>
+                    </a:lnT>
+                    <a:lnB w="9525" cap="flat" cmpd="sng" algn="ctr">
+                      <a:solidFill>
+                        <a:srgbClr val="BFBFBF"/>
+                      </a:solidFill>
+                      <a:prstDash val="solid"/>
+                      <a:round/>
+                      <a:headEnd type="none" w="med" len="med"/>
+                      <a:tailEnd type="none" w="med" len="med"/>
+                    </a:lnB>
+                    <a:solidFill>
+                      <a:srgbClr val="FFFFFF"/>
+                    </a:solidFill>
+                  </a:tcPr>
+                </a:tc>
+                <a:tc>
+                  <a:txBody>
+                    <a:bodyPr/>
+                    <a:lstStyle/>
+                    <a:p>
+                      <a:pPr algn="ctr" indent="0" marL="0">
+                        <a:buNone/>
+                      </a:pPr>
+                      <a:r>
+                        <a:rPr lang="en-US" sz="850" b="1" dirty="0">
+                          <a:solidFill>
+                            <a:srgbClr val="B8692E"/>
+                          </a:solidFill>
+                          <a:latin typeface="Meiryo" pitchFamily="34" charset="0"/>
+                          <a:ea typeface="Meiryo" pitchFamily="34" charset="-122"/>
+                          <a:cs typeface="Meiryo" pitchFamily="34" charset="-120"/>
+                        </a:rPr>
+                        <a:t>しない</a:t>
+                      </a:r>
+                      <a:endParaRPr lang="en-US" sz="850" dirty="0">
+                        <a:latin typeface="Meiryo" charset="0"/>
+                        <a:ea typeface="Meiryo" charset="0"/>
+                        <a:cs typeface="Meiryo" charset="0"/>
+                      </a:endParaRPr>
+                    </a:p>
+                  </a:txBody>
+                  <a:tcPr marL="54864" marR="54864" marT="18288" marB="18288" anchor="ctr">
+                    <a:lnL w="0" cap="flat" cmpd="sng" algn="ctr">
+                      <a:noFill/>
+                    </a:lnL>
+                    <a:lnR w="0" cap="flat" cmpd="sng" algn="ctr">
+                      <a:noFill/>
+                    </a:lnR>
+                    <a:lnT w="0" cap="flat" cmpd="sng" algn="ctr">
+                      <a:noFill/>
+                    </a:lnT>
+                    <a:lnB w="9525" cap="flat" cmpd="sng" algn="ctr">
+                      <a:solidFill>
+                        <a:srgbClr val="BFBFBF"/>
+                      </a:solidFill>
+                      <a:prstDash val="solid"/>
+                      <a:round/>
+                      <a:headEnd type="none" w="med" len="med"/>
+                      <a:tailEnd type="none" w="med" len="med"/>
+                    </a:lnB>
+                    <a:solidFill>
+                      <a:srgbClr val="FFFFFF"/>
+                    </a:solidFill>
+                  </a:tcPr>
+                </a:tc>
+                <a:tc>
+                  <a:txBody>
+                    <a:bodyPr/>
+                    <a:lstStyle/>
+                    <a:p>
+                      <a:pPr algn="ctr" indent="0" marL="0">
+                        <a:buNone/>
+                      </a:pPr>
+                      <a:r>
+                        <a:rPr lang="en-US" sz="850" b="1" dirty="0">
+                          <a:solidFill>
+                            <a:srgbClr val="B8692E"/>
+                          </a:solidFill>
+                          <a:latin typeface="Meiryo" pitchFamily="34" charset="0"/>
+                          <a:ea typeface="Meiryo" pitchFamily="34" charset="-122"/>
+                          <a:cs typeface="Meiryo" pitchFamily="34" charset="-120"/>
+                        </a:rPr>
+                        <a:t>-139</a:t>
+                      </a:r>
+                      <a:endParaRPr lang="en-US" sz="850" dirty="0">
+                        <a:latin typeface="Meiryo" charset="0"/>
+                        <a:ea typeface="Meiryo" charset="0"/>
+                        <a:cs typeface="Meiryo" charset="0"/>
+                      </a:endParaRPr>
+                    </a:p>
+                  </a:txBody>
+                  <a:tcPr marL="54864" marR="54864" marT="18288" marB="18288" anchor="ctr">
+                    <a:lnL w="0" cap="flat" cmpd="sng" algn="ctr">
+                      <a:noFill/>
+                    </a:lnL>
+                    <a:lnR w="0" cap="flat" cmpd="sng" algn="ctr">
+                      <a:noFill/>
+                    </a:lnR>
+                    <a:lnT w="0" cap="flat" cmpd="sng" algn="ctr">
+                      <a:noFill/>
+                    </a:lnT>
+                    <a:lnB w="9525" cap="flat" cmpd="sng" algn="ctr">
+                      <a:solidFill>
+                        <a:srgbClr val="BFBFBF"/>
+                      </a:solidFill>
+                      <a:prstDash val="solid"/>
+                      <a:round/>
+                      <a:headEnd type="none" w="med" len="med"/>
+                      <a:tailEnd type="none" w="med" len="med"/>
+                    </a:lnB>
+                    <a:solidFill>
+                      <a:srgbClr val="FFFFFF"/>
+                    </a:solidFill>
+                  </a:tcPr>
+                </a:tc>
+              </a:tr>
+            </a:tbl>
+          </a:graphicData>
+        </a:graphic>
+      </p:graphicFrame>
+      <p:sp>
+        <p:nvSpPr>
+          <p:cNvPr id="9" name="Shape 5"/>
+          <p:cNvSpPr/>
+          <p:nvPr/>
+        </p:nvSpPr>
+        <p:spPr>
+          <a:xfrm>
+            <a:off x="365760" y="3447288"/>
+            <a:ext cx="4846320" cy="822960"/>
+          </a:xfrm>
+          <a:prstGeom prst="rect">
+            <a:avLst/>
+          </a:prstGeom>
+          <a:solidFill>
+            <a:srgbClr val="1A1A1A"/>
+          </a:solidFill>
+          <a:ln/>
+        </p:spPr>
+      </p:sp>
+      <p:sp>
+        <p:nvSpPr>
+          <p:cNvPr id="10" name="Text 6"/>
+          <p:cNvSpPr txBox="1"/>
+          <p:nvPr/>
+        </p:nvSpPr>
+        <p:spPr>
+          <a:xfrm>
+            <a:off x="502920" y="3465576"/>
+            <a:ext cx="4572000" cy="786384"/>
+          </a:xfrm>
+          <a:prstGeom prst="rect">
+            <a:avLst/>
+          </a:prstGeom>
+          <a:noFill/>
+          <a:ln/>
+        </p:spPr>
+        <p:txBody>
+          <a:bodyPr wrap="square" lIns="0" tIns="0" rIns="0" bIns="0" rtlCol="0" anchor="ctr"/>
+          <a:lstStyle/>
+          <a:p>
+            <a:pPr algn="l" indent="0" marL="0">
+              <a:lnSpc>
+                <a:spcPct val="115000"/>
+              </a:lnSpc>
+              <a:spcAft>
+                <a:spcPts val="100"/>
+              </a:spcAft>
+              <a:buNone/>
+            </a:pPr>
+            <a:r>
+              <a:rPr lang="en-US" sz="900" b="1" dirty="0">
+                <a:solidFill>
+                  <a:srgbClr val="E3A774"/>
+                </a:solidFill>
+                <a:latin typeface="Meiryo" pitchFamily="34" charset="0"/>
+                <a:ea typeface="Meiryo" pitchFamily="34" charset="-122"/>
+                <a:cs typeface="Meiryo" pitchFamily="34" charset="-120"/>
+              </a:rPr>
+              <a:t>読み方</a:t>
+            </a:r>
+            <a:endParaRPr lang="en-US" sz="900" dirty="0"/>
+          </a:p>
+          <a:p>
+            <a:pPr algn="l" indent="0" marL="0">
+              <a:lnSpc>
+                <a:spcPct val="115000"/>
+              </a:lnSpc>
+              <a:spcAft>
+                <a:spcPts val="100"/>
+              </a:spcAft>
+              <a:buNone/>
+            </a:pPr>
+            <a:r>
+              <a:rPr lang="en-US" sz="900" dirty="0">
+                <a:solidFill>
+                  <a:srgbClr val="FFFFFF"/>
+                </a:solidFill>
+                <a:latin typeface="Meiryo" pitchFamily="34" charset="0"/>
+                <a:ea typeface="Meiryo" pitchFamily="34" charset="-122"/>
+                <a:cs typeface="Meiryo" pitchFamily="34" charset="-120"/>
+              </a:rPr>
+              <a:t>採用を遅らせれば、計画の6割で黒字、5割を割ると黒字にならない。</a:t>
+            </a:r>
+            <a:endParaRPr lang="en-US" sz="900" dirty="0"/>
+          </a:p>
+          <a:p>
+            <a:pPr algn="l" indent="0" marL="0">
+              <a:lnSpc>
+                <a:spcPct val="115000"/>
+              </a:lnSpc>
+              <a:spcAft>
+                <a:spcPts val="100"/>
+              </a:spcAft>
+              <a:buNone/>
+            </a:pPr>
+            <a:r>
+              <a:rPr lang="en-US" sz="900" dirty="0">
+                <a:solidFill>
+                  <a:srgbClr val="FFFFFF"/>
+                </a:solidFill>
+                <a:latin typeface="Meiryo" pitchFamily="34" charset="0"/>
+                <a:ea typeface="Meiryo" pitchFamily="34" charset="-122"/>
+                <a:cs typeface="Meiryo" pitchFamily="34" charset="-120"/>
+              </a:rPr>
+              <a:t>遅れているのに計画どおり採用すると、7割でも現金が尽きる。</a:t>
+            </a:r>
+            <a:endParaRPr lang="en-US" sz="900" dirty="0"/>
+          </a:p>
+          <a:p>
+            <a:pPr algn="l" indent="0" marL="0">
+              <a:lnSpc>
+                <a:spcPct val="115000"/>
+              </a:lnSpc>
+              <a:spcAft>
+                <a:spcPts val="100"/>
+              </a:spcAft>
+              <a:buNone/>
+            </a:pPr>
+            <a:r>
+              <a:rPr lang="en-US" sz="900" dirty="0">
+                <a:solidFill>
+                  <a:srgbClr val="FFFFFF"/>
+                </a:solidFill>
+                <a:latin typeface="Meiryo" pitchFamily="34" charset="0"/>
+                <a:ea typeface="Meiryo" pitchFamily="34" charset="-122"/>
+                <a:cs typeface="Meiryo" pitchFamily="34" charset="-120"/>
+              </a:rPr>
+              <a:t>採用は「期末で社員1人3拠点」の見込みが立ってから</a:t>
+            </a:r>
+            <a:endParaRPr lang="en-US" sz="900" dirty="0"/>
+          </a:p>
+        </p:txBody>
+      </p:sp>
+      <p:sp>
+        <p:nvSpPr>
+          <p:cNvPr id="11" name="Text 7"/>
+          <p:cNvSpPr txBox="1"/>
+          <p:nvPr/>
+        </p:nvSpPr>
+        <p:spPr>
+          <a:xfrm>
+            <a:off x="5486400" y="1051560"/>
+            <a:ext cx="3291840" cy="237744"/>
+          </a:xfrm>
+          <a:prstGeom prst="rect">
+            <a:avLst/>
+          </a:prstGeom>
+          <a:noFill/>
+          <a:ln/>
+        </p:spPr>
+        <p:txBody>
+          <a:bodyPr wrap="square" lIns="0" tIns="0" rIns="0" bIns="0" rtlCol="0" anchor="t"/>
+          <a:lstStyle/>
+          <a:p>
+            <a:pPr algn="l" indent="0" marL="0">
+              <a:lnSpc>
+                <a:spcPct val="115000"/>
+              </a:lnSpc>
+              <a:buNone/>
+            </a:pPr>
+            <a:r>
+              <a:rPr lang="en-US" sz="1050" b="1" dirty="0">
+                <a:solidFill>
+                  <a:srgbClr val="1A1A1A"/>
+                </a:solidFill>
+                <a:latin typeface="Meiryo" pitchFamily="34" charset="0"/>
+                <a:ea typeface="Meiryo" pitchFamily="34" charset="-122"/>
+                <a:cs typeface="Meiryo" pitchFamily="34" charset="-120"/>
+              </a:rPr>
+              <a:t>進む・直す・止まるの線</a:t>
+            </a:r>
+            <a:endParaRPr lang="en-US" sz="1050" dirty="0"/>
+          </a:p>
+        </p:txBody>
+      </p:sp>
+      <p:sp>
+        <p:nvSpPr>
+          <p:cNvPr id="12" name="Shape 8"/>
+          <p:cNvSpPr/>
+          <p:nvPr/>
+        </p:nvSpPr>
+        <p:spPr>
+          <a:xfrm>
+            <a:off x="5486400" y="1344168"/>
+            <a:ext cx="3291840" cy="1371600"/>
+          </a:xfrm>
+          <a:prstGeom prst="rect">
+            <a:avLst/>
+          </a:prstGeom>
+          <a:solidFill>
+            <a:srgbClr val="FFFFFF"/>
+          </a:solidFill>
+          <a:ln w="12700">
+            <a:solidFill>
+              <a:srgbClr val="1A1A1A"/>
+            </a:solidFill>
+            <a:prstDash val="solid"/>
+          </a:ln>
+        </p:spPr>
+      </p:sp>
+      <p:sp>
+        <p:nvSpPr>
+          <p:cNvPr id="13" name="Text 9"/>
+          <p:cNvSpPr txBox="1"/>
+          <p:nvPr/>
+        </p:nvSpPr>
+        <p:spPr>
+          <a:xfrm>
+            <a:off x="5596128" y="1380744"/>
+            <a:ext cx="3072384" cy="256032"/>
+          </a:xfrm>
+          <a:prstGeom prst="rect">
+            <a:avLst/>
+          </a:prstGeom>
+          <a:noFill/>
+          <a:ln/>
+        </p:spPr>
+        <p:txBody>
+          <a:bodyPr wrap="square" lIns="0" tIns="0" rIns="0" bIns="0" rtlCol="0" anchor="ctr"/>
+          <a:lstStyle/>
+          <a:p>
+            <a:pPr algn="l" indent="0" marL="0">
+              <a:lnSpc>
+                <a:spcPct val="115000"/>
+              </a:lnSpc>
+              <a:buNone/>
+            </a:pPr>
+            <a:r>
+              <a:rPr lang="en-US" sz="950" b="1" dirty="0">
+                <a:solidFill>
+                  <a:srgbClr val="B8692E"/>
+                </a:solidFill>
+                <a:latin typeface="Meiryo" pitchFamily="34" charset="0"/>
+                <a:ea typeface="Meiryo" pitchFamily="34" charset="-122"/>
+                <a:cs typeface="Meiryo" pitchFamily="34" charset="-120"/>
+              </a:rPr>
+              <a:t>1年目末　</a:t>
+            </a:r>
+            <a:pPr algn="l" indent="0" marL="0">
+              <a:lnSpc>
+                <a:spcPct val="115000"/>
+              </a:lnSpc>
+              <a:buNone/>
+            </a:pPr>
+            <a:r>
+              <a:rPr lang="en-US" sz="950" b="1" dirty="0">
+                <a:solidFill>
+                  <a:srgbClr val="1A1A1A"/>
+                </a:solidFill>
+                <a:latin typeface="Meiryo" pitchFamily="34" charset="0"/>
+                <a:ea typeface="Meiryo" pitchFamily="34" charset="-122"/>
+                <a:cs typeface="Meiryo" pitchFamily="34" charset="-120"/>
+              </a:rPr>
+              <a:t>実証3社のうち本契約</a:t>
+            </a:r>
+            <a:endParaRPr lang="en-US" sz="950" dirty="0"/>
+          </a:p>
+        </p:txBody>
+      </p:sp>
+      <p:sp>
+        <p:nvSpPr>
+          <p:cNvPr id="14" name="Shape 10"/>
+          <p:cNvSpPr/>
+          <p:nvPr/>
+        </p:nvSpPr>
+        <p:spPr>
+          <a:xfrm>
+            <a:off x="5596128" y="1673352"/>
+            <a:ext cx="777240" cy="292608"/>
+          </a:xfrm>
+          <a:prstGeom prst="rect">
+            <a:avLst/>
+          </a:prstGeom>
+          <a:solidFill>
+            <a:srgbClr val="1A1A1A"/>
+          </a:solidFill>
+          <a:ln/>
+        </p:spPr>
+      </p:sp>
+      <p:sp>
+        <p:nvSpPr>
+          <p:cNvPr id="15" name="Text 11"/>
+          <p:cNvSpPr txBox="1"/>
+          <p:nvPr/>
+        </p:nvSpPr>
+        <p:spPr>
+          <a:xfrm>
+            <a:off x="5596128" y="1673352"/>
+            <a:ext cx="777240" cy="292608"/>
+          </a:xfrm>
+          <a:prstGeom prst="rect">
+            <a:avLst/>
+          </a:prstGeom>
+          <a:noFill/>
+          <a:ln/>
+        </p:spPr>
+        <p:txBody>
+          <a:bodyPr wrap="square" lIns="0" tIns="0" rIns="0" bIns="0" rtlCol="0" anchor="ctr"/>
+          <a:lstStyle/>
+          <a:p>
+            <a:pPr algn="ctr" indent="0" marL="0">
+              <a:lnSpc>
+                <a:spcPct val="115000"/>
+              </a:lnSpc>
+              <a:buNone/>
+            </a:pPr>
+            <a:r>
+              <a:rPr lang="en-US" sz="900" b="1" dirty="0">
+                <a:solidFill>
+                  <a:srgbClr val="FFFFFF"/>
+                </a:solidFill>
+                <a:latin typeface="Meiryo" pitchFamily="34" charset="0"/>
+                <a:ea typeface="Meiryo" pitchFamily="34" charset="-122"/>
+                <a:cs typeface="Meiryo" pitchFamily="34" charset="-120"/>
+              </a:rPr>
+              <a:t>2社以上</a:t>
+            </a:r>
+            <a:endParaRPr lang="en-US" sz="900" dirty="0"/>
+          </a:p>
+        </p:txBody>
+      </p:sp>
+      <p:sp>
+        <p:nvSpPr>
+          <p:cNvPr id="16" name="Text 12"/>
+          <p:cNvSpPr txBox="1"/>
+          <p:nvPr/>
+        </p:nvSpPr>
+        <p:spPr>
+          <a:xfrm>
+            <a:off x="6446520" y="1673352"/>
+            <a:ext cx="2240280" cy="292608"/>
+          </a:xfrm>
+          <a:prstGeom prst="rect">
+            <a:avLst/>
+          </a:prstGeom>
+          <a:noFill/>
+          <a:ln/>
+        </p:spPr>
+        <p:txBody>
+          <a:bodyPr wrap="square" lIns="0" tIns="0" rIns="0" bIns="0" rtlCol="0" anchor="ctr"/>
+          <a:lstStyle/>
+          <a:p>
+            <a:pPr algn="l" indent="0" marL="0">
+              <a:lnSpc>
+                <a:spcPct val="115000"/>
+              </a:lnSpc>
+              <a:buNone/>
+            </a:pPr>
+            <a:r>
+              <a:rPr lang="en-US" sz="950" dirty="0">
+                <a:solidFill>
+                  <a:srgbClr val="1A1A1A"/>
+                </a:solidFill>
+                <a:latin typeface="Meiryo" pitchFamily="34" charset="0"/>
+                <a:ea typeface="Meiryo" pitchFamily="34" charset="-122"/>
+                <a:cs typeface="Meiryo" pitchFamily="34" charset="-120"/>
+              </a:rPr>
+              <a:t>→ 進む</a:t>
+            </a:r>
+            <a:endParaRPr lang="en-US" sz="950" dirty="0"/>
+          </a:p>
+        </p:txBody>
+      </p:sp>
+      <p:sp>
+        <p:nvSpPr>
+          <p:cNvPr id="17" name="Shape 13"/>
+          <p:cNvSpPr/>
+          <p:nvPr/>
+        </p:nvSpPr>
+        <p:spPr>
+          <a:xfrm>
+            <a:off x="5596128" y="2020824"/>
+            <a:ext cx="777240" cy="292608"/>
+          </a:xfrm>
+          <a:prstGeom prst="rect">
+            <a:avLst/>
+          </a:prstGeom>
+          <a:solidFill>
+            <a:srgbClr val="4D4D4D"/>
+          </a:solidFill>
+          <a:ln/>
+        </p:spPr>
+      </p:sp>
+      <p:sp>
+        <p:nvSpPr>
+          <p:cNvPr id="18" name="Text 14"/>
+          <p:cNvSpPr txBox="1"/>
+          <p:nvPr/>
+        </p:nvSpPr>
+        <p:spPr>
+          <a:xfrm>
+            <a:off x="5596128" y="2020824"/>
+            <a:ext cx="777240" cy="292608"/>
+          </a:xfrm>
+          <a:prstGeom prst="rect">
+            <a:avLst/>
+          </a:prstGeom>
+          <a:noFill/>
+          <a:ln/>
+        </p:spPr>
+        <p:txBody>
+          <a:bodyPr wrap="square" lIns="0" tIns="0" rIns="0" bIns="0" rtlCol="0" anchor="ctr"/>
+          <a:lstStyle/>
+          <a:p>
+            <a:pPr algn="ctr" indent="0" marL="0">
+              <a:lnSpc>
+                <a:spcPct val="115000"/>
+              </a:lnSpc>
+              <a:buNone/>
+            </a:pPr>
+            <a:r>
+              <a:rPr lang="en-US" sz="900" b="1" dirty="0">
+                <a:solidFill>
+                  <a:srgbClr val="FFFFFF"/>
+                </a:solidFill>
+                <a:latin typeface="Meiryo" pitchFamily="34" charset="0"/>
+                <a:ea typeface="Meiryo" pitchFamily="34" charset="-122"/>
+                <a:cs typeface="Meiryo" pitchFamily="34" charset="-120"/>
+              </a:rPr>
+              <a:t>1社</a:t>
+            </a:r>
+            <a:endParaRPr lang="en-US" sz="900" dirty="0"/>
+          </a:p>
+        </p:txBody>
+      </p:sp>
+      <p:sp>
+        <p:nvSpPr>
+          <p:cNvPr id="19" name="Text 15"/>
+          <p:cNvSpPr txBox="1"/>
+          <p:nvPr/>
+        </p:nvSpPr>
+        <p:spPr>
+          <a:xfrm>
+            <a:off x="6446520" y="2020824"/>
+            <a:ext cx="2240280" cy="292608"/>
+          </a:xfrm>
+          <a:prstGeom prst="rect">
+            <a:avLst/>
+          </a:prstGeom>
+          <a:noFill/>
+          <a:ln/>
+        </p:spPr>
+        <p:txBody>
+          <a:bodyPr wrap="square" lIns="0" tIns="0" rIns="0" bIns="0" rtlCol="0" anchor="ctr"/>
+          <a:lstStyle/>
+          <a:p>
+            <a:pPr algn="l" indent="0" marL="0">
+              <a:lnSpc>
+                <a:spcPct val="115000"/>
+              </a:lnSpc>
+              <a:buNone/>
+            </a:pPr>
+            <a:r>
+              <a:rPr lang="en-US" sz="950" dirty="0">
+                <a:solidFill>
+                  <a:srgbClr val="1A1A1A"/>
+                </a:solidFill>
+                <a:latin typeface="Meiryo" pitchFamily="34" charset="0"/>
+                <a:ea typeface="Meiryo" pitchFamily="34" charset="-122"/>
+                <a:cs typeface="Meiryo" pitchFamily="34" charset="-120"/>
+              </a:rPr>
+              <a:t>→ 値段と顧客を見直す</a:t>
+            </a:r>
+            <a:endParaRPr lang="en-US" sz="950" dirty="0"/>
+          </a:p>
+        </p:txBody>
+      </p:sp>
+      <p:sp>
+        <p:nvSpPr>
+          <p:cNvPr id="20" name="Shape 16"/>
+          <p:cNvSpPr/>
+          <p:nvPr/>
+        </p:nvSpPr>
+        <p:spPr>
+          <a:xfrm>
+            <a:off x="5596128" y="2368296"/>
+            <a:ext cx="777240" cy="292608"/>
+          </a:xfrm>
+          <a:prstGeom prst="rect">
+            <a:avLst/>
+          </a:prstGeom>
+          <a:solidFill>
+            <a:srgbClr val="B8692E"/>
+          </a:solidFill>
+          <a:ln/>
+        </p:spPr>
+      </p:sp>
+      <p:sp>
+        <p:nvSpPr>
+          <p:cNvPr id="21" name="Text 17"/>
+          <p:cNvSpPr txBox="1"/>
+          <p:nvPr/>
+        </p:nvSpPr>
+        <p:spPr>
+          <a:xfrm>
+            <a:off x="5596128" y="2368296"/>
+            <a:ext cx="777240" cy="292608"/>
+          </a:xfrm>
+          <a:prstGeom prst="rect">
+            <a:avLst/>
+          </a:prstGeom>
+          <a:noFill/>
+          <a:ln/>
+        </p:spPr>
+        <p:txBody>
+          <a:bodyPr wrap="square" lIns="0" tIns="0" rIns="0" bIns="0" rtlCol="0" anchor="ctr"/>
+          <a:lstStyle/>
+          <a:p>
+            <a:pPr algn="ctr" indent="0" marL="0">
+              <a:lnSpc>
+                <a:spcPct val="115000"/>
+              </a:lnSpc>
+              <a:buNone/>
+            </a:pPr>
+            <a:r>
+              <a:rPr lang="en-US" sz="900" b="1" dirty="0">
+                <a:solidFill>
+                  <a:srgbClr val="FFFFFF"/>
+                </a:solidFill>
+                <a:latin typeface="Meiryo" pitchFamily="34" charset="0"/>
+                <a:ea typeface="Meiryo" pitchFamily="34" charset="-122"/>
+                <a:cs typeface="Meiryo" pitchFamily="34" charset="-120"/>
+              </a:rPr>
+              <a:t>0社</a:t>
+            </a:r>
+            <a:endParaRPr lang="en-US" sz="900" dirty="0"/>
+          </a:p>
+        </p:txBody>
+      </p:sp>
+      <p:sp>
+        <p:nvSpPr>
+          <p:cNvPr id="22" name="Text 18"/>
+          <p:cNvSpPr txBox="1"/>
+          <p:nvPr/>
+        </p:nvSpPr>
+        <p:spPr>
+          <a:xfrm>
+            <a:off x="6446520" y="2368296"/>
+            <a:ext cx="2240280" cy="292608"/>
+          </a:xfrm>
+          <a:prstGeom prst="rect">
+            <a:avLst/>
+          </a:prstGeom>
+          <a:noFill/>
+          <a:ln/>
+        </p:spPr>
+        <p:txBody>
+          <a:bodyPr wrap="square" lIns="0" tIns="0" rIns="0" bIns="0" rtlCol="0" anchor="ctr"/>
+          <a:lstStyle/>
+          <a:p>
+            <a:pPr algn="l" indent="0" marL="0">
+              <a:lnSpc>
+                <a:spcPct val="115000"/>
+              </a:lnSpc>
+              <a:buNone/>
+            </a:pPr>
+            <a:r>
+              <a:rPr lang="en-US" sz="950" dirty="0">
+                <a:solidFill>
+                  <a:srgbClr val="1A1A1A"/>
+                </a:solidFill>
+                <a:latin typeface="Meiryo" pitchFamily="34" charset="0"/>
+                <a:ea typeface="Meiryo" pitchFamily="34" charset="-122"/>
+                <a:cs typeface="Meiryo" pitchFamily="34" charset="-120"/>
+              </a:rPr>
+              <a:t>→ 撤退か方向転換</a:t>
+            </a:r>
+            <a:endParaRPr lang="en-US" sz="950" dirty="0"/>
+          </a:p>
+        </p:txBody>
+      </p:sp>
+      <p:sp>
+        <p:nvSpPr>
+          <p:cNvPr id="23" name="Shape 19"/>
+          <p:cNvSpPr/>
+          <p:nvPr/>
+        </p:nvSpPr>
+        <p:spPr>
+          <a:xfrm>
+            <a:off x="5486400" y="2825496"/>
+            <a:ext cx="3291840" cy="1024128"/>
+          </a:xfrm>
+          <a:prstGeom prst="rect">
+            <a:avLst/>
+          </a:prstGeom>
+          <a:solidFill>
+            <a:srgbClr val="FFFFFF"/>
+          </a:solidFill>
+          <a:ln w="12700">
+            <a:solidFill>
+              <a:srgbClr val="1A1A1A"/>
+            </a:solidFill>
+            <a:prstDash val="solid"/>
+          </a:ln>
+        </p:spPr>
+      </p:sp>
+      <p:sp>
+        <p:nvSpPr>
+          <p:cNvPr id="24" name="Text 20"/>
+          <p:cNvSpPr txBox="1"/>
+          <p:nvPr/>
+        </p:nvSpPr>
+        <p:spPr>
+          <a:xfrm>
+            <a:off x="5596128" y="2862072"/>
+            <a:ext cx="3072384" cy="256032"/>
+          </a:xfrm>
+          <a:prstGeom prst="rect">
+            <a:avLst/>
+          </a:prstGeom>
+          <a:noFill/>
+          <a:ln/>
+        </p:spPr>
+        <p:txBody>
+          <a:bodyPr wrap="square" lIns="0" tIns="0" rIns="0" bIns="0" rtlCol="0" anchor="ctr"/>
+          <a:lstStyle/>
+          <a:p>
+            <a:pPr algn="l" indent="0" marL="0">
+              <a:lnSpc>
+                <a:spcPct val="115000"/>
+              </a:lnSpc>
+              <a:buNone/>
+            </a:pPr>
+            <a:r>
+              <a:rPr lang="en-US" sz="950" b="1" dirty="0">
+                <a:solidFill>
+                  <a:srgbClr val="B8692E"/>
+                </a:solidFill>
+                <a:latin typeface="Meiryo" pitchFamily="34" charset="0"/>
+                <a:ea typeface="Meiryo" pitchFamily="34" charset="-122"/>
+                <a:cs typeface="Meiryo" pitchFamily="34" charset="-120"/>
+              </a:rPr>
+              <a:t>2年目末　</a:t>
+            </a:r>
+            <a:pPr algn="l" indent="0" marL="0">
+              <a:lnSpc>
+                <a:spcPct val="115000"/>
+              </a:lnSpc>
+              <a:buNone/>
+            </a:pPr>
+            <a:r>
+              <a:rPr lang="en-US" sz="950" b="1" dirty="0">
+                <a:solidFill>
+                  <a:srgbClr val="1A1A1A"/>
+                </a:solidFill>
+                <a:latin typeface="Meiryo" pitchFamily="34" charset="0"/>
+                <a:ea typeface="Meiryo" pitchFamily="34" charset="-122"/>
+                <a:cs typeface="Meiryo" pitchFamily="34" charset="-120"/>
+              </a:rPr>
+              <a:t>新規拠点</a:t>
+            </a:r>
+            <a:endParaRPr lang="en-US" sz="950" dirty="0"/>
+          </a:p>
+        </p:txBody>
+      </p:sp>
+      <p:sp>
+        <p:nvSpPr>
+          <p:cNvPr id="25" name="Shape 21"/>
+          <p:cNvSpPr/>
+          <p:nvPr/>
+        </p:nvSpPr>
+        <p:spPr>
+          <a:xfrm>
+            <a:off x="5596128" y="3154680"/>
+            <a:ext cx="777240" cy="292608"/>
+          </a:xfrm>
+          <a:prstGeom prst="rect">
+            <a:avLst/>
+          </a:prstGeom>
+          <a:solidFill>
+            <a:srgbClr val="1A1A1A"/>
+          </a:solidFill>
+          <a:ln/>
+        </p:spPr>
+      </p:sp>
+      <p:sp>
+        <p:nvSpPr>
+          <p:cNvPr id="26" name="Text 22"/>
+          <p:cNvSpPr txBox="1"/>
+          <p:nvPr/>
+        </p:nvSpPr>
+        <p:spPr>
+          <a:xfrm>
+            <a:off x="5596128" y="3154680"/>
+            <a:ext cx="777240" cy="292608"/>
+          </a:xfrm>
+          <a:prstGeom prst="rect">
+            <a:avLst/>
+          </a:prstGeom>
+          <a:noFill/>
+          <a:ln/>
+        </p:spPr>
+        <p:txBody>
+          <a:bodyPr wrap="square" lIns="0" tIns="0" rIns="0" bIns="0" rtlCol="0" anchor="ctr"/>
+          <a:lstStyle/>
+          <a:p>
+            <a:pPr algn="ctr" indent="0" marL="0">
+              <a:lnSpc>
+                <a:spcPct val="115000"/>
+              </a:lnSpc>
+              <a:buNone/>
+            </a:pPr>
+            <a:r>
+              <a:rPr lang="en-US" sz="900" b="1" dirty="0">
+                <a:solidFill>
+                  <a:srgbClr val="FFFFFF"/>
+                </a:solidFill>
+                <a:latin typeface="Meiryo" pitchFamily="34" charset="0"/>
+                <a:ea typeface="Meiryo" pitchFamily="34" charset="-122"/>
+                <a:cs typeface="Meiryo" pitchFamily="34" charset="-120"/>
+              </a:rPr>
+              <a:t>5以上</a:t>
+            </a:r>
+            <a:endParaRPr lang="en-US" sz="900" dirty="0"/>
+          </a:p>
+        </p:txBody>
+      </p:sp>
+      <p:sp>
+        <p:nvSpPr>
+          <p:cNvPr id="27" name="Text 23"/>
+          <p:cNvSpPr txBox="1"/>
+          <p:nvPr/>
+        </p:nvSpPr>
+        <p:spPr>
+          <a:xfrm>
+            <a:off x="6446520" y="3154680"/>
+            <a:ext cx="2240280" cy="292608"/>
+          </a:xfrm>
+          <a:prstGeom prst="rect">
+            <a:avLst/>
+          </a:prstGeom>
+          <a:noFill/>
+          <a:ln/>
+        </p:spPr>
+        <p:txBody>
+          <a:bodyPr wrap="square" lIns="0" tIns="0" rIns="0" bIns="0" rtlCol="0" anchor="ctr"/>
+          <a:lstStyle/>
+          <a:p>
+            <a:pPr algn="l" indent="0" marL="0">
+              <a:lnSpc>
+                <a:spcPct val="115000"/>
+              </a:lnSpc>
+              <a:buNone/>
+            </a:pPr>
+            <a:r>
+              <a:rPr lang="en-US" sz="950" dirty="0">
+                <a:solidFill>
+                  <a:srgbClr val="1A1A1A"/>
+                </a:solidFill>
+                <a:latin typeface="Meiryo" pitchFamily="34" charset="0"/>
+                <a:ea typeface="Meiryo" pitchFamily="34" charset="-122"/>
+                <a:cs typeface="Meiryo" pitchFamily="34" charset="-120"/>
+              </a:rPr>
+              <a:t>→ 計画どおり採用</a:t>
+            </a:r>
+            <a:endParaRPr lang="en-US" sz="950" dirty="0"/>
+          </a:p>
+        </p:txBody>
+      </p:sp>
+      <p:sp>
+        <p:nvSpPr>
+          <p:cNvPr id="28" name="Shape 24"/>
+          <p:cNvSpPr/>
+          <p:nvPr/>
+        </p:nvSpPr>
+        <p:spPr>
+          <a:xfrm>
+            <a:off x="5596128" y="3502152"/>
+            <a:ext cx="777240" cy="292608"/>
+          </a:xfrm>
+          <a:prstGeom prst="rect">
+            <a:avLst/>
+          </a:prstGeom>
+          <a:solidFill>
+            <a:srgbClr val="B8692E"/>
+          </a:solidFill>
+          <a:ln/>
+        </p:spPr>
+      </p:sp>
+      <p:sp>
+        <p:nvSpPr>
+          <p:cNvPr id="29" name="Text 25"/>
+          <p:cNvSpPr txBox="1"/>
+          <p:nvPr/>
+        </p:nvSpPr>
+        <p:spPr>
+          <a:xfrm>
+            <a:off x="5596128" y="3502152"/>
+            <a:ext cx="777240" cy="292608"/>
+          </a:xfrm>
+          <a:prstGeom prst="rect">
+            <a:avLst/>
+          </a:prstGeom>
+          <a:noFill/>
+          <a:ln/>
+        </p:spPr>
+        <p:txBody>
+          <a:bodyPr wrap="square" lIns="0" tIns="0" rIns="0" bIns="0" rtlCol="0" anchor="ctr"/>
+          <a:lstStyle/>
+          <a:p>
+            <a:pPr algn="ctr" indent="0" marL="0">
+              <a:lnSpc>
+                <a:spcPct val="115000"/>
+              </a:lnSpc>
+              <a:buNone/>
+            </a:pPr>
+            <a:r>
+              <a:rPr lang="en-US" sz="900" b="1" dirty="0">
+                <a:solidFill>
+                  <a:srgbClr val="FFFFFF"/>
+                </a:solidFill>
+                <a:latin typeface="Meiryo" pitchFamily="34" charset="0"/>
+                <a:ea typeface="Meiryo" pitchFamily="34" charset="-122"/>
+                <a:cs typeface="Meiryo" pitchFamily="34" charset="-120"/>
+              </a:rPr>
+              <a:t>5未満</a:t>
+            </a:r>
+            <a:endParaRPr lang="en-US" sz="900" dirty="0"/>
+          </a:p>
+        </p:txBody>
+      </p:sp>
+      <p:sp>
+        <p:nvSpPr>
+          <p:cNvPr id="30" name="Text 26"/>
+          <p:cNvSpPr txBox="1"/>
+          <p:nvPr/>
+        </p:nvSpPr>
+        <p:spPr>
+          <a:xfrm>
+            <a:off x="6446520" y="3502152"/>
+            <a:ext cx="2240280" cy="292608"/>
+          </a:xfrm>
+          <a:prstGeom prst="rect">
+            <a:avLst/>
+          </a:prstGeom>
+          <a:noFill/>
+          <a:ln/>
+        </p:spPr>
+        <p:txBody>
+          <a:bodyPr wrap="square" lIns="0" tIns="0" rIns="0" bIns="0" rtlCol="0" anchor="ctr"/>
+          <a:lstStyle/>
+          <a:p>
+            <a:pPr algn="l" indent="0" marL="0">
+              <a:lnSpc>
+                <a:spcPct val="115000"/>
+              </a:lnSpc>
+              <a:buNone/>
+            </a:pPr>
+            <a:r>
+              <a:rPr lang="en-US" sz="950" dirty="0">
+                <a:solidFill>
+                  <a:srgbClr val="1A1A1A"/>
+                </a:solidFill>
+                <a:latin typeface="Meiryo" pitchFamily="34" charset="0"/>
+                <a:ea typeface="Meiryo" pitchFamily="34" charset="-122"/>
+                <a:cs typeface="Meiryo" pitchFamily="34" charset="-120"/>
+              </a:rPr>
+              <a:t>→ 採用を止める</a:t>
+            </a:r>
+            <a:endParaRPr lang="en-US" sz="950" dirty="0"/>
+          </a:p>
+        </p:txBody>
+      </p:sp>
+      <p:sp>
+        <p:nvSpPr>
+          <p:cNvPr id="31" name="Text 27"/>
+          <p:cNvSpPr txBox="1"/>
+          <p:nvPr/>
+        </p:nvSpPr>
+        <p:spPr>
+          <a:xfrm>
+            <a:off x="365760" y="4553712"/>
+            <a:ext cx="8412480" cy="237744"/>
+          </a:xfrm>
+          <a:prstGeom prst="rect">
+            <a:avLst/>
+          </a:prstGeom>
+          <a:noFill/>
+          <a:ln/>
+        </p:spPr>
+        <p:txBody>
+          <a:bodyPr wrap="square" lIns="0" tIns="0" rIns="0" bIns="0" rtlCol="0" anchor="t"/>
+          <a:lstStyle/>
+          <a:p>
+            <a:pPr algn="l" indent="0" marL="0">
+              <a:lnSpc>
+                <a:spcPct val="115000"/>
+              </a:lnSpc>
+              <a:buNone/>
+            </a:pPr>
+            <a:r>
+              <a:rPr lang="en-US" sz="800" dirty="0">
+                <a:solidFill>
+                  <a:srgbClr val="8C8C8C"/>
+                </a:solidFill>
+                <a:latin typeface="Meiryo" pitchFamily="34" charset="0"/>
+                <a:ea typeface="Meiryo" pitchFamily="34" charset="-122"/>
+                <a:cs typeface="Meiryo" pitchFamily="34" charset="-120"/>
+              </a:rPr>
+              <a:t>新規・受託を同じ割合で減らした簡易計算。採用連動＝4＋（計画−4）×達成度。調達1.25億円が前提（公庫だけなら計画どおりでも1年目から現金不足）</a:t>
+            </a:r>
+            <a:endParaRPr lang="en-US" sz="800" dirty="0"/>
+          </a:p>
+        </p:txBody>
+      </p:sp>
+      <p:sp>
+        <p:nvSpPr>
+          <p:cNvPr id="25" name="Slide Number Placeholder 0"/>
+          <p:cNvSpPr>
+            <a:spLocks noGrp="1"/>
+          </p:cNvSpPr>
+          <p:nvPr>
+            <p:ph type="sldNum" sz="quarter" idx="4294967295"/>
+          </p:nvPr>
+        </p:nvSpPr>
+        <p:spPr>
+          <a:xfrm>
+            <a:off x="365760" y="4837176"/>
+            <a:ext cx="320040" cy="201168"/>
+          </a:xfrm>
+          <a:prstGeom prst="rect">
+            <a:avLst/>
+          </a:prstGeom>
+          <a:extLst>
+            <a:ext uri="{C572A759-6A51-4108-AA02-DFA0A04FC94B}">
+              <ma14:wrappingTextBoxFlag xmlns:ma14="http://schemas.microsoft.com/office/mac/drawingml/2011/main" val="0"/>
+            </a:ext>
+          </a:extLst>
+        </p:spPr>
+        <p:txBody>
+          <a:bodyPr lIns="0" tIns="0" rIns="0" bIns="0"/>
+          <a:lstStyle>
+            <a:lvl1pPr>
+              <a:defRPr sz="850">
+                <a:solidFill>
+                  <a:srgbClr val="8C8C8C"/>
+                </a:solidFill>
+                <a:latin typeface="Meiryo"/>
+                <a:ea typeface="Meiryo"/>
+                <a:cs typeface="Meiryo"/>
+              </a:defRPr>
+            </a:lvl1pPr>
+          </a:lstStyle>
+          <a:p>
+            <a:pPr algn="l"/>
+            <a:fld id="{F7021451-1387-4CA6-816F-3879F97B5CBC}" type="slidenum">
+              <a:rPr b="0" lang="en-US"/>
+              <a:t>12</a:t>
+            </a:fld>
+            <a:endParaRPr lang="en-US"/>
+          </a:p>
+        </p:txBody>
+      </p:sp>
+    </p:spTree>
+  </p:cSld>
+  <p:clrMapOvr>
+    <a:masterClrMapping/>
+  </p:clrMapOvr>
+</p:sld>
+</file>
+
+<file path=ppt/slides/slide13.xml><?xml version="1.0" encoding="utf-8"?>
+<p:sld xmlns:a="http://schemas.openxmlformats.org/drawingml/2006/main" xmlns:r="http://schemas.openxmlformats.org/officeDocument/2006/relationships" xmlns:p="http://schemas.openxmlformats.org/presentationml/2006/main">
+  <p:cSld name="Slide 13">
     <p:spTree>
       <p:nvGrpSpPr>
         <p:cNvPr id="1" name=""/>
@@ -8555,7 +11738,7 @@
       </p:sp>
       <p:graphicFrame>
         <p:nvGraphicFramePr>
-          <p:cNvPr id="13" name="need"/>
+          <p:cNvPr id="14" name="need"/>
           <p:cNvGraphicFramePr>
             <a:graphicFrameLocks noGrp="1"/>
           </p:cNvGraphicFramePr>
@@ -9395,7 +12578,7 @@
       </p:sp>
       <p:graphicFrame>
         <p:nvGraphicFramePr>
-          <p:cNvPr id="25" name="raise"/>
+          <p:cNvPr id="27" name="raise"/>
           <p:cNvGraphicFramePr>
             <a:graphicFrameLocks noGrp="1"/>
           </p:cNvGraphicFramePr>
@@ -10228,7 +13411,7 @@
       </p:sp>
       <p:graphicFrame>
         <p:nvGraphicFramePr>
-          <p:cNvPr id="37" name="cash"/>
+          <p:cNvPr id="40" name="cash"/>
           <p:cNvGraphicFramePr>
             <a:graphicFrameLocks noGrp="1"/>
           </p:cNvGraphicFramePr>
@@ -11067,7 +14250,7 @@
                           <a:ea typeface="Meiryo" pitchFamily="34" charset="-122"/>
                           <a:cs typeface="Meiryo" pitchFamily="34" charset="-120"/>
                         </a:rPr>
-                        <a:t>28</a:t>
+                        <a:t>20</a:t>
                       </a:r>
                       <a:endParaRPr lang="en-US" sz="900" dirty="0">
                         <a:latin typeface="Meiryo" charset="0"/>
@@ -11117,7 +14300,7 @@
                           <a:ea typeface="Meiryo" pitchFamily="34" charset="-122"/>
                           <a:cs typeface="Meiryo" pitchFamily="34" charset="-120"/>
                         </a:rPr>
-                        <a:t>69</a:t>
+                        <a:t>61</a:t>
                       </a:r>
                       <a:endParaRPr lang="en-US" sz="900" dirty="0">
                         <a:latin typeface="Meiryo" charset="0"/>
@@ -11393,7 +14576,7 @@
                           <a:ea typeface="Meiryo" pitchFamily="34" charset="-122"/>
                           <a:cs typeface="Meiryo" pitchFamily="34" charset="-120"/>
                         </a:rPr>
-                        <a:t>88</a:t>
+                        <a:t>80</a:t>
                       </a:r>
                       <a:endParaRPr lang="en-US" sz="900" dirty="0">
                         <a:latin typeface="Meiryo" charset="0"/>
@@ -11449,7 +14632,7 @@
                           <a:ea typeface="Meiryo" pitchFamily="34" charset="-122"/>
                           <a:cs typeface="Meiryo" pitchFamily="34" charset="-120"/>
                         </a:rPr>
-                        <a:t>156</a:t>
+                        <a:t>140</a:t>
                       </a:r>
                       <a:endParaRPr lang="en-US" sz="900" dirty="0">
                         <a:latin typeface="Meiryo" charset="0"/>
@@ -11644,7 +14827,7 @@
                 <a:ea typeface="Meiryo" pitchFamily="34" charset="-122"/>
                 <a:cs typeface="Meiryo" pitchFamily="34" charset="-120"/>
               </a:rPr>
-              <a:t>④ 採用は社員1人2.8拠点の見込みが立ってから</a:t>
+              <a:t>④ 採用は期末で社員1人3拠点の見込みが立ってから</a:t>
             </a:r>
             <a:endParaRPr lang="en-US" sz="950" dirty="0"/>
           </a:p>
@@ -11734,7 +14917,7 @@
             <a:pPr algn="l"/>
             <a:fld id="{F7021451-1387-4CA6-816F-3879F97B5CBC}" type="slidenum">
               <a:rPr b="0" lang="en-US"/>
-              <a:t>12</a:t>
+              <a:t>13</a:t>
             </a:fld>
             <a:endParaRPr lang="en-US"/>
           </a:p>
@@ -11748,9 +14931,9 @@
 </p:sld>
 </file>
 
-<file path=ppt/slides/slide13.xml><?xml version="1.0" encoding="utf-8"?>
+<file path=ppt/slides/slide14.xml><?xml version="1.0" encoding="utf-8"?>
 <p:sld xmlns:a="http://schemas.openxmlformats.org/drawingml/2006/main" xmlns:r="http://schemas.openxmlformats.org/officeDocument/2006/relationships" xmlns:p="http://schemas.openxmlformats.org/presentationml/2006/main">
-  <p:cSld name="Slide 13">
+  <p:cSld name="Slide 14">
     <p:spTree>
       <p:nvGrpSpPr>
         <p:cNvPr id="1" name=""/>
@@ -11868,7 +15051,7 @@
       </p:sp>
       <p:graphicFrame>
         <p:nvGraphicFramePr>
-          <p:cNvPr id="14" name="seg-matrix"/>
+          <p:cNvPr id="15" name="seg-matrix"/>
           <p:cNvGraphicFramePr>
             <a:graphicFrameLocks noGrp="1"/>
           </p:cNvGraphicFramePr>
@@ -12708,7 +15891,7 @@
       </p:graphicFrame>
       <p:graphicFrame>
         <p:nvGraphicFramePr>
-          <p:cNvPr id="27" name="market-assump"/>
+          <p:cNvPr id="29" name="market-assump"/>
           <p:cNvGraphicFramePr>
             <a:graphicFrameLocks noGrp="1"/>
           </p:cNvGraphicFramePr>
@@ -14085,7 +17268,7 @@
             <a:pPr algn="l"/>
             <a:fld id="{F7021451-1387-4CA6-816F-3879F97B5CBC}" type="slidenum">
               <a:rPr b="0" lang="en-US"/>
-              <a:t>13</a:t>
+              <a:t>14</a:t>
             </a:fld>
             <a:endParaRPr lang="en-US"/>
           </a:p>
@@ -14099,9 +17282,9 @@
 </p:sld>
 </file>
 
-<file path=ppt/slides/slide14.xml><?xml version="1.0" encoding="utf-8"?>
+<file path=ppt/slides/slide15.xml><?xml version="1.0" encoding="utf-8"?>
 <p:sld xmlns:a="http://schemas.openxmlformats.org/drawingml/2006/main" xmlns:r="http://schemas.openxmlformats.org/officeDocument/2006/relationships" xmlns:p="http://schemas.openxmlformats.org/presentationml/2006/main">
-  <p:cSld name="Slide 14">
+  <p:cSld name="Slide 15">
     <p:spTree>
       <p:nvGrpSpPr>
         <p:cNvPr id="1" name=""/>
@@ -14219,7 +17402,7 @@
       </p:sp>
       <p:graphicFrame>
         <p:nvGraphicFramePr>
-          <p:cNvPr id="15" name="seg-eval"/>
+          <p:cNvPr id="16" name="seg-eval"/>
           <p:cNvGraphicFramePr>
             <a:graphicFrameLocks noGrp="1"/>
           </p:cNvGraphicFramePr>
@@ -16098,7 +19281,7 @@
       </p:sp>
       <p:graphicFrame>
         <p:nvGraphicFramePr>
-          <p:cNvPr id="29" name="funnel"/>
+          <p:cNvPr id="31" name="funnel"/>
           <p:cNvGraphicFramePr>
             <a:graphicFrameLocks noGrp="1"/>
           </p:cNvGraphicFramePr>
@@ -17718,7 +20901,7 @@
             <a:pPr algn="l"/>
             <a:fld id="{F7021451-1387-4CA6-816F-3879F97B5CBC}" type="slidenum">
               <a:rPr b="0" lang="en-US"/>
-              <a:t>14</a:t>
+              <a:t>15</a:t>
             </a:fld>
             <a:endParaRPr lang="en-US"/>
           </a:p>
@@ -17732,9 +20915,9 @@
 </p:sld>
 </file>
 
-<file path=ppt/slides/slide15.xml><?xml version="1.0" encoding="utf-8"?>
+<file path=ppt/slides/slide16.xml><?xml version="1.0" encoding="utf-8"?>
 <p:sld xmlns:a="http://schemas.openxmlformats.org/drawingml/2006/main" xmlns:r="http://schemas.openxmlformats.org/officeDocument/2006/relationships" xmlns:p="http://schemas.openxmlformats.org/presentationml/2006/main">
-  <p:cSld name="Slide 15">
+  <p:cSld name="Slide 16">
     <p:spTree>
       <p:nvGrpSpPr>
         <p:cNvPr id="1" name=""/>
@@ -17852,7 +21035,7 @@
       </p:sp>
       <p:graphicFrame>
         <p:nvGraphicFramePr>
-          <p:cNvPr id="16" name="device-spec"/>
+          <p:cNvPr id="17" name="device-spec"/>
           <p:cNvGraphicFramePr>
             <a:graphicFrameLocks noGrp="1"/>
           </p:cNvGraphicFramePr>
@@ -19425,7 +22608,7 @@
             <a:pPr algn="l"/>
             <a:fld id="{F7021451-1387-4CA6-816F-3879F97B5CBC}" type="slidenum">
               <a:rPr b="0" lang="en-US"/>
-              <a:t>15</a:t>
+              <a:t>16</a:t>
             </a:fld>
             <a:endParaRPr lang="en-US"/>
           </a:p>
@@ -19439,9 +22622,9 @@
 </p:sld>
 </file>
 
-<file path=ppt/slides/slide16.xml><?xml version="1.0" encoding="utf-8"?>
+<file path=ppt/slides/slide17.xml><?xml version="1.0" encoding="utf-8"?>
 <p:sld xmlns:a="http://schemas.openxmlformats.org/drawingml/2006/main" xmlns:r="http://schemas.openxmlformats.org/officeDocument/2006/relationships" xmlns:p="http://schemas.openxmlformats.org/presentationml/2006/main">
-  <p:cSld name="Slide 16">
+  <p:cSld name="Slide 17">
     <p:spTree>
       <p:nvGrpSpPr>
         <p:cNvPr id="1" name=""/>
@@ -19559,7 +22742,7 @@
       </p:sp>
       <p:graphicFrame>
         <p:nvGraphicFramePr>
-          <p:cNvPr id="17" name="qa"/>
+          <p:cNvPr id="18" name="qa"/>
           <p:cNvGraphicFramePr>
             <a:graphicFrameLocks noGrp="1"/>
           </p:cNvGraphicFramePr>
@@ -20412,7 +23595,7 @@
                           <a:ea typeface="Meiryo" pitchFamily="34" charset="-122"/>
                           <a:cs typeface="Meiryo" pitchFamily="34" charset="-120"/>
                         </a:rPr>
-                        <a:t>人を先に雇うからです。1人2.8拠点を超える4年目に黒字</a:t>
+                        <a:t>人を先に雇うからです。期末で1人3拠点を超える4年目に黒字</a:t>
                       </a:r>
                       <a:endParaRPr lang="en-US" sz="800" dirty="0">
                         <a:latin typeface="Meiryo" charset="0"/>
@@ -20564,7 +23747,7 @@
                           <a:ea typeface="Meiryo" pitchFamily="34" charset="-122"/>
                           <a:cs typeface="Meiryo" pitchFamily="34" charset="-120"/>
                         </a:rPr>
-                        <a:t>採用も遅らせます。3割遅れても現金は2,000万円を割りません</a:t>
+                        <a:t>採用も遅らせます。計画の6割で黒字。2年目に5拠点未満なら採用を止めます</a:t>
                       </a:r>
                       <a:endParaRPr lang="en-US" sz="800" dirty="0">
                         <a:latin typeface="Meiryo" charset="0"/>
@@ -20614,7 +23797,7 @@
                           <a:ea typeface="Meiryo" pitchFamily="34" charset="-122"/>
                           <a:cs typeface="Meiryo" pitchFamily="34" charset="-120"/>
                         </a:rPr>
-                        <a:t>根拠9</a:t>
+                        <a:t>根拠9-2</a:t>
                       </a:r>
                       <a:endParaRPr lang="en-US" sz="800" dirty="0">
                         <a:latin typeface="Meiryo" charset="0"/>
@@ -20716,7 +23899,7 @@
                           <a:ea typeface="Meiryo" pitchFamily="34" charset="-122"/>
                           <a:cs typeface="Meiryo" pitchFamily="34" charset="-120"/>
                         </a:rPr>
-                        <a:t>2割引きでも4年目に黒字。5年目の営業利益は3,200万円</a:t>
+                        <a:t>2割引きなら黒字化は5年目。現金は最低ラインを割りません</a:t>
                       </a:r>
                       <a:endParaRPr lang="en-US" sz="800" dirty="0">
                         <a:latin typeface="Meiryo" charset="0"/>
@@ -20868,7 +24051,7 @@
                           <a:ea typeface="Meiryo" pitchFamily="34" charset="-122"/>
                           <a:cs typeface="Meiryo" pitchFamily="34" charset="-120"/>
                         </a:rPr>
-                        <a:t>計画の解約率なら平均18年。3年でもCACの13倍です</a:t>
+                        <a:t>計画の解約率なら平均18年。3年でもCACの9倍です</a:t>
                       </a:r>
                       <a:endParaRPr lang="en-US" sz="800" dirty="0">
                         <a:latin typeface="Meiryo" charset="0"/>
@@ -21800,7 +24983,7 @@
             <a:pPr algn="l"/>
             <a:fld id="{F7021451-1387-4CA6-816F-3879F97B5CBC}" type="slidenum">
               <a:rPr b="0" lang="en-US"/>
-              <a:t>16</a:t>
+              <a:t>17</a:t>
             </a:fld>
             <a:endParaRPr lang="en-US"/>
           </a:p>
@@ -21814,9 +24997,9 @@
 </p:sld>
 </file>
 
-<file path=ppt/slides/slide17.xml><?xml version="1.0" encoding="utf-8"?>
+<file path=ppt/slides/slide18.xml><?xml version="1.0" encoding="utf-8"?>
 <p:sld xmlns:a="http://schemas.openxmlformats.org/drawingml/2006/main" xmlns:r="http://schemas.openxmlformats.org/officeDocument/2006/relationships" xmlns:p="http://schemas.openxmlformats.org/presentationml/2006/main">
-  <p:cSld name="Slide 17">
+  <p:cSld name="Slide 18">
     <p:spTree>
       <p:nvGrpSpPr>
         <p:cNvPr id="1" name=""/>
@@ -21917,7 +25100,7 @@
       </p:sp>
       <p:graphicFrame>
         <p:nvGraphicFramePr>
-          <p:cNvPr id="18" name="sources"/>
+          <p:cNvPr id="19" name="sources"/>
           <p:cNvGraphicFramePr>
             <a:graphicFrameLocks noGrp="1"/>
           </p:cNvGraphicFramePr>
@@ -23457,7 +26640,7 @@
             <a:pPr algn="l"/>
             <a:fld id="{F7021451-1387-4CA6-816F-3879F97B5CBC}" type="slidenum">
               <a:rPr b="0" lang="en-US"/>
-              <a:t>17</a:t>
+              <a:t>18</a:t>
             </a:fld>
             <a:endParaRPr lang="en-US"/>
           </a:p>
@@ -23541,7 +26724,7 @@
                 <a:ea typeface="Meiryo" pitchFamily="34" charset="-122"/>
                 <a:cs typeface="Meiryo" pitchFamily="34" charset="-120"/>
               </a:rPr>
-              <a:t>数字の木 ─ 5年目の営業利益6,900万円を分解する</a:t>
+              <a:t>数字の木 ─ 5年目の営業利益6,100万円を分解する</a:t>
             </a:r>
             <a:endParaRPr lang="en-US" sz="2000" dirty="0"/>
           </a:p>
@@ -23662,7 +26845,7 @@
                 <a:ea typeface="Meiryo" pitchFamily="34" charset="-122"/>
                 <a:cs typeface="Meiryo" pitchFamily="34" charset="-120"/>
               </a:rPr>
-              <a:t>69</a:t>
+              <a:t>61</a:t>
             </a:r>
             <a:endParaRPr lang="en-US" sz="1400" dirty="0"/>
           </a:p>
@@ -23783,7 +26966,7 @@
                 <a:ea typeface="Meiryo" pitchFamily="34" charset="-122"/>
                 <a:cs typeface="Meiryo" pitchFamily="34" charset="-120"/>
               </a:rPr>
-              <a:t>213</a:t>
+              <a:t>207</a:t>
             </a:r>
             <a:endParaRPr lang="en-US" sz="1400" dirty="0"/>
           </a:p>
@@ -23825,7 +27008,7 @@
                 <a:ea typeface="Meiryo" pitchFamily="34" charset="-122"/>
                 <a:cs typeface="Meiryo" pitchFamily="34" charset="-120"/>
               </a:rPr>
-              <a:t>利用料×85%＋サービス×40%</a:t>
+              <a:t>利用料×85%＋サービス×1/3</a:t>
             </a:r>
             <a:endParaRPr lang="en-US" sz="750" dirty="0"/>
           </a:p>
@@ -23904,7 +27087,7 @@
                 <a:ea typeface="Meiryo" pitchFamily="34" charset="-122"/>
                 <a:cs typeface="Meiryo" pitchFamily="34" charset="-120"/>
               </a:rPr>
-              <a:t>144</a:t>
+              <a:t>147</a:t>
             </a:r>
             <a:endParaRPr lang="en-US" sz="1400" dirty="0"/>
           </a:p>
@@ -24146,7 +27329,7 @@
                 <a:ea typeface="Meiryo" pitchFamily="34" charset="-122"/>
                 <a:cs typeface="Meiryo" pitchFamily="34" charset="-120"/>
               </a:rPr>
-              <a:t>30</a:t>
+              <a:t>25</a:t>
             </a:r>
             <a:endParaRPr lang="en-US" sz="1400" dirty="0"/>
           </a:p>
@@ -24188,7 +27371,7 @@
                 <a:ea typeface="Meiryo" pitchFamily="34" charset="-122"/>
                 <a:cs typeface="Meiryo" pitchFamily="34" charset="-120"/>
               </a:rPr>
-              <a:t>導入支援66＋受託9.5 × 40%</a:t>
+              <a:t>導入支援66＋受託9.5 × 1/3</a:t>
             </a:r>
             <a:endParaRPr lang="en-US" sz="750" dirty="0"/>
           </a:p>
@@ -24267,7 +27450,7 @@
                 <a:ea typeface="Meiryo" pitchFamily="34" charset="-122"/>
                 <a:cs typeface="Meiryo" pitchFamily="34" charset="-120"/>
               </a:rPr>
-              <a:t>160</a:t>
+              <a:t>168</a:t>
             </a:r>
             <a:endParaRPr lang="en-US" sz="1400" dirty="0"/>
           </a:p>
@@ -24309,7 +27492,7 @@
                 <a:ea typeface="Meiryo" pitchFamily="34" charset="-122"/>
                 <a:cs typeface="Meiryo" pitchFamily="34" charset="-120"/>
               </a:rPr>
-              <a:t>社員20人 × 800万円</a:t>
+              <a:t>社員21人 × 800万円</a:t>
             </a:r>
             <a:endParaRPr lang="en-US" sz="750" dirty="0"/>
           </a:p>
@@ -24388,7 +27571,7 @@
                 <a:ea typeface="Meiryo" pitchFamily="34" charset="-122"/>
                 <a:cs typeface="Meiryo" pitchFamily="34" charset="-120"/>
               </a:rPr>
-              <a:t>−45 / +29</a:t>
+              <a:t>−50 / +29</a:t>
             </a:r>
             <a:endParaRPr lang="en-US" sz="1400" dirty="0"/>
           </a:p>
@@ -24430,7 +27613,7 @@
                 <a:ea typeface="Meiryo" pitchFamily="34" charset="-122"/>
                 <a:cs typeface="Meiryo" pitchFamily="34" charset="-120"/>
               </a:rPr>
-              <a:t>サービス×60% ／ 家賃・広告など</a:t>
+              <a:t>サービス×2/3 ／ 家賃・広告など</a:t>
             </a:r>
             <a:endParaRPr lang="en-US" sz="750" dirty="0"/>
           </a:p>
@@ -26123,7 +29306,7 @@
                           <a:ea typeface="Meiryo" pitchFamily="34" charset="-122"/>
                           <a:cs typeface="Meiryo" pitchFamily="34" charset="-120"/>
                         </a:rPr>
-                        <a:t>担当者1人が約2か月現場に入る。原価120万円</a:t>
+                        <a:t>担当者1人が約2か月現場に入る。原価133万円（800万円×2/12）</a:t>
                       </a:r>
                       <a:endParaRPr lang="en-US" sz="850" dirty="0">
                         <a:latin typeface="Meiryo" charset="0"/>
@@ -26325,7 +29508,7 @@
                           <a:ea typeface="Meiryo" pitchFamily="34" charset="-122"/>
                           <a:cs typeface="Meiryo" pitchFamily="34" charset="-120"/>
                         </a:rPr>
-                        <a:t>クラウド・AI推論・保守。実証で実測する</a:t>
+                        <a:t>クラウド・AI推論・保守。端末で大事な場面だけ送る前提。実測する</a:t>
                       </a:r>
                       <a:endParaRPr lang="en-US" sz="850" dirty="0">
                         <a:latin typeface="Meiryo" charset="0"/>
@@ -26375,7 +29558,7 @@
                           <a:ea typeface="Meiryo" pitchFamily="34" charset="-122"/>
                           <a:cs typeface="Meiryo" pitchFamily="34" charset="-120"/>
                         </a:rPr>
-                        <a:t>B</a:t>
+                        <a:t>C</a:t>
                       </a:r>
                       <a:endParaRPr lang="en-US" sz="850" dirty="0">
                         <a:latin typeface="Meiryo" charset="0"/>
@@ -26477,7 +29660,7 @@
                           <a:ea typeface="Meiryo" pitchFamily="34" charset="-122"/>
                           <a:cs typeface="Meiryo" pitchFamily="34" charset="-120"/>
                         </a:rPr>
-                        <a:t>60%</a:t>
+                        <a:t>2/3</a:t>
                       </a:r>
                       <a:endParaRPr lang="en-US" sz="850" dirty="0">
                         <a:latin typeface="Meiryo" charset="0"/>
@@ -26527,7 +29710,7 @@
                           <a:ea typeface="Meiryo" pitchFamily="34" charset="-122"/>
                           <a:cs typeface="Meiryo" pitchFamily="34" charset="-120"/>
                         </a:rPr>
-                        <a:t>担当者の人件費（1人年800万円の2か月分＋交通費）</a:t>
+                        <a:t>担当者の人件費（1人年800万円の2か月分）。交通費は販管費</a:t>
                       </a:r>
                       <a:endParaRPr lang="en-US" sz="850" dirty="0">
                         <a:latin typeface="Meiryo" charset="0"/>
@@ -27285,7 +30468,7 @@
                           <a:ea typeface="Meiryo" pitchFamily="34" charset="-122"/>
                           <a:cs typeface="Meiryo" pitchFamily="34" charset="-120"/>
                         </a:rPr>
-                        <a:t>4→7→11→15→20人</a:t>
+                        <a:t>4→7→11→16→21人</a:t>
                       </a:r>
                       <a:endParaRPr lang="en-US" sz="850" dirty="0">
                         <a:latin typeface="Meiryo" charset="0"/>
@@ -27335,7 +30518,7 @@
                           <a:ea typeface="Meiryo" pitchFamily="34" charset="-122"/>
                           <a:cs typeface="Meiryo" pitchFamily="34" charset="-120"/>
                         </a:rPr>
-                        <a:t>社員1人2.8拠点を超える前提で採用する（根拠7）</a:t>
+                        <a:t>営業は4年目から3人。期末1人3拠点の見込みで採用（根拠7）</a:t>
                       </a:r>
                       <a:endParaRPr lang="en-US" sz="850" dirty="0">
                         <a:latin typeface="Meiryo" charset="0"/>
@@ -28065,7 +31248,7 @@
                 <a:ea typeface="Meiryo" pitchFamily="34" charset="-122"/>
                 <a:cs typeface="Meiryo" pitchFamily="34" charset="-120"/>
               </a:rPr>
-              <a:t>※ 月6.5時間の出典は発表前に原典を確認する。Cの2つ（削減時間・解約）を、500万円の実証で実測する</a:t>
+              <a:t>※ 月6.5時間の出典は発表前に原典を確認する。Cの3つ（削減時間・解約・利用料の原価）を、500万円の実証で実測する</a:t>
             </a:r>
             <a:endParaRPr lang="en-US" sz="800" dirty="0"/>
           </a:p>
@@ -38870,7 +42053,7 @@
                           <a:ea typeface="Meiryo" pitchFamily="34" charset="-122"/>
                           <a:cs typeface="Meiryo" pitchFamily="34" charset="-120"/>
                         </a:rPr>
-                        <a:t>− サービスの原価（支援・受託×60%）</a:t>
+                        <a:t>− サービスの原価（支援・受託×2/3）</a:t>
                       </a:r>
                       <a:endParaRPr lang="en-US" sz="900" dirty="0">
                         <a:latin typeface="Meiryo" charset="0"/>
@@ -38920,7 +42103,7 @@
                           <a:ea typeface="Meiryo" pitchFamily="34" charset="-122"/>
                           <a:cs typeface="Meiryo" pitchFamily="34" charset="-120"/>
                         </a:rPr>
-                        <a:t>720</a:t>
+                        <a:t>800</a:t>
                       </a:r>
                       <a:endParaRPr lang="en-US" sz="900" dirty="0">
                         <a:latin typeface="Meiryo" charset="0"/>
@@ -38970,7 +42153,7 @@
                           <a:ea typeface="Meiryo" pitchFamily="34" charset="-122"/>
                           <a:cs typeface="Meiryo" pitchFamily="34" charset="-120"/>
                         </a:rPr>
-                        <a:t>1,530</a:t>
+                        <a:t>1,700</a:t>
                       </a:r>
                       <a:endParaRPr lang="en-US" sz="900" dirty="0">
                         <a:latin typeface="Meiryo" charset="0"/>
@@ -39020,7 +42203,7 @@
                           <a:ea typeface="Meiryo" pitchFamily="34" charset="-122"/>
                           <a:cs typeface="Meiryo" pitchFamily="34" charset="-120"/>
                         </a:rPr>
-                        <a:t>2,820</a:t>
+                        <a:t>3,133</a:t>
                       </a:r>
                       <a:endParaRPr lang="en-US" sz="900" dirty="0">
                         <a:latin typeface="Meiryo" charset="0"/>
@@ -39070,7 +42253,7 @@
                           <a:ea typeface="Meiryo" pitchFamily="34" charset="-122"/>
                           <a:cs typeface="Meiryo" pitchFamily="34" charset="-120"/>
                         </a:rPr>
-                        <a:t>3,570</a:t>
+                        <a:t>3,967</a:t>
                       </a:r>
                       <a:endParaRPr lang="en-US" sz="900" dirty="0">
                         <a:latin typeface="Meiryo" charset="0"/>
@@ -39120,7 +42303,7 @@
                           <a:ea typeface="Meiryo" pitchFamily="34" charset="-122"/>
                           <a:cs typeface="Meiryo" pitchFamily="34" charset="-120"/>
                         </a:rPr>
-                        <a:t>4,530</a:t>
+                        <a:t>5,033</a:t>
                       </a:r>
                       <a:endParaRPr lang="en-US" sz="900" dirty="0">
                         <a:latin typeface="Meiryo" charset="0"/>
@@ -39228,7 +42411,7 @@
                           <a:ea typeface="Meiryo" pitchFamily="34" charset="-122"/>
                           <a:cs typeface="Meiryo" pitchFamily="34" charset="-120"/>
                         </a:rPr>
-                        <a:t>480</a:t>
+                        <a:t>400</a:t>
                       </a:r>
                       <a:endParaRPr lang="en-US" sz="900" dirty="0">
                         <a:latin typeface="Meiryo" charset="0"/>
@@ -39284,7 +42467,7 @@
                           <a:ea typeface="Meiryo" pitchFamily="34" charset="-122"/>
                           <a:cs typeface="Meiryo" pitchFamily="34" charset="-120"/>
                         </a:rPr>
-                        <a:t>2,933</a:t>
+                        <a:t>2,763</a:t>
                       </a:r>
                       <a:endParaRPr lang="en-US" sz="900" dirty="0">
                         <a:latin typeface="Meiryo" charset="0"/>
@@ -39340,7 +42523,7 @@
                           <a:ea typeface="Meiryo" pitchFamily="34" charset="-122"/>
                           <a:cs typeface="Meiryo" pitchFamily="34" charset="-120"/>
                         </a:rPr>
-                        <a:t>7,235</a:t>
+                        <a:t>6,922</a:t>
                       </a:r>
                       <a:endParaRPr lang="en-US" sz="900" dirty="0">
                         <a:latin typeface="Meiryo" charset="0"/>
@@ -39396,7 +42579,7 @@
                           <a:ea typeface="Meiryo" pitchFamily="34" charset="-122"/>
                           <a:cs typeface="Meiryo" pitchFamily="34" charset="-120"/>
                         </a:rPr>
-                        <a:t>13,473</a:t>
+                        <a:t>13,076</a:t>
                       </a:r>
                       <a:endParaRPr lang="en-US" sz="900" dirty="0">
                         <a:latin typeface="Meiryo" charset="0"/>
@@ -39452,7 +42635,7 @@
                           <a:ea typeface="Meiryo" pitchFamily="34" charset="-122"/>
                           <a:cs typeface="Meiryo" pitchFamily="34" charset="-120"/>
                         </a:rPr>
-                        <a:t>21,253</a:t>
+                        <a:t>20,749</a:t>
                       </a:r>
                       <a:endParaRPr lang="en-US" sz="900" dirty="0">
                         <a:latin typeface="Meiryo" charset="0"/>
@@ -39560,7 +42743,7 @@
                           <a:ea typeface="Meiryo" pitchFamily="34" charset="-122"/>
                           <a:cs typeface="Meiryo" pitchFamily="34" charset="-120"/>
                         </a:rPr>
-                        <a:t>40%</a:t>
+                        <a:t>33%</a:t>
                       </a:r>
                       <a:endParaRPr lang="en-US" sz="900" dirty="0">
                         <a:latin typeface="Meiryo" charset="0"/>
@@ -39610,7 +42793,7 @@
                           <a:ea typeface="Meiryo" pitchFamily="34" charset="-122"/>
                           <a:cs typeface="Meiryo" pitchFamily="34" charset="-120"/>
                         </a:rPr>
-                        <a:t>61%</a:t>
+                        <a:t>58%</a:t>
                       </a:r>
                       <a:endParaRPr lang="en-US" sz="900" dirty="0">
                         <a:latin typeface="Meiryo" charset="0"/>
@@ -39660,7 +42843,7 @@
                           <a:ea typeface="Meiryo" pitchFamily="34" charset="-122"/>
                           <a:cs typeface="Meiryo" pitchFamily="34" charset="-120"/>
                         </a:rPr>
-                        <a:t>66%</a:t>
+                        <a:t>63%</a:t>
                       </a:r>
                       <a:endParaRPr lang="en-US" sz="900" dirty="0">
                         <a:latin typeface="Meiryo" charset="0"/>
@@ -39710,7 +42893,7 @@
                           <a:ea typeface="Meiryo" pitchFamily="34" charset="-122"/>
                           <a:cs typeface="Meiryo" pitchFamily="34" charset="-120"/>
                         </a:rPr>
-                        <a:t>71%</a:t>
+                        <a:t>69%</a:t>
                       </a:r>
                       <a:endParaRPr lang="en-US" sz="900" dirty="0">
                         <a:latin typeface="Meiryo" charset="0"/>
@@ -39760,7 +42943,7 @@
                           <a:ea typeface="Meiryo" pitchFamily="34" charset="-122"/>
                           <a:cs typeface="Meiryo" pitchFamily="34" charset="-120"/>
                         </a:rPr>
-                        <a:t>73%</a:t>
+                        <a:t>72%</a:t>
                       </a:r>
                       <a:endParaRPr lang="en-US" sz="900" dirty="0">
                         <a:latin typeface="Meiryo" charset="0"/>
@@ -40012,7 +43195,7 @@
                           <a:ea typeface="Meiryo" pitchFamily="34" charset="-122"/>
                           <a:cs typeface="Meiryo" pitchFamily="34" charset="-120"/>
                         </a:rPr>
-                        <a:t>12,000（15人）</a:t>
+                        <a:t>12,800（16人）</a:t>
                       </a:r>
                       <a:endParaRPr lang="en-US" sz="900" dirty="0">
                         <a:latin typeface="Meiryo" charset="0"/>
@@ -40062,7 +43245,7 @@
                           <a:ea typeface="Meiryo" pitchFamily="34" charset="-122"/>
                           <a:cs typeface="Meiryo" pitchFamily="34" charset="-120"/>
                         </a:rPr>
-                        <a:t>16,000（20人）</a:t>
+                        <a:t>16,800（21人）</a:t>
                       </a:r>
                       <a:endParaRPr lang="en-US" sz="900" dirty="0">
                         <a:latin typeface="Meiryo" charset="0"/>
@@ -40164,7 +43347,7 @@
                           <a:ea typeface="Meiryo" pitchFamily="34" charset="-122"/>
                           <a:cs typeface="Meiryo" pitchFamily="34" charset="-120"/>
                         </a:rPr>
-                        <a:t>720</a:t>
+                        <a:t>800</a:t>
                       </a:r>
                       <a:endParaRPr lang="en-US" sz="900" dirty="0">
                         <a:latin typeface="Meiryo" charset="0"/>
@@ -40214,7 +43397,7 @@
                           <a:ea typeface="Meiryo" pitchFamily="34" charset="-122"/>
                           <a:cs typeface="Meiryo" pitchFamily="34" charset="-120"/>
                         </a:rPr>
-                        <a:t>1,530</a:t>
+                        <a:t>1,700</a:t>
                       </a:r>
                       <a:endParaRPr lang="en-US" sz="900" dirty="0">
                         <a:latin typeface="Meiryo" charset="0"/>
@@ -40264,7 +43447,7 @@
                           <a:ea typeface="Meiryo" pitchFamily="34" charset="-122"/>
                           <a:cs typeface="Meiryo" pitchFamily="34" charset="-120"/>
                         </a:rPr>
-                        <a:t>2,820</a:t>
+                        <a:t>3,133</a:t>
                       </a:r>
                       <a:endParaRPr lang="en-US" sz="900" dirty="0">
                         <a:latin typeface="Meiryo" charset="0"/>
@@ -40314,7 +43497,7 @@
                           <a:ea typeface="Meiryo" pitchFamily="34" charset="-122"/>
                           <a:cs typeface="Meiryo" pitchFamily="34" charset="-120"/>
                         </a:rPr>
-                        <a:t>3,570</a:t>
+                        <a:t>3,967</a:t>
                       </a:r>
                       <a:endParaRPr lang="en-US" sz="900" dirty="0">
                         <a:latin typeface="Meiryo" charset="0"/>
@@ -40364,7 +43547,7 @@
                           <a:ea typeface="Meiryo" pitchFamily="34" charset="-122"/>
                           <a:cs typeface="Meiryo" pitchFamily="34" charset="-120"/>
                         </a:rPr>
-                        <a:t>4,530</a:t>
+                        <a:t>5,033</a:t>
                       </a:r>
                       <a:endParaRPr lang="en-US" sz="900" dirty="0">
                         <a:latin typeface="Meiryo" charset="0"/>
@@ -40774,7 +43957,7 @@
                           <a:ea typeface="Meiryo" pitchFamily="34" charset="-122"/>
                           <a:cs typeface="Meiryo" pitchFamily="34" charset="-120"/>
                         </a:rPr>
-                        <a:t>3,680</a:t>
+                        <a:t>3,600</a:t>
                       </a:r>
                       <a:endParaRPr lang="en-US" sz="900" dirty="0">
                         <a:latin typeface="Meiryo" charset="0"/>
@@ -40830,7 +44013,7 @@
                           <a:ea typeface="Meiryo" pitchFamily="34" charset="-122"/>
                           <a:cs typeface="Meiryo" pitchFamily="34" charset="-120"/>
                         </a:rPr>
-                        <a:t>5,600</a:t>
+                        <a:t>5,430</a:t>
                       </a:r>
                       <a:endParaRPr lang="en-US" sz="900" dirty="0">
                         <a:latin typeface="Meiryo" charset="0"/>
@@ -40886,7 +44069,7 @@
                           <a:ea typeface="Meiryo" pitchFamily="34" charset="-122"/>
                           <a:cs typeface="Meiryo" pitchFamily="34" charset="-120"/>
                         </a:rPr>
-                        <a:t>7,880</a:t>
+                        <a:t>7,567</a:t>
                       </a:r>
                       <a:endParaRPr lang="en-US" sz="900" dirty="0">
                         <a:latin typeface="Meiryo" charset="0"/>
@@ -40942,7 +44125,7 @@
                           <a:ea typeface="Meiryo" pitchFamily="34" charset="-122"/>
                           <a:cs typeface="Meiryo" pitchFamily="34" charset="-120"/>
                         </a:rPr>
-                        <a:t>10,700</a:t>
+                        <a:t>11,103</a:t>
                       </a:r>
                       <a:endParaRPr lang="en-US" sz="900" dirty="0">
                         <a:latin typeface="Meiryo" charset="0"/>
@@ -40998,7 +44181,7 @@
                           <a:ea typeface="Meiryo" pitchFamily="34" charset="-122"/>
                           <a:cs typeface="Meiryo" pitchFamily="34" charset="-120"/>
                         </a:rPr>
-                        <a:t>14,370</a:t>
+                        <a:t>14,667</a:t>
                       </a:r>
                       <a:endParaRPr lang="en-US" sz="900" dirty="0">
                         <a:latin typeface="Meiryo" charset="0"/>
@@ -41280,7 +44463,7 @@
                           <a:ea typeface="Meiryo" pitchFamily="34" charset="-122"/>
                           <a:cs typeface="Meiryo" pitchFamily="34" charset="-120"/>
                         </a:rPr>
-                        <a:t>2,773</a:t>
+                        <a:t>1,973</a:t>
                       </a:r>
                       <a:endParaRPr lang="en-US" sz="900" dirty="0">
                         <a:latin typeface="Meiryo" charset="0"/>
@@ -41336,7 +44519,7 @@
                           <a:ea typeface="Meiryo" pitchFamily="34" charset="-122"/>
                           <a:cs typeface="Meiryo" pitchFamily="34" charset="-120"/>
                         </a:rPr>
-                        <a:t>6,883</a:t>
+                        <a:t>6,082</a:t>
                       </a:r>
                       <a:endParaRPr lang="en-US" sz="900" dirty="0">
                         <a:latin typeface="Meiryo" charset="0"/>
@@ -41594,7 +44777,7 @@
                           <a:ea typeface="Meiryo" pitchFamily="34" charset="-122"/>
                           <a:cs typeface="Meiryo" pitchFamily="34" charset="-120"/>
                         </a:rPr>
-                        <a:t>▲3,740</a:t>
+                        <a:t>▲4,540</a:t>
                       </a:r>
                       <a:endParaRPr lang="en-US" sz="900" dirty="0">
                         <a:latin typeface="Meiryo" charset="0"/>
@@ -41644,7 +44827,7 @@
                           <a:ea typeface="Meiryo" pitchFamily="34" charset="-122"/>
                           <a:cs typeface="Meiryo" pitchFamily="34" charset="-120"/>
                         </a:rPr>
-                        <a:t>3,143</a:t>
+                        <a:t>1,542</a:t>
                       </a:r>
                       <a:endParaRPr lang="en-US" sz="900" dirty="0">
                         <a:latin typeface="Meiryo" charset="0"/>
@@ -41718,7 +44901,7 @@
                 <a:ea typeface="Meiryo" pitchFamily="34" charset="-122"/>
                 <a:cs typeface="Meiryo" pitchFamily="34" charset="-120"/>
               </a:rPr>
-              <a:t>発表資料の表は百万円単位で四捨五入（例：5年目 粗利21,253万円→213、販管費14,370万円→144、営業利益6,883万円→69）</a:t>
+              <a:t>発表資料の表は百万円単位で四捨五入（例：5年目 粗利20,749万円→207、販管費14,667万円→147、営業利益6,082万円→61）</a:t>
             </a:r>
             <a:endParaRPr lang="en-US" sz="800" dirty="0"/>
           </a:p>
@@ -42340,7 +45523,7 @@
                           <a:ea typeface="Meiryo" pitchFamily="34" charset="-122"/>
                           <a:cs typeface="Meiryo" pitchFamily="34" charset="-120"/>
                         </a:rPr>
-                        <a:t>37</a:t>
+                        <a:t>36</a:t>
                       </a:r>
                       <a:endParaRPr lang="en-US" sz="900" dirty="0">
                         <a:latin typeface="Meiryo" charset="0"/>
@@ -42390,7 +45573,7 @@
                           <a:ea typeface="Meiryo" pitchFamily="34" charset="-122"/>
                           <a:cs typeface="Meiryo" pitchFamily="34" charset="-120"/>
                         </a:rPr>
-                        <a:t>56</a:t>
+                        <a:t>54</a:t>
                       </a:r>
                       <a:endParaRPr lang="en-US" sz="900" dirty="0">
                         <a:latin typeface="Meiryo" charset="0"/>
@@ -42440,7 +45623,7 @@
                           <a:ea typeface="Meiryo" pitchFamily="34" charset="-122"/>
                           <a:cs typeface="Meiryo" pitchFamily="34" charset="-120"/>
                         </a:rPr>
-                        <a:t>79</a:t>
+                        <a:t>76</a:t>
                       </a:r>
                       <a:endParaRPr lang="en-US" sz="900" dirty="0">
                         <a:latin typeface="Meiryo" charset="0"/>
@@ -42490,7 +45673,7 @@
                           <a:ea typeface="Meiryo" pitchFamily="34" charset="-122"/>
                           <a:cs typeface="Meiryo" pitchFamily="34" charset="-120"/>
                         </a:rPr>
-                        <a:t>107</a:t>
+                        <a:t>111</a:t>
                       </a:r>
                       <a:endParaRPr lang="en-US" sz="900" dirty="0">
                         <a:latin typeface="Meiryo" charset="0"/>
@@ -42540,7 +45723,7 @@
                           <a:ea typeface="Meiryo" pitchFamily="34" charset="-122"/>
                           <a:cs typeface="Meiryo" pitchFamily="34" charset="-120"/>
                         </a:rPr>
-                        <a:t>144</a:t>
+                        <a:t>147</a:t>
                       </a:r>
                       <a:endParaRPr lang="en-US" sz="900" dirty="0">
                         <a:latin typeface="Meiryo" charset="0"/>
@@ -42642,7 +45825,7 @@
                           <a:ea typeface="Meiryo" pitchFamily="34" charset="-122"/>
                           <a:cs typeface="Meiryo" pitchFamily="34" charset="-120"/>
                         </a:rPr>
-                        <a:t>40%</a:t>
+                        <a:t>33%</a:t>
                       </a:r>
                       <a:endParaRPr lang="en-US" sz="900" dirty="0">
                         <a:latin typeface="Meiryo" charset="0"/>
@@ -42692,7 +45875,7 @@
                           <a:ea typeface="Meiryo" pitchFamily="34" charset="-122"/>
                           <a:cs typeface="Meiryo" pitchFamily="34" charset="-120"/>
                         </a:rPr>
-                        <a:t>61%</a:t>
+                        <a:t>58%</a:t>
                       </a:r>
                       <a:endParaRPr lang="en-US" sz="900" dirty="0">
                         <a:latin typeface="Meiryo" charset="0"/>
@@ -42742,7 +45925,7 @@
                           <a:ea typeface="Meiryo" pitchFamily="34" charset="-122"/>
                           <a:cs typeface="Meiryo" pitchFamily="34" charset="-120"/>
                         </a:rPr>
-                        <a:t>66%</a:t>
+                        <a:t>63%</a:t>
                       </a:r>
                       <a:endParaRPr lang="en-US" sz="900" dirty="0">
                         <a:latin typeface="Meiryo" charset="0"/>
@@ -42792,7 +45975,7 @@
                           <a:ea typeface="Meiryo" pitchFamily="34" charset="-122"/>
                           <a:cs typeface="Meiryo" pitchFamily="34" charset="-120"/>
                         </a:rPr>
-                        <a:t>71%</a:t>
+                        <a:t>69%</a:t>
                       </a:r>
                       <a:endParaRPr lang="en-US" sz="900" dirty="0">
                         <a:latin typeface="Meiryo" charset="0"/>
@@ -42842,7 +46025,7 @@
                           <a:ea typeface="Meiryo" pitchFamily="34" charset="-122"/>
                           <a:cs typeface="Meiryo" pitchFamily="34" charset="-120"/>
                         </a:rPr>
-                        <a:t>73%</a:t>
+                        <a:t>72%</a:t>
                       </a:r>
                       <a:endParaRPr lang="en-US" sz="900" dirty="0">
                         <a:latin typeface="Meiryo" charset="0"/>
@@ -42950,7 +46133,7 @@
                           <a:ea typeface="Meiryo" pitchFamily="34" charset="-122"/>
                           <a:cs typeface="Meiryo" pitchFamily="34" charset="-120"/>
                         </a:rPr>
-                        <a:t>92</a:t>
+                        <a:t>108</a:t>
                       </a:r>
                       <a:endParaRPr lang="en-US" sz="900" dirty="0">
                         <a:latin typeface="Meiryo" charset="0"/>
@@ -43006,7 +46189,7 @@
                           <a:ea typeface="Meiryo" pitchFamily="34" charset="-122"/>
                           <a:cs typeface="Meiryo" pitchFamily="34" charset="-120"/>
                         </a:rPr>
-                        <a:t>92</a:t>
+                        <a:t>94</a:t>
                       </a:r>
                       <a:endParaRPr lang="en-US" sz="900" dirty="0">
                         <a:latin typeface="Meiryo" charset="0"/>
@@ -43118,7 +46301,7 @@
                           <a:ea typeface="Meiryo" pitchFamily="34" charset="-122"/>
                           <a:cs typeface="Meiryo" pitchFamily="34" charset="-120"/>
                         </a:rPr>
-                        <a:t>151</a:t>
+                        <a:t>161</a:t>
                       </a:r>
                       <a:endParaRPr lang="en-US" sz="900" dirty="0">
                         <a:latin typeface="Meiryo" charset="0"/>
@@ -43174,7 +46357,7 @@
                           <a:ea typeface="Meiryo" pitchFamily="34" charset="-122"/>
                           <a:cs typeface="Meiryo" pitchFamily="34" charset="-120"/>
                         </a:rPr>
-                        <a:t>196</a:t>
+                        <a:t>205</a:t>
                       </a:r>
                       <a:endParaRPr lang="en-US" sz="900" dirty="0">
                         <a:latin typeface="Meiryo" charset="0"/>
@@ -43734,7 +46917,7 @@
                           <a:ea typeface="Meiryo" pitchFamily="34" charset="-122"/>
                           <a:cs typeface="Meiryo" pitchFamily="34" charset="-120"/>
                         </a:rPr>
-                        <a:t>21%</a:t>
+                        <a:t>15%</a:t>
                       </a:r>
                       <a:endParaRPr lang="en-US" sz="900" dirty="0">
                         <a:latin typeface="Meiryo" charset="0"/>
@@ -43784,7 +46967,7 @@
                           <a:ea typeface="Meiryo" pitchFamily="34" charset="-122"/>
                           <a:cs typeface="Meiryo" pitchFamily="34" charset="-120"/>
                         </a:rPr>
-                        <a:t>32%</a:t>
+                        <a:t>29%</a:t>
                       </a:r>
                       <a:endParaRPr lang="en-US" sz="900" dirty="0">
                         <a:latin typeface="Meiryo" charset="0"/>
@@ -43920,7 +47103,7 @@
                 <a:ea typeface="Meiryo" pitchFamily="34" charset="-122"/>
                 <a:cs typeface="Meiryo" pitchFamily="34" charset="-120"/>
               </a:rPr>
-              <a:t>社員1人の販管費 713万円（4年目：1億700万円÷15人）</a:t>
+              <a:t>社員1人の販管費 694万円（4年目：11,103万円÷16人）</a:t>
             </a:r>
             <a:endParaRPr lang="en-US" sz="950" dirty="0"/>
           </a:p>
@@ -43940,7 +47123,7 @@
                 <a:ea typeface="Meiryo" pitchFamily="34" charset="-122"/>
                 <a:cs typeface="Meiryo" pitchFamily="34" charset="-120"/>
               </a:rPr>
-              <a:t>÷ 1拠点の粗利 255万円（300万円×85%）</a:t>
+              <a:t>÷ 1拠点の粗利 255万円 ＝ 2.7拠点／人</a:t>
             </a:r>
             <a:endParaRPr lang="en-US" sz="950" dirty="0"/>
           </a:p>
@@ -43952,7 +47135,7 @@
               <a:buNone/>
             </a:pPr>
             <a:r>
-              <a:rPr lang="en-US" sz="1400" b="1" dirty="0">
+              <a:rPr lang="en-US" sz="1300" b="1" dirty="0">
                 <a:solidFill>
                   <a:srgbClr val="E3A774"/>
                 </a:solidFill>
@@ -43960,7 +47143,7 @@
                 <a:ea typeface="Meiryo" pitchFamily="34" charset="-122"/>
                 <a:cs typeface="Meiryo" pitchFamily="34" charset="-120"/>
               </a:rPr>
-              <a:t>＝ 2.8拠点／人</a:t>
+              <a:t>新規は初年度半額 → 期末で1人3拠点</a:t>
             </a:r>
             <a:endParaRPr lang="en-US" sz="950" dirty="0"/>
           </a:p>
@@ -44505,7 +47688,7 @@
                           <a:ea typeface="Meiryo" pitchFamily="34" charset="-122"/>
                           <a:cs typeface="Meiryo" pitchFamily="34" charset="-120"/>
                         </a:rPr>
-                        <a:t>3.67</a:t>
+                        <a:t>3.44</a:t>
                       </a:r>
                       <a:endParaRPr lang="en-US" sz="900" dirty="0">
                         <a:latin typeface="Meiryo" charset="0"/>
@@ -44555,7 +47738,7 @@
                           <a:ea typeface="Meiryo" pitchFamily="34" charset="-122"/>
                           <a:cs typeface="Meiryo" pitchFamily="34" charset="-120"/>
                         </a:rPr>
-                        <a:t>4.25</a:t>
+                        <a:t>4.05</a:t>
                       </a:r>
                       <a:endParaRPr lang="en-US" sz="900" dirty="0">
                         <a:latin typeface="Meiryo" charset="0"/>
@@ -44715,7 +47898,7 @@
                 <a:ea typeface="Meiryo" pitchFamily="34" charset="-122"/>
                 <a:cs typeface="Meiryo" pitchFamily="34" charset="-120"/>
               </a:rPr>
-              <a:t>「3年目は社員11人で30拠点、1人2.73で2.8に届かず赤字。4年目は15人で55拠点、3.67で黒字です」</a:t>
+              <a:t>「3年目は社員11人で30拠点、1人2.73で3に届かず赤字。4年目は16人で55拠点、3.44で黒字です」</a:t>
             </a:r>
             <a:endParaRPr lang="en-US" sz="950" dirty="0"/>
           </a:p>
@@ -44758,7 +47941,7 @@
                 <a:ea typeface="Meiryo" pitchFamily="34" charset="-122"/>
                 <a:cs typeface="Meiryo" pitchFamily="34" charset="-120"/>
               </a:rPr>
-              <a:t>採用は「1人2.8拠点を超える見込み」が立ってから。これが根拠9の資金の守りになる</a:t>
+              <a:t>採用は「期末で1人3拠点を超える見込み」が立ってから。これが根拠9の資金の守りになる</a:t>
             </a:r>
             <a:endParaRPr lang="en-US" sz="950" dirty="0"/>
           </a:p>
@@ -44800,7 +47983,7 @@
                 <a:ea typeface="Meiryo" pitchFamily="34" charset="-122"/>
                 <a:cs typeface="Meiryo" pitchFamily="34" charset="-120"/>
               </a:rPr>
-              <a:t>713万円は4年目の値（1年目920万円、5年目719万円）。年によって多少動くため、目安として2.8を使う</a:t>
+              <a:t>694万円は4年目の値（1年目900万円、5年目698万円）。新規拠点は初年度に利用料が半年分なので、期末の拠点数では3を目安にする</a:t>
             </a:r>
             <a:endParaRPr lang="en-US" sz="800" dirty="0"/>
           </a:p>

</xml_diff>